<commit_message>
fix(plano-b): corrige rodape (sliver) e overlap da formula Wellness; add PDF
</commit_message>
<xml_diff>
--- a/plano_b_pso_diabetes/Apresentacao_Equipe4_PlanoB_CIRG.pptx
+++ b/plano_b_pso_diabetes/Apresentacao_Equipe4_PlanoB_CIRG.pptx
@@ -3230,8 +3230,8 @@
         </p:blipFill>
         <p:spPr>
           <a:xfrm>
-            <a:off x="292608" y="6309360"/>
-            <a:ext cx="1188720" cy="543560"/>
+            <a:off x="292608" y="6291072"/>
+            <a:ext cx="1065929" cy="548640"/>
           </a:xfrm>
           <a:prstGeom prst="rect">
             <a:avLst/>
@@ -3731,8 +3731,8 @@
         </p:blipFill>
         <p:spPr>
           <a:xfrm>
-            <a:off x="292608" y="6309360"/>
-            <a:ext cx="1188720" cy="543560"/>
+            <a:off x="292608" y="6291072"/>
+            <a:ext cx="1065929" cy="548640"/>
           </a:xfrm>
           <a:prstGeom prst="rect">
             <a:avLst/>
@@ -4637,8 +4637,8 @@
         </p:blipFill>
         <p:spPr>
           <a:xfrm>
-            <a:off x="292608" y="6309360"/>
-            <a:ext cx="1188720" cy="543560"/>
+            <a:off x="292608" y="6291072"/>
+            <a:ext cx="1065929" cy="548640"/>
           </a:xfrm>
           <a:prstGeom prst="rect">
             <a:avLst/>
@@ -5300,8 +5300,8 @@
         </p:blipFill>
         <p:spPr>
           <a:xfrm>
-            <a:off x="292608" y="6309360"/>
-            <a:ext cx="1188720" cy="543560"/>
+            <a:off x="292608" y="6291072"/>
+            <a:ext cx="1065929" cy="548640"/>
           </a:xfrm>
           <a:prstGeom prst="rect">
             <a:avLst/>
@@ -6462,8 +6462,8 @@
         </p:blipFill>
         <p:spPr>
           <a:xfrm>
-            <a:off x="292608" y="6309360"/>
-            <a:ext cx="1188720" cy="543560"/>
+            <a:off x="292608" y="6291072"/>
+            <a:ext cx="1065929" cy="548640"/>
           </a:xfrm>
           <a:prstGeom prst="rect">
             <a:avLst/>
@@ -7076,8 +7076,8 @@
         </p:blipFill>
         <p:spPr>
           <a:xfrm>
-            <a:off x="292608" y="6309360"/>
-            <a:ext cx="1188720" cy="543560"/>
+            <a:off x="292608" y="6291072"/>
+            <a:ext cx="1065929" cy="548640"/>
           </a:xfrm>
           <a:prstGeom prst="rect">
             <a:avLst/>
@@ -8167,8 +8167,8 @@
         </p:blipFill>
         <p:spPr>
           <a:xfrm>
-            <a:off x="292608" y="6309360"/>
-            <a:ext cx="1188720" cy="543560"/>
+            <a:off x="292608" y="6291072"/>
+            <a:ext cx="1065929" cy="548640"/>
           </a:xfrm>
           <a:prstGeom prst="rect">
             <a:avLst/>
@@ -9110,8 +9110,8 @@
         </p:blipFill>
         <p:spPr>
           <a:xfrm>
-            <a:off x="292608" y="6309360"/>
-            <a:ext cx="1188720" cy="543560"/>
+            <a:off x="292608" y="6291072"/>
+            <a:ext cx="1065929" cy="548640"/>
           </a:xfrm>
           <a:prstGeom prst="rect">
             <a:avLst/>
@@ -10374,8 +10374,8 @@
         </p:blipFill>
         <p:spPr>
           <a:xfrm>
-            <a:off x="292608" y="6309360"/>
-            <a:ext cx="1188720" cy="543560"/>
+            <a:off x="292608" y="6291072"/>
+            <a:ext cx="1065929" cy="548640"/>
           </a:xfrm>
           <a:prstGeom prst="rect">
             <a:avLst/>
@@ -11349,8 +11349,8 @@
         </p:blipFill>
         <p:spPr>
           <a:xfrm>
-            <a:off x="292608" y="6309360"/>
-            <a:ext cx="1188720" cy="543560"/>
+            <a:off x="292608" y="6291072"/>
+            <a:ext cx="1065929" cy="548640"/>
           </a:xfrm>
           <a:prstGeom prst="rect">
             <a:avLst/>
@@ -12628,8 +12628,8 @@
         </p:blipFill>
         <p:spPr>
           <a:xfrm>
-            <a:off x="292608" y="6309360"/>
-            <a:ext cx="1188720" cy="543560"/>
+            <a:off x="292608" y="6291072"/>
+            <a:ext cx="1065929" cy="548640"/>
           </a:xfrm>
           <a:prstGeom prst="rect">
             <a:avLst/>
@@ -14453,8 +14453,8 @@
         </p:blipFill>
         <p:spPr>
           <a:xfrm>
-            <a:off x="292608" y="6309360"/>
-            <a:ext cx="1188720" cy="543560"/>
+            <a:off x="292608" y="6291072"/>
+            <a:ext cx="1065929" cy="548640"/>
           </a:xfrm>
           <a:prstGeom prst="rect">
             <a:avLst/>
@@ -15390,8 +15390,8 @@
         </p:blipFill>
         <p:spPr>
           <a:xfrm>
-            <a:off x="292608" y="6309360"/>
-            <a:ext cx="1188720" cy="543560"/>
+            <a:off x="292608" y="6291072"/>
+            <a:ext cx="1065929" cy="548640"/>
           </a:xfrm>
           <a:prstGeom prst="rect">
             <a:avLst/>
@@ -15715,7 +15715,7 @@
         </p:nvSpPr>
         <p:spPr>
           <a:xfrm>
-            <a:off x="502920" y="3611880"/>
+            <a:off x="502920" y="4206240"/>
             <a:ext cx="6264078" cy="868680"/>
           </a:xfrm>
           <a:prstGeom prst="rect">
@@ -15761,7 +15761,7 @@
         </p:nvSpPr>
         <p:spPr>
           <a:xfrm>
-            <a:off x="777240" y="3730752"/>
+            <a:off x="777240" y="4325112"/>
             <a:ext cx="5715438" cy="685800"/>
           </a:xfrm>
           <a:prstGeom prst="rect">
@@ -16407,8 +16407,8 @@
         </p:blipFill>
         <p:spPr>
           <a:xfrm>
-            <a:off x="292608" y="6309360"/>
-            <a:ext cx="1188720" cy="543560"/>
+            <a:off x="292608" y="6291072"/>
+            <a:ext cx="1065929" cy="548640"/>
           </a:xfrm>
           <a:prstGeom prst="rect">
             <a:avLst/>
@@ -19007,8 +19007,8 @@
         </p:blipFill>
         <p:spPr>
           <a:xfrm>
-            <a:off x="292608" y="6309360"/>
-            <a:ext cx="1188720" cy="543560"/>
+            <a:off x="292608" y="6291072"/>
+            <a:ext cx="1065929" cy="548640"/>
           </a:xfrm>
           <a:prstGeom prst="rect">
             <a:avLst/>

</xml_diff>

<commit_message>
feat(plano-b): adiciona mentores Rodrigo Amaro e Allan Miller na capa
</commit_message>
<xml_diff>
--- a/plano_b_pso_diabetes/Apresentacao_Equipe4_PlanoB_CIRG.pptx
+++ b/plano_b_pso_diabetes/Apresentacao_Equipe4_PlanoB_CIRG.pptx
@@ -3452,8 +3452,8 @@
         </p:nvSpPr>
         <p:spPr>
           <a:xfrm>
-            <a:off x="914400" y="3794760"/>
-            <a:ext cx="10362895" cy="1005840"/>
+            <a:off x="914400" y="3611880"/>
+            <a:ext cx="10362895" cy="1280160"/>
           </a:xfrm>
           <a:prstGeom prst="rect">
             <a:avLst/>
@@ -3475,7 +3475,7 @@
               </a:spcAft>
             </a:pPr>
             <a:r>
-              <a:rPr sz="2000" b="0" i="0">
+              <a:rPr sz="1900" b="0" i="0">
                 <a:solidFill>
                   <a:srgbClr val="595959"/>
                 </a:solidFill>
@@ -3490,17 +3490,36 @@
                 <a:spcPts val="0"/>
               </a:spcBef>
               <a:spcAft>
-                <a:spcPts val="0"/>
-              </a:spcAft>
-            </a:pPr>
-            <a:r>
-              <a:rPr sz="2000" b="0" i="0">
+                <a:spcPts val="400"/>
+              </a:spcAft>
+            </a:pPr>
+            <a:r>
+              <a:rPr sz="1900" b="0" i="0">
                 <a:solidFill>
                   <a:srgbClr val="595959"/>
                 </a:solidFill>
                 <a:latin typeface="Book Antiqua"/>
               </a:rPr>
               <a:t>Prof. Dr. Fernando Buarque de Lima Neto</a:t>
+            </a:r>
+          </a:p>
+          <a:p>
+            <a:pPr algn="ctr">
+              <a:spcBef>
+                <a:spcPts val="0"/>
+              </a:spcBef>
+              <a:spcAft>
+                <a:spcPts val="0"/>
+              </a:spcAft>
+            </a:pPr>
+            <a:r>
+              <a:rPr sz="1600" b="0" i="0">
+                <a:solidFill>
+                  <a:srgbClr val="595959"/>
+                </a:solidFill>
+                <a:latin typeface="Book Antiqua"/>
+              </a:rPr>
+              <a:t>Mentoria: Rodrigo Amaro  ·  Allan Miller</a:t>
             </a:r>
           </a:p>
         </p:txBody>
@@ -3513,7 +3532,7 @@
         </p:nvSpPr>
         <p:spPr>
           <a:xfrm>
-            <a:off x="914400" y="4937760"/>
+            <a:off x="914400" y="5029200"/>
             <a:ext cx="10362895" cy="1097280"/>
           </a:xfrm>
           <a:prstGeom prst="rect">

</xml_diff>

<commit_message>
fix(plano-b): fonte Palatino Linotype + rodape com linha unica (recorte do logo sem o filete)
</commit_message>
<xml_diff>
--- a/plano_b_pso_diabetes/Apresentacao_Equipe4_PlanoB_CIRG.pptx
+++ b/plano_b_pso_diabetes/Apresentacao_Equipe4_PlanoB_CIRG.pptx
@@ -3230,8 +3230,8 @@
         </p:blipFill>
         <p:spPr>
           <a:xfrm>
-            <a:off x="292608" y="6291072"/>
-            <a:ext cx="1065929" cy="548640"/>
+            <a:off x="292608" y="6355080"/>
+            <a:ext cx="1191126" cy="457200"/>
           </a:xfrm>
           <a:prstGeom prst="rect">
             <a:avLst/>
@@ -3246,8 +3246,8 @@
         </p:nvSpPr>
         <p:spPr>
           <a:xfrm>
-            <a:off x="1783080" y="6355080"/>
-            <a:ext cx="7498079" cy="457200"/>
+            <a:off x="1691640" y="6373368"/>
+            <a:ext cx="8229600" cy="457200"/>
           </a:xfrm>
           <a:prstGeom prst="rect">
             <a:avLst/>
@@ -3269,11 +3269,11 @@
               </a:spcAft>
             </a:pPr>
             <a:r>
-              <a:rPr sz="1000" b="0" i="0">
+              <a:rPr sz="1100" b="0" i="0">
                 <a:solidFill>
                   <a:srgbClr val="203864"/>
                 </a:solidFill>
-                <a:latin typeface="Book Antiqua"/>
+                <a:latin typeface="Palatino Linotype"/>
               </a:rPr>
               <a:t>COURSE: Computação Natural</a:t>
             </a:r>
@@ -3288,11 +3288,11 @@
               </a:spcAft>
             </a:pPr>
             <a:r>
-              <a:rPr sz="1000" b="0" i="0">
+              <a:rPr sz="1100" b="0" i="0">
                 <a:solidFill>
                   <a:srgbClr val="203864"/>
                 </a:solidFill>
-                <a:latin typeface="Book Antiqua"/>
+                <a:latin typeface="Palatino Linotype"/>
               </a:rPr>
               <a:t>CLASS: Equipe 4  -  TOPIC: Otimizador Bioinspirado (Plano B)</a:t>
             </a:r>
@@ -3307,7 +3307,7 @@
         </p:nvSpPr>
         <p:spPr>
           <a:xfrm>
-            <a:off x="11323015" y="6364224"/>
+            <a:off x="11323015" y="6400800"/>
             <a:ext cx="548640" cy="274320"/>
           </a:xfrm>
           <a:prstGeom prst="rect">
@@ -3334,7 +3334,7 @@
                 <a:solidFill>
                   <a:srgbClr val="203864"/>
                 </a:solidFill>
-                <a:latin typeface="Book Antiqua"/>
+                <a:latin typeface="Palatino Linotype"/>
               </a:rPr>
               <a:t>1</a:t>
             </a:r>
@@ -3376,7 +3376,7 @@
                 <a:solidFill>
                   <a:srgbClr val="203864"/>
                 </a:solidFill>
-                <a:latin typeface="Book Antiqua"/>
+                <a:latin typeface="Palatino Linotype"/>
               </a:rPr>
               <a:t>At CIRG of POLI/UPE Nature insights nurture our creativity for real problem solving</a:t>
             </a:r>
@@ -3418,7 +3418,7 @@
                 <a:solidFill>
                   <a:srgbClr val="203864"/>
                 </a:solidFill>
-                <a:latin typeface="Book Antiqua"/>
+                <a:latin typeface="Palatino Linotype"/>
               </a:rPr>
               <a:t>Projeto REDS-DM1</a:t>
             </a:r>
@@ -3437,7 +3437,7 @@
                 <a:solidFill>
                   <a:srgbClr val="203864"/>
                 </a:solidFill>
-                <a:latin typeface="Book Antiqua"/>
+                <a:latin typeface="Palatino Linotype"/>
               </a:rPr>
               <a:t>Otimizador Bioinspirado para Gestão de Saúde em Diabetes  ·  Plano B</a:t>
             </a:r>
@@ -3479,7 +3479,7 @@
                 <a:solidFill>
                   <a:srgbClr val="595959"/>
                 </a:solidFill>
-                <a:latin typeface="Book Antiqua"/>
+                <a:latin typeface="Palatino Linotype"/>
               </a:rPr>
               <a:t>Pedro Henrique França  ·  Silas Nunes  ·  Jéssica Maria  ·  José Mario</a:t>
             </a:r>
@@ -3498,7 +3498,7 @@
                 <a:solidFill>
                   <a:srgbClr val="595959"/>
                 </a:solidFill>
-                <a:latin typeface="Book Antiqua"/>
+                <a:latin typeface="Palatino Linotype"/>
               </a:rPr>
               <a:t>Prof. Dr. Fernando Buarque de Lima Neto</a:t>
             </a:r>
@@ -3517,7 +3517,7 @@
                 <a:solidFill>
                   <a:srgbClr val="595959"/>
                 </a:solidFill>
-                <a:latin typeface="Book Antiqua"/>
+                <a:latin typeface="Palatino Linotype"/>
               </a:rPr>
               <a:t>Mentoria: Rodrigo Amaro  ·  Allan Miller</a:t>
             </a:r>
@@ -3559,7 +3559,7 @@
                 <a:solidFill>
                   <a:srgbClr val="595959"/>
                 </a:solidFill>
-                <a:latin typeface="Book Antiqua"/>
+                <a:latin typeface="Palatino Linotype"/>
               </a:rPr>
               <a:t>Universidade de Pernambuco – UPE</a:t>
             </a:r>
@@ -3578,7 +3578,7 @@
                 <a:solidFill>
                   <a:srgbClr val="595959"/>
                 </a:solidFill>
-                <a:latin typeface="Book Antiqua"/>
+                <a:latin typeface="Palatino Linotype"/>
               </a:rPr>
               <a:t>Escola Politécnica de Pernambuco – POLI</a:t>
             </a:r>
@@ -3597,7 +3597,7 @@
                 <a:solidFill>
                   <a:srgbClr val="595959"/>
                 </a:solidFill>
-                <a:latin typeface="Book Antiqua"/>
+                <a:latin typeface="Palatino Linotype"/>
               </a:rPr>
               <a:t>Computational Intelligent Research Group – CIRG</a:t>
             </a:r>
@@ -3750,8 +3750,8 @@
         </p:blipFill>
         <p:spPr>
           <a:xfrm>
-            <a:off x="292608" y="6291072"/>
-            <a:ext cx="1065929" cy="548640"/>
+            <a:off x="292608" y="6355080"/>
+            <a:ext cx="1191126" cy="457200"/>
           </a:xfrm>
           <a:prstGeom prst="rect">
             <a:avLst/>
@@ -3766,8 +3766,8 @@
         </p:nvSpPr>
         <p:spPr>
           <a:xfrm>
-            <a:off x="1783080" y="6355080"/>
-            <a:ext cx="7498079" cy="457200"/>
+            <a:off x="1691640" y="6373368"/>
+            <a:ext cx="8229600" cy="457200"/>
           </a:xfrm>
           <a:prstGeom prst="rect">
             <a:avLst/>
@@ -3789,11 +3789,11 @@
               </a:spcAft>
             </a:pPr>
             <a:r>
-              <a:rPr sz="1000" b="0" i="0">
+              <a:rPr sz="1100" b="0" i="0">
                 <a:solidFill>
                   <a:srgbClr val="203864"/>
                 </a:solidFill>
-                <a:latin typeface="Book Antiqua"/>
+                <a:latin typeface="Palatino Linotype"/>
               </a:rPr>
               <a:t>COURSE: Computação Natural</a:t>
             </a:r>
@@ -3808,11 +3808,11 @@
               </a:spcAft>
             </a:pPr>
             <a:r>
-              <a:rPr sz="1000" b="0" i="0">
+              <a:rPr sz="1100" b="0" i="0">
                 <a:solidFill>
                   <a:srgbClr val="203864"/>
                 </a:solidFill>
-                <a:latin typeface="Book Antiqua"/>
+                <a:latin typeface="Palatino Linotype"/>
               </a:rPr>
               <a:t>CLASS: Equipe 4  -  TOPIC: Otimizador Bioinspirado (Plano B)</a:t>
             </a:r>
@@ -3827,7 +3827,7 @@
         </p:nvSpPr>
         <p:spPr>
           <a:xfrm>
-            <a:off x="11323015" y="6364224"/>
+            <a:off x="11323015" y="6400800"/>
             <a:ext cx="548640" cy="274320"/>
           </a:xfrm>
           <a:prstGeom prst="rect">
@@ -3854,7 +3854,7 @@
                 <a:solidFill>
                   <a:srgbClr val="203864"/>
                 </a:solidFill>
-                <a:latin typeface="Book Antiqua"/>
+                <a:latin typeface="Palatino Linotype"/>
               </a:rPr>
               <a:t>10</a:t>
             </a:r>
@@ -3896,7 +3896,7 @@
                 <a:solidFill>
                   <a:srgbClr val="203864"/>
                 </a:solidFill>
-                <a:latin typeface="Book Antiqua"/>
+                <a:latin typeface="Palatino Linotype"/>
               </a:rPr>
               <a:t>O otimizador acha o ótimo conhecido</a:t>
             </a:r>
@@ -3984,7 +3984,7 @@
                 <a:solidFill>
                   <a:srgbClr val="595959"/>
                 </a:solidFill>
-                <a:latin typeface="Book Antiqua"/>
+                <a:latin typeface="Palatino Linotype"/>
               </a:rPr>
               <a:t>AUC treino</a:t>
             </a:r>
@@ -4026,7 +4026,7 @@
                 <a:solidFill>
                   <a:srgbClr val="595959"/>
                 </a:solidFill>
-                <a:latin typeface="Book Antiqua"/>
+                <a:latin typeface="Palatino Linotype"/>
               </a:rPr>
               <a:t>0,820</a:t>
             </a:r>
@@ -4114,7 +4114,7 @@
                 <a:solidFill>
                   <a:srgbClr val="404040"/>
                 </a:solidFill>
-                <a:latin typeface="Book Antiqua"/>
+                <a:latin typeface="Palatino Linotype"/>
               </a:rPr>
               <a:t>AUC teste</a:t>
             </a:r>
@@ -4156,7 +4156,7 @@
                 <a:solidFill>
                   <a:srgbClr val="404040"/>
                 </a:solidFill>
-                <a:latin typeface="Book Antiqua"/>
+                <a:latin typeface="Palatino Linotype"/>
               </a:rPr>
               <a:t>0,664</a:t>
             </a:r>
@@ -4244,7 +4244,7 @@
                 <a:solidFill>
                   <a:srgbClr val="404040"/>
                 </a:solidFill>
-                <a:latin typeface="Book Antiqua"/>
+                <a:latin typeface="Palatino Linotype"/>
               </a:rPr>
               <a:t>AUC sklearn (baseline)</a:t>
             </a:r>
@@ -4286,7 +4286,7 @@
                 <a:solidFill>
                   <a:srgbClr val="404040"/>
                 </a:solidFill>
-                <a:latin typeface="Book Antiqua"/>
+                <a:latin typeface="Palatino Linotype"/>
               </a:rPr>
               <a:t>0,664</a:t>
             </a:r>
@@ -4372,7 +4372,7 @@
                 <a:solidFill>
                   <a:srgbClr val="CDD7E3"/>
                 </a:solidFill>
-                <a:latin typeface="Book Antiqua"/>
+                <a:latin typeface="Palatino Linotype"/>
               </a:rPr>
               <a:t>Cosseno(pesos PSO, sklearn)</a:t>
             </a:r>
@@ -4391,7 +4391,7 @@
                 <a:solidFill>
                   <a:srgbClr val="FFFFFF"/>
                 </a:solidFill>
-                <a:latin typeface="Book Antiqua"/>
+                <a:latin typeface="Palatino Linotype"/>
               </a:rPr>
               <a:t>1,000</a:t>
             </a:r>
@@ -4503,7 +4503,7 @@
                 <a:solidFill>
                   <a:srgbClr val="595959"/>
                 </a:solidFill>
-                <a:latin typeface="Book Antiqua"/>
+                <a:latin typeface="Palatino Linotype"/>
               </a:rPr>
               <a:t>O AUC mede a dificuldade do problema; o cosseno prova o otimizador. Para uma demonstração de validação, o PSO num problema convexo é limpo e didático: encontra EXATAMENTE a mesma solução que o otimizador analítico.</a:t>
             </a:r>
@@ -4656,8 +4656,8 @@
         </p:blipFill>
         <p:spPr>
           <a:xfrm>
-            <a:off x="292608" y="6291072"/>
-            <a:ext cx="1065929" cy="548640"/>
+            <a:off x="292608" y="6355080"/>
+            <a:ext cx="1191126" cy="457200"/>
           </a:xfrm>
           <a:prstGeom prst="rect">
             <a:avLst/>
@@ -4672,8 +4672,8 @@
         </p:nvSpPr>
         <p:spPr>
           <a:xfrm>
-            <a:off x="1783080" y="6355080"/>
-            <a:ext cx="7498079" cy="457200"/>
+            <a:off x="1691640" y="6373368"/>
+            <a:ext cx="8229600" cy="457200"/>
           </a:xfrm>
           <a:prstGeom prst="rect">
             <a:avLst/>
@@ -4695,11 +4695,11 @@
               </a:spcAft>
             </a:pPr>
             <a:r>
-              <a:rPr sz="1000" b="0" i="0">
+              <a:rPr sz="1100" b="0" i="0">
                 <a:solidFill>
                   <a:srgbClr val="203864"/>
                 </a:solidFill>
-                <a:latin typeface="Book Antiqua"/>
+                <a:latin typeface="Palatino Linotype"/>
               </a:rPr>
               <a:t>COURSE: Computação Natural</a:t>
             </a:r>
@@ -4714,11 +4714,11 @@
               </a:spcAft>
             </a:pPr>
             <a:r>
-              <a:rPr sz="1000" b="0" i="0">
+              <a:rPr sz="1100" b="0" i="0">
                 <a:solidFill>
                   <a:srgbClr val="203864"/>
                 </a:solidFill>
-                <a:latin typeface="Book Antiqua"/>
+                <a:latin typeface="Palatino Linotype"/>
               </a:rPr>
               <a:t>CLASS: Equipe 4  -  TOPIC: Otimizador Bioinspirado (Plano B)</a:t>
             </a:r>
@@ -4733,7 +4733,7 @@
         </p:nvSpPr>
         <p:spPr>
           <a:xfrm>
-            <a:off x="11323015" y="6364224"/>
+            <a:off x="11323015" y="6400800"/>
             <a:ext cx="548640" cy="274320"/>
           </a:xfrm>
           <a:prstGeom prst="rect">
@@ -4760,7 +4760,7 @@
                 <a:solidFill>
                   <a:srgbClr val="203864"/>
                 </a:solidFill>
-                <a:latin typeface="Book Antiqua"/>
+                <a:latin typeface="Palatino Linotype"/>
               </a:rPr>
               <a:t>11</a:t>
             </a:r>
@@ -4802,7 +4802,7 @@
                 <a:solidFill>
                   <a:srgbClr val="203864"/>
                 </a:solidFill>
-                <a:latin typeface="Book Antiqua"/>
+                <a:latin typeface="Palatino Linotype"/>
               </a:rPr>
               <a:t>O ganho: o perfil do indivíduo ideal</a:t>
             </a:r>
@@ -4914,7 +4914,7 @@
                 <a:solidFill>
                   <a:srgbClr val="203864"/>
                 </a:solidFill>
-                <a:latin typeface="Book Antiqua"/>
+                <a:latin typeface="Palatino Linotype"/>
               </a:rPr>
               <a:t>Top características (peso do PSO)</a:t>
             </a:r>
@@ -4933,7 +4933,7 @@
                 <a:solidFill>
                   <a:srgbClr val="203864"/>
                 </a:solidFill>
-                <a:latin typeface="Book Antiqua"/>
+                <a:latin typeface="Arial"/>
               </a:rPr>
               <a:t>•  </a:t>
             </a:r>
@@ -4942,7 +4942,7 @@
                 <a:solidFill>
                   <a:srgbClr val="404040"/>
                 </a:solidFill>
-                <a:latin typeface="Book Antiqua"/>
+                <a:latin typeface="Palatino Linotype"/>
               </a:rPr>
               <a:t>CP2h +0,338  ·  BMI −0,304  ·  BUN +0,240</a:t>
             </a:r>
@@ -4961,7 +4961,7 @@
                 <a:solidFill>
                   <a:srgbClr val="203864"/>
                 </a:solidFill>
-                <a:latin typeface="Book Antiqua"/>
+                <a:latin typeface="Arial"/>
               </a:rPr>
               <a:t>•  </a:t>
             </a:r>
@@ -4970,7 +4970,7 @@
                 <a:solidFill>
                   <a:srgbClr val="404040"/>
                 </a:solidFill>
-                <a:latin typeface="Book Antiqua"/>
+                <a:latin typeface="Palatino Linotype"/>
               </a:rPr>
               <a:t>waist1 −0,232  ·  ISIGutt −0,212  ·  WHR −0,193</a:t>
             </a:r>
@@ -4989,7 +4989,7 @@
                 <a:solidFill>
                   <a:srgbClr val="203864"/>
                 </a:solidFill>
-                <a:latin typeface="Book Antiqua"/>
+                <a:latin typeface="Arial"/>
               </a:rPr>
               <a:t>•  </a:t>
             </a:r>
@@ -4998,7 +4998,7 @@
                 <a:solidFill>
                   <a:srgbClr val="404040"/>
                 </a:solidFill>
-                <a:latin typeface="Book Antiqua"/>
+                <a:latin typeface="Palatino Linotype"/>
               </a:rPr>
               <a:t>SCRE +0,162  ·  ALT −0,134  ·  FatherDM −0,119</a:t>
             </a:r>
@@ -5086,7 +5086,7 @@
                 <a:solidFill>
                   <a:srgbClr val="203864"/>
                 </a:solidFill>
-                <a:latin typeface="Book Antiqua"/>
+                <a:latin typeface="Palatino Linotype"/>
               </a:rPr>
               <a:t>Perfil-síntese do diabético ideal</a:t>
             </a:r>
@@ -5105,7 +5105,7 @@
                 <a:solidFill>
                   <a:srgbClr val="404040"/>
                 </a:solidFill>
-                <a:latin typeface="Book Antiqua"/>
+                <a:latin typeface="Palatino Linotype"/>
               </a:rPr>
               <a:t>Mais magro, com menor resistência à insulina, função hepática preservada (ALT) e sem histórico familiar de DM.</a:t>
             </a:r>
@@ -5147,7 +5147,7 @@
                 <a:solidFill>
                   <a:srgbClr val="595959"/>
                 </a:solidFill>
-                <a:latin typeface="Book Antiqua"/>
+                <a:latin typeface="Palatino Linotype"/>
               </a:rPr>
               <a:t>Médias (ideais vs demais):</a:t>
             </a:r>
@@ -5166,7 +5166,7 @@
                 <a:solidFill>
                   <a:srgbClr val="404040"/>
                 </a:solidFill>
-                <a:latin typeface="Book Antiqua"/>
+                <a:latin typeface="Palatino Linotype"/>
               </a:rPr>
               <a:t>BMI 21,4 vs 24,8   ·   ISIGutt 57,3 vs 104,8   ·   ALT 33,4 vs 45,7</a:t>
             </a:r>
@@ -5319,8 +5319,8 @@
         </p:blipFill>
         <p:spPr>
           <a:xfrm>
-            <a:off x="292608" y="6291072"/>
-            <a:ext cx="1065929" cy="548640"/>
+            <a:off x="292608" y="6355080"/>
+            <a:ext cx="1191126" cy="457200"/>
           </a:xfrm>
           <a:prstGeom prst="rect">
             <a:avLst/>
@@ -5335,8 +5335,8 @@
         </p:nvSpPr>
         <p:spPr>
           <a:xfrm>
-            <a:off x="1783080" y="6355080"/>
-            <a:ext cx="7498079" cy="457200"/>
+            <a:off x="1691640" y="6373368"/>
+            <a:ext cx="8229600" cy="457200"/>
           </a:xfrm>
           <a:prstGeom prst="rect">
             <a:avLst/>
@@ -5358,11 +5358,11 @@
               </a:spcAft>
             </a:pPr>
             <a:r>
-              <a:rPr sz="1000" b="0" i="0">
+              <a:rPr sz="1100" b="0" i="0">
                 <a:solidFill>
                   <a:srgbClr val="203864"/>
                 </a:solidFill>
-                <a:latin typeface="Book Antiqua"/>
+                <a:latin typeface="Palatino Linotype"/>
               </a:rPr>
               <a:t>COURSE: Computação Natural</a:t>
             </a:r>
@@ -5377,11 +5377,11 @@
               </a:spcAft>
             </a:pPr>
             <a:r>
-              <a:rPr sz="1000" b="0" i="0">
+              <a:rPr sz="1100" b="0" i="0">
                 <a:solidFill>
                   <a:srgbClr val="203864"/>
                 </a:solidFill>
-                <a:latin typeface="Book Antiqua"/>
+                <a:latin typeface="Palatino Linotype"/>
               </a:rPr>
               <a:t>CLASS: Equipe 4  -  TOPIC: Otimizador Bioinspirado (Plano B)</a:t>
             </a:r>
@@ -5396,7 +5396,7 @@
         </p:nvSpPr>
         <p:spPr>
           <a:xfrm>
-            <a:off x="11323015" y="6364224"/>
+            <a:off x="11323015" y="6400800"/>
             <a:ext cx="548640" cy="274320"/>
           </a:xfrm>
           <a:prstGeom prst="rect">
@@ -5423,7 +5423,7 @@
                 <a:solidFill>
                   <a:srgbClr val="203864"/>
                 </a:solidFill>
-                <a:latin typeface="Book Antiqua"/>
+                <a:latin typeface="Palatino Linotype"/>
               </a:rPr>
               <a:t>12</a:t>
             </a:r>
@@ -5465,7 +5465,7 @@
                 <a:solidFill>
                   <a:srgbClr val="203864"/>
                 </a:solidFill>
-                <a:latin typeface="Book Antiqua"/>
+                <a:latin typeface="Palatino Linotype"/>
               </a:rPr>
               <a:t>Meta-FSS — o enxame que ajusta o enxame</a:t>
             </a:r>
@@ -5507,7 +5507,7 @@
                 <a:solidFill>
                   <a:srgbClr val="595959"/>
                 </a:solidFill>
-                <a:latin typeface="Book Antiqua"/>
+                <a:latin typeface="Palatino Linotype"/>
               </a:rPr>
               <a:t>FSS (Fish School Search) otimiza os hiperparâmetros do PSO — meta-otimização em dois níveis.</a:t>
             </a:r>
@@ -5639,7 +5639,7 @@
                 <a:solidFill>
                   <a:srgbClr val="203864"/>
                 </a:solidFill>
-                <a:latin typeface="Book Antiqua"/>
+                <a:latin typeface="Palatino Linotype"/>
               </a:rPr>
               <a:t>FSS — meta-nível</a:t>
             </a:r>
@@ -5658,7 +5658,7 @@
                 <a:solidFill>
                   <a:srgbClr val="595959"/>
                 </a:solidFill>
-                <a:latin typeface="Book Antiqua"/>
+                <a:latin typeface="Palatino Linotype"/>
               </a:rPr>
               <a:t>ajusta w, c1, c2, λ</a:t>
             </a:r>
@@ -5700,7 +5700,7 @@
                 <a:solidFill>
                   <a:srgbClr val="595959"/>
                 </a:solidFill>
-                <a:latin typeface="Book Antiqua"/>
+                <a:latin typeface="Palatino Linotype"/>
               </a:rPr>
               <a:t>→</a:t>
             </a:r>
@@ -5832,7 +5832,7 @@
                 <a:solidFill>
                   <a:srgbClr val="203864"/>
                 </a:solidFill>
-                <a:latin typeface="Book Antiqua"/>
+                <a:latin typeface="Palatino Linotype"/>
               </a:rPr>
               <a:t>PSO — nível 1</a:t>
             </a:r>
@@ -5851,7 +5851,7 @@
                 <a:solidFill>
                   <a:srgbClr val="595959"/>
                 </a:solidFill>
-                <a:latin typeface="Book Antiqua"/>
+                <a:latin typeface="Palatino Linotype"/>
               </a:rPr>
               <a:t>otimiza os pesos do modelo</a:t>
             </a:r>
@@ -5893,7 +5893,7 @@
                 <a:solidFill>
                   <a:srgbClr val="595959"/>
                 </a:solidFill>
-                <a:latin typeface="Book Antiqua"/>
+                <a:latin typeface="Palatino Linotype"/>
               </a:rPr>
               <a:t>→</a:t>
             </a:r>
@@ -6025,7 +6025,7 @@
                 <a:solidFill>
                   <a:srgbClr val="203864"/>
                 </a:solidFill>
-                <a:latin typeface="Book Antiqua"/>
+                <a:latin typeface="Palatino Linotype"/>
               </a:rPr>
               <a:t>Regressão logística</a:t>
             </a:r>
@@ -6044,7 +6044,7 @@
                 <a:solidFill>
                   <a:srgbClr val="595959"/>
                 </a:solidFill>
-                <a:latin typeface="Book Antiqua"/>
+                <a:latin typeface="Palatino Linotype"/>
               </a:rPr>
               <a:t>classifica o Wellness</a:t>
             </a:r>
@@ -6086,7 +6086,7 @@
                 <a:solidFill>
                   <a:srgbClr val="203864"/>
                 </a:solidFill>
-                <a:latin typeface="Book Antiqua"/>
+                <a:latin typeface="Palatino Linotype"/>
               </a:rPr>
               <a:t>Hiperparâmetros encontrados pelo FSS</a:t>
             </a:r>
@@ -6105,7 +6105,7 @@
                 <a:solidFill>
                   <a:srgbClr val="203864"/>
                 </a:solidFill>
-                <a:latin typeface="Book Antiqua"/>
+                <a:latin typeface="Arial"/>
               </a:rPr>
               <a:t>•  </a:t>
             </a:r>
@@ -6114,7 +6114,7 @@
                 <a:solidFill>
                   <a:srgbClr val="404040"/>
                 </a:solidFill>
-                <a:latin typeface="Book Antiqua"/>
+                <a:latin typeface="Palatino Linotype"/>
               </a:rPr>
               <a:t>w = 0,67  ·  c1 = 0,74  ·  c2 = 0,59  ·  λ = 0,016</a:t>
             </a:r>
@@ -6133,7 +6133,7 @@
                 <a:solidFill>
                   <a:srgbClr val="203864"/>
                 </a:solidFill>
-                <a:latin typeface="Book Antiqua"/>
+                <a:latin typeface="Arial"/>
               </a:rPr>
               <a:t>•  </a:t>
             </a:r>
@@ -6142,7 +6142,7 @@
                 <a:solidFill>
                   <a:srgbClr val="404040"/>
                 </a:solidFill>
-                <a:latin typeface="Book Antiqua"/>
+                <a:latin typeface="Palatino Linotype"/>
               </a:rPr>
               <a:t>AUC teste: 0,678 (meta)  vs  0,664 (padrão)  →  +0,014</a:t>
             </a:r>
@@ -6161,7 +6161,7 @@
                 <a:solidFill>
                   <a:srgbClr val="203864"/>
                 </a:solidFill>
-                <a:latin typeface="Book Antiqua"/>
+                <a:latin typeface="Arial"/>
               </a:rPr>
               <a:t>•  </a:t>
             </a:r>
@@ -6170,7 +6170,7 @@
                 <a:solidFill>
                   <a:srgbClr val="404040"/>
                 </a:solidFill>
-                <a:latin typeface="Book Antiqua"/>
+                <a:latin typeface="Palatino Linotype"/>
               </a:rPr>
               <a:t>Avaliação por CV-3 no treino (sem tocar no teste).</a:t>
             </a:r>
@@ -6328,7 +6328,7 @@
                 <a:solidFill>
                   <a:srgbClr val="404040"/>
                 </a:solidFill>
-                <a:latin typeface="Book Antiqua"/>
+                <a:latin typeface="Palatino Linotype"/>
               </a:rPr>
               <a:t>Leitura honesta: o ganho (+0,014) está dentro do ruído da estimativa (IC ≈ 0,68 ± 0,15) e parte vem do afrouxamento do L2. O ponto não é o número — é mostrar a família FSS governando o PSO.</a:t>
             </a:r>
@@ -6481,8 +6481,8 @@
         </p:blipFill>
         <p:spPr>
           <a:xfrm>
-            <a:off x="292608" y="6291072"/>
-            <a:ext cx="1065929" cy="548640"/>
+            <a:off x="292608" y="6355080"/>
+            <a:ext cx="1191126" cy="457200"/>
           </a:xfrm>
           <a:prstGeom prst="rect">
             <a:avLst/>
@@ -6497,8 +6497,8 @@
         </p:nvSpPr>
         <p:spPr>
           <a:xfrm>
-            <a:off x="1783080" y="6355080"/>
-            <a:ext cx="7498079" cy="457200"/>
+            <a:off x="1691640" y="6373368"/>
+            <a:ext cx="8229600" cy="457200"/>
           </a:xfrm>
           <a:prstGeom prst="rect">
             <a:avLst/>
@@ -6520,11 +6520,11 @@
               </a:spcAft>
             </a:pPr>
             <a:r>
-              <a:rPr sz="1000" b="0" i="0">
+              <a:rPr sz="1100" b="0" i="0">
                 <a:solidFill>
                   <a:srgbClr val="203864"/>
                 </a:solidFill>
-                <a:latin typeface="Book Antiqua"/>
+                <a:latin typeface="Palatino Linotype"/>
               </a:rPr>
               <a:t>COURSE: Computação Natural</a:t>
             </a:r>
@@ -6539,11 +6539,11 @@
               </a:spcAft>
             </a:pPr>
             <a:r>
-              <a:rPr sz="1000" b="0" i="0">
+              <a:rPr sz="1100" b="0" i="0">
                 <a:solidFill>
                   <a:srgbClr val="203864"/>
                 </a:solidFill>
-                <a:latin typeface="Book Antiqua"/>
+                <a:latin typeface="Palatino Linotype"/>
               </a:rPr>
               <a:t>CLASS: Equipe 4  -  TOPIC: Otimizador Bioinspirado (Plano B)</a:t>
             </a:r>
@@ -6558,7 +6558,7 @@
         </p:nvSpPr>
         <p:spPr>
           <a:xfrm>
-            <a:off x="11323015" y="6364224"/>
+            <a:off x="11323015" y="6400800"/>
             <a:ext cx="548640" cy="274320"/>
           </a:xfrm>
           <a:prstGeom prst="rect">
@@ -6585,7 +6585,7 @@
                 <a:solidFill>
                   <a:srgbClr val="203864"/>
                 </a:solidFill>
-                <a:latin typeface="Book Antiqua"/>
+                <a:latin typeface="Palatino Linotype"/>
               </a:rPr>
               <a:t>13</a:t>
             </a:r>
@@ -6627,7 +6627,7 @@
                 <a:solidFill>
                   <a:srgbClr val="203864"/>
                 </a:solidFill>
-                <a:latin typeface="Book Antiqua"/>
+                <a:latin typeface="Palatino Linotype"/>
               </a:rPr>
               <a:t>BFSS, de relance — o plano principal segue vivo</a:t>
             </a:r>
@@ -6669,7 +6669,7 @@
                 <a:solidFill>
                   <a:srgbClr val="203864"/>
                 </a:solidFill>
-                <a:latin typeface="Book Antiqua"/>
+                <a:latin typeface="Palatino Linotype"/>
               </a:rPr>
               <a:t>Validação por marcadores plantados</a:t>
             </a:r>
@@ -6688,7 +6688,7 @@
                 <a:solidFill>
                   <a:srgbClr val="203864"/>
                 </a:solidFill>
-                <a:latin typeface="Book Antiqua"/>
+                <a:latin typeface="Arial"/>
               </a:rPr>
               <a:t>•  </a:t>
             </a:r>
@@ -6697,7 +6697,7 @@
                 <a:solidFill>
                   <a:srgbClr val="404040"/>
                 </a:solidFill>
-                <a:latin typeface="Book Antiqua"/>
+                <a:latin typeface="Palatino Linotype"/>
               </a:rPr>
               <a:t>Base sintética com gabarito (verdade-base plantada).</a:t>
             </a:r>
@@ -6716,7 +6716,7 @@
                 <a:solidFill>
                   <a:srgbClr val="203864"/>
                 </a:solidFill>
-                <a:latin typeface="Book Antiqua"/>
+                <a:latin typeface="Arial"/>
               </a:rPr>
               <a:t>•  </a:t>
             </a:r>
@@ -6725,7 +6725,7 @@
                 <a:solidFill>
                   <a:srgbClr val="404040"/>
                 </a:solidFill>
-                <a:latin typeface="Book Antiqua"/>
+                <a:latin typeface="Palatino Linotype"/>
               </a:rPr>
               <a:t>Prova ALGORÍTMICA de que o otimizador recupera o sinal — não é alegação clínica.</a:t>
             </a:r>
@@ -6744,7 +6744,7 @@
                 <a:solidFill>
                   <a:srgbClr val="203864"/>
                 </a:solidFill>
-                <a:latin typeface="Book Antiqua"/>
+                <a:latin typeface="Arial"/>
               </a:rPr>
               <a:t>•  </a:t>
             </a:r>
@@ -6753,7 +6753,7 @@
                 <a:solidFill>
                   <a:srgbClr val="404040"/>
                 </a:solidFill>
-                <a:latin typeface="Book Antiqua"/>
+                <a:latin typeface="Palatino Linotype"/>
               </a:rPr>
               <a:t>Mantém a família de enxame (FSS) como fio condutor do projeto.</a:t>
             </a:r>
@@ -6772,7 +6772,7 @@
                 <a:solidFill>
                   <a:srgbClr val="595959"/>
                 </a:solidFill>
-                <a:latin typeface="Book Antiqua"/>
+                <a:latin typeface="Palatino Linotype"/>
               </a:rPr>
               <a:t>Próximo: MOPSO discreto + NSGA-II para a frente de Pareto.</a:t>
             </a:r>
@@ -6904,7 +6904,7 @@
                 <a:solidFill>
                   <a:srgbClr val="595959"/>
                 </a:solidFill>
-                <a:latin typeface="Book Antiqua"/>
+                <a:latin typeface="Palatino Linotype"/>
               </a:rPr>
               <a:t>STATUS</a:t>
             </a:r>
@@ -6923,7 +6923,7 @@
                 <a:solidFill>
                   <a:srgbClr val="2E6B4F"/>
                 </a:solidFill>
-                <a:latin typeface="Book Antiqua"/>
+                <a:latin typeface="Palatino Linotype"/>
               </a:rPr>
               <a:t>BFSS validado</a:t>
             </a:r>
@@ -6942,7 +6942,7 @@
                 <a:solidFill>
                   <a:srgbClr val="404040"/>
                 </a:solidFill>
-                <a:latin typeface="Book Antiqua"/>
+                <a:latin typeface="Palatino Linotype"/>
               </a:rPr>
               <a:t>Recuperou 8 de 9 marcadores plantados; o subconjunto selecionado eleva o R².</a:t>
             </a:r>
@@ -7095,8 +7095,8 @@
         </p:blipFill>
         <p:spPr>
           <a:xfrm>
-            <a:off x="292608" y="6291072"/>
-            <a:ext cx="1065929" cy="548640"/>
+            <a:off x="292608" y="6355080"/>
+            <a:ext cx="1191126" cy="457200"/>
           </a:xfrm>
           <a:prstGeom prst="rect">
             <a:avLst/>
@@ -7111,8 +7111,8 @@
         </p:nvSpPr>
         <p:spPr>
           <a:xfrm>
-            <a:off x="1783080" y="6355080"/>
-            <a:ext cx="7498079" cy="457200"/>
+            <a:off x="1691640" y="6373368"/>
+            <a:ext cx="8229600" cy="457200"/>
           </a:xfrm>
           <a:prstGeom prst="rect">
             <a:avLst/>
@@ -7134,11 +7134,11 @@
               </a:spcAft>
             </a:pPr>
             <a:r>
-              <a:rPr sz="1000" b="0" i="0">
+              <a:rPr sz="1100" b="0" i="0">
                 <a:solidFill>
                   <a:srgbClr val="203864"/>
                 </a:solidFill>
-                <a:latin typeface="Book Antiqua"/>
+                <a:latin typeface="Palatino Linotype"/>
               </a:rPr>
               <a:t>COURSE: Computação Natural</a:t>
             </a:r>
@@ -7153,11 +7153,11 @@
               </a:spcAft>
             </a:pPr>
             <a:r>
-              <a:rPr sz="1000" b="0" i="0">
+              <a:rPr sz="1100" b="0" i="0">
                 <a:solidFill>
                   <a:srgbClr val="203864"/>
                 </a:solidFill>
-                <a:latin typeface="Book Antiqua"/>
+                <a:latin typeface="Palatino Linotype"/>
               </a:rPr>
               <a:t>CLASS: Equipe 4  -  TOPIC: Otimizador Bioinspirado (Plano B)</a:t>
             </a:r>
@@ -7172,7 +7172,7 @@
         </p:nvSpPr>
         <p:spPr>
           <a:xfrm>
-            <a:off x="11323015" y="6364224"/>
+            <a:off x="11323015" y="6400800"/>
             <a:ext cx="548640" cy="274320"/>
           </a:xfrm>
           <a:prstGeom prst="rect">
@@ -7199,7 +7199,7 @@
                 <a:solidFill>
                   <a:srgbClr val="203864"/>
                 </a:solidFill>
-                <a:latin typeface="Book Antiqua"/>
+                <a:latin typeface="Palatino Linotype"/>
               </a:rPr>
               <a:t>14</a:t>
             </a:r>
@@ -7241,7 +7241,7 @@
                 <a:solidFill>
                   <a:srgbClr val="203864"/>
                 </a:solidFill>
-                <a:latin typeface="Book Antiqua"/>
+                <a:latin typeface="Palatino Linotype"/>
               </a:rPr>
               <a:t>Limitações declaradas</a:t>
             </a:r>
@@ -7373,7 +7373,7 @@
                 <a:solidFill>
                   <a:srgbClr val="404040"/>
                 </a:solidFill>
-                <a:latin typeface="Book Antiqua"/>
+                <a:latin typeface="Palatino Linotype"/>
               </a:rPr>
               <a:t>A base não distingue T1D/T2D → 'diabetes tipo não especificado'; é testbed, não evidência clínica.</a:t>
             </a:r>
@@ -7505,7 +7505,7 @@
                 <a:solidFill>
                   <a:srgbClr val="404040"/>
                 </a:solidFill>
-                <a:latin typeface="Book Antiqua"/>
+                <a:latin typeface="Palatino Linotype"/>
               </a:rPr>
               <a:t>Coorte única e transversal (China, 2012) → fala de associação, não de causalidade.</a:t>
             </a:r>
@@ -7637,7 +7637,7 @@
                 <a:solidFill>
                   <a:srgbClr val="404040"/>
                 </a:solidFill>
-                <a:latin typeface="Book Antiqua"/>
+                <a:latin typeface="Palatino Linotype"/>
               </a:rPr>
               <a:t>O rótulo 'ideal' é uma escolha de projeto defensável, não a única.</a:t>
             </a:r>
@@ -7769,7 +7769,7 @@
                 <a:solidFill>
                   <a:srgbClr val="404040"/>
                 </a:solidFill>
-                <a:latin typeface="Book Antiqua"/>
+                <a:latin typeface="Palatino Linotype"/>
               </a:rPr>
               <a:t>As 26 preditoras foram curadas à mão → podem ter omitido pistas relevantes.</a:t>
             </a:r>
@@ -7901,7 +7901,7 @@
                 <a:solidFill>
                   <a:srgbClr val="404040"/>
                 </a:solidFill>
-                <a:latin typeface="Book Antiqua"/>
+                <a:latin typeface="Palatino Linotype"/>
               </a:rPr>
               <a:t>Imputação pela mediana 'achata' a variação; o corte do terço (33%) é limiar arbitrário.</a:t>
             </a:r>
@@ -8033,7 +8033,7 @@
                 <a:solidFill>
                   <a:srgbClr val="404040"/>
                 </a:solidFill>
-                <a:latin typeface="Book Antiqua"/>
+                <a:latin typeface="Palatino Linotype"/>
               </a:rPr>
               <a:t>L2 (λ=0,05) calibrado empiricamente, não por cross-validation formal.</a:t>
             </a:r>
@@ -8186,8 +8186,8 @@
         </p:blipFill>
         <p:spPr>
           <a:xfrm>
-            <a:off x="292608" y="6291072"/>
-            <a:ext cx="1065929" cy="548640"/>
+            <a:off x="292608" y="6355080"/>
+            <a:ext cx="1191126" cy="457200"/>
           </a:xfrm>
           <a:prstGeom prst="rect">
             <a:avLst/>
@@ -8202,8 +8202,8 @@
         </p:nvSpPr>
         <p:spPr>
           <a:xfrm>
-            <a:off x="1783080" y="6355080"/>
-            <a:ext cx="7498079" cy="457200"/>
+            <a:off x="1691640" y="6373368"/>
+            <a:ext cx="8229600" cy="457200"/>
           </a:xfrm>
           <a:prstGeom prst="rect">
             <a:avLst/>
@@ -8225,11 +8225,11 @@
               </a:spcAft>
             </a:pPr>
             <a:r>
-              <a:rPr sz="1000" b="0" i="0">
+              <a:rPr sz="1100" b="0" i="0">
                 <a:solidFill>
                   <a:srgbClr val="203864"/>
                 </a:solidFill>
-                <a:latin typeface="Book Antiqua"/>
+                <a:latin typeface="Palatino Linotype"/>
               </a:rPr>
               <a:t>COURSE: Computação Natural</a:t>
             </a:r>
@@ -8244,11 +8244,11 @@
               </a:spcAft>
             </a:pPr>
             <a:r>
-              <a:rPr sz="1000" b="0" i="0">
+              <a:rPr sz="1100" b="0" i="0">
                 <a:solidFill>
                   <a:srgbClr val="203864"/>
                 </a:solidFill>
-                <a:latin typeface="Book Antiqua"/>
+                <a:latin typeface="Palatino Linotype"/>
               </a:rPr>
               <a:t>CLASS: Equipe 4  -  TOPIC: Otimizador Bioinspirado (Plano B)</a:t>
             </a:r>
@@ -8263,7 +8263,7 @@
         </p:nvSpPr>
         <p:spPr>
           <a:xfrm>
-            <a:off x="11323015" y="6364224"/>
+            <a:off x="11323015" y="6400800"/>
             <a:ext cx="548640" cy="274320"/>
           </a:xfrm>
           <a:prstGeom prst="rect">
@@ -8290,7 +8290,7 @@
                 <a:solidFill>
                   <a:srgbClr val="203864"/>
                 </a:solidFill>
-                <a:latin typeface="Book Antiqua"/>
+                <a:latin typeface="Palatino Linotype"/>
               </a:rPr>
               <a:t>15</a:t>
             </a:r>
@@ -8332,7 +8332,7 @@
                 <a:solidFill>
                   <a:srgbClr val="203864"/>
                 </a:solidFill>
-                <a:latin typeface="Book Antiqua"/>
+                <a:latin typeface="Palatino Linotype"/>
               </a:rPr>
               <a:t>Próximos passos e conclusão</a:t>
             </a:r>
@@ -8420,7 +8420,7 @@
                 <a:solidFill>
                   <a:srgbClr val="203864"/>
                 </a:solidFill>
-                <a:latin typeface="Book Antiqua"/>
+                <a:latin typeface="Palatino Linotype"/>
               </a:rPr>
               <a:t>PSO (Plano B)</a:t>
             </a:r>
@@ -8462,7 +8462,7 @@
                 <a:solidFill>
                   <a:srgbClr val="595959"/>
                 </a:solidFill>
-                <a:latin typeface="Book Antiqua"/>
+                <a:latin typeface="Palatino Linotype"/>
               </a:rPr>
               <a:t>→</a:t>
             </a:r>
@@ -8550,7 +8550,7 @@
                 <a:solidFill>
                   <a:srgbClr val="203864"/>
                 </a:solidFill>
-                <a:latin typeface="Book Antiqua"/>
+                <a:latin typeface="Palatino Linotype"/>
               </a:rPr>
               <a:t>BFSS</a:t>
             </a:r>
@@ -8592,7 +8592,7 @@
                 <a:solidFill>
                   <a:srgbClr val="595959"/>
                 </a:solidFill>
-                <a:latin typeface="Book Antiqua"/>
+                <a:latin typeface="Palatino Linotype"/>
               </a:rPr>
               <a:t>→</a:t>
             </a:r>
@@ -8680,7 +8680,7 @@
                 <a:solidFill>
                   <a:srgbClr val="203864"/>
                 </a:solidFill>
-                <a:latin typeface="Book Antiqua"/>
+                <a:latin typeface="Palatino Linotype"/>
               </a:rPr>
               <a:t>Simulador HLY</a:t>
             </a:r>
@@ -8722,7 +8722,7 @@
                 <a:solidFill>
                   <a:srgbClr val="595959"/>
                 </a:solidFill>
-                <a:latin typeface="Book Antiqua"/>
+                <a:latin typeface="Palatino Linotype"/>
               </a:rPr>
               <a:t>→</a:t>
             </a:r>
@@ -8810,7 +8810,7 @@
                 <a:solidFill>
                   <a:srgbClr val="203864"/>
                 </a:solidFill>
-                <a:latin typeface="Book Antiqua"/>
+                <a:latin typeface="Palatino Linotype"/>
               </a:rPr>
               <a:t>MOPSO + NSGA-II</a:t>
             </a:r>
@@ -8852,7 +8852,7 @@
                 <a:solidFill>
                   <a:srgbClr val="203864"/>
                 </a:solidFill>
-                <a:latin typeface="Book Antiqua"/>
+                <a:latin typeface="Palatino Linotype"/>
               </a:rPr>
               <a:t>Próximo passo — frente de Pareto</a:t>
             </a:r>
@@ -8871,7 +8871,7 @@
                 <a:solidFill>
                   <a:srgbClr val="404040"/>
                 </a:solidFill>
-                <a:latin typeface="Book Antiqua"/>
+                <a:latin typeface="Palatino Linotype"/>
               </a:rPr>
               <a:t>MOPSO discreto + NSGA-II sobre ~540 políticas, com gabarito computável por enumeração (HLY × Custo × Equidade).</a:t>
             </a:r>
@@ -8957,7 +8957,7 @@
                 <a:solidFill>
                   <a:srgbClr val="CDD7E3"/>
                 </a:solidFill>
-                <a:latin typeface="Book Antiqua"/>
+                <a:latin typeface="Palatino Linotype"/>
               </a:rPr>
               <a:t>Conclusão</a:t>
             </a:r>
@@ -8976,7 +8976,7 @@
                 <a:solidFill>
                   <a:srgbClr val="FFFFFF"/>
                 </a:solidFill>
-                <a:latin typeface="Book Antiqua"/>
+                <a:latin typeface="Palatino Linotype"/>
               </a:rPr>
               <a:t>PSO validado (cosseno 1,000) + perfil clínico interpretável = o otimizador funciona. O Plano A continua como horizonte multiobjetivo.</a:t>
             </a:r>
@@ -9129,8 +9129,8 @@
         </p:blipFill>
         <p:spPr>
           <a:xfrm>
-            <a:off x="292608" y="6291072"/>
-            <a:ext cx="1065929" cy="548640"/>
+            <a:off x="292608" y="6355080"/>
+            <a:ext cx="1191126" cy="457200"/>
           </a:xfrm>
           <a:prstGeom prst="rect">
             <a:avLst/>
@@ -9145,8 +9145,8 @@
         </p:nvSpPr>
         <p:spPr>
           <a:xfrm>
-            <a:off x="1783080" y="6355080"/>
-            <a:ext cx="7498079" cy="457200"/>
+            <a:off x="1691640" y="6373368"/>
+            <a:ext cx="8229600" cy="457200"/>
           </a:xfrm>
           <a:prstGeom prst="rect">
             <a:avLst/>
@@ -9168,11 +9168,11 @@
               </a:spcAft>
             </a:pPr>
             <a:r>
-              <a:rPr sz="1000" b="0" i="0">
+              <a:rPr sz="1100" b="0" i="0">
                 <a:solidFill>
                   <a:srgbClr val="203864"/>
                 </a:solidFill>
-                <a:latin typeface="Book Antiqua"/>
+                <a:latin typeface="Palatino Linotype"/>
               </a:rPr>
               <a:t>COURSE: Computação Natural</a:t>
             </a:r>
@@ -9187,11 +9187,11 @@
               </a:spcAft>
             </a:pPr>
             <a:r>
-              <a:rPr sz="1000" b="0" i="0">
+              <a:rPr sz="1100" b="0" i="0">
                 <a:solidFill>
                   <a:srgbClr val="203864"/>
                 </a:solidFill>
-                <a:latin typeface="Book Antiqua"/>
+                <a:latin typeface="Palatino Linotype"/>
               </a:rPr>
               <a:t>CLASS: Equipe 4  -  TOPIC: Otimizador Bioinspirado (Plano B)</a:t>
             </a:r>
@@ -9206,7 +9206,7 @@
         </p:nvSpPr>
         <p:spPr>
           <a:xfrm>
-            <a:off x="11323015" y="6364224"/>
+            <a:off x="11323015" y="6400800"/>
             <a:ext cx="548640" cy="274320"/>
           </a:xfrm>
           <a:prstGeom prst="rect">
@@ -9233,7 +9233,7 @@
                 <a:solidFill>
                   <a:srgbClr val="203864"/>
                 </a:solidFill>
-                <a:latin typeface="Book Antiqua"/>
+                <a:latin typeface="Palatino Linotype"/>
               </a:rPr>
               <a:t>2</a:t>
             </a:r>
@@ -9275,7 +9275,7 @@
                 <a:solidFill>
                   <a:srgbClr val="203864"/>
                 </a:solidFill>
-                <a:latin typeface="Book Antiqua"/>
+                <a:latin typeface="Palatino Linotype"/>
               </a:rPr>
               <a:t>Agenda</a:t>
             </a:r>
@@ -9407,7 +9407,7 @@
                 <a:solidFill>
                   <a:srgbClr val="41719C"/>
                 </a:solidFill>
-                <a:latin typeface="Book Antiqua"/>
+                <a:latin typeface="Palatino Linotype"/>
               </a:rPr>
               <a:t>01</a:t>
             </a:r>
@@ -9449,7 +9449,7 @@
                 <a:solidFill>
                   <a:srgbClr val="203864"/>
                 </a:solidFill>
-                <a:latin typeface="Book Antiqua"/>
+                <a:latin typeface="Palatino Linotype"/>
               </a:rPr>
               <a:t>De onde viemos</a:t>
             </a:r>
@@ -9468,7 +9468,7 @@
                 <a:solidFill>
                   <a:srgbClr val="595959"/>
                 </a:solidFill>
-                <a:latin typeface="Book Antiqua"/>
+                <a:latin typeface="Palatino Linotype"/>
               </a:rPr>
               <a:t>Trajetória em 3 fases e redução de escopo</a:t>
             </a:r>
@@ -9600,7 +9600,7 @@
                 <a:solidFill>
                   <a:srgbClr val="41719C"/>
                 </a:solidFill>
-                <a:latin typeface="Book Antiqua"/>
+                <a:latin typeface="Palatino Linotype"/>
               </a:rPr>
               <a:t>02</a:t>
             </a:r>
@@ -9642,7 +9642,7 @@
                 <a:solidFill>
                   <a:srgbClr val="203864"/>
                 </a:solidFill>
-                <a:latin typeface="Book Antiqua"/>
+                <a:latin typeface="Palatino Linotype"/>
               </a:rPr>
               <a:t>O Plano B e seu objetivo</a:t>
             </a:r>
@@ -9661,7 +9661,7 @@
                 <a:solidFill>
                   <a:srgbClr val="595959"/>
                 </a:solidFill>
-                <a:latin typeface="Book Antiqua"/>
+                <a:latin typeface="Palatino Linotype"/>
               </a:rPr>
               <a:t>Objetivo adaptado e a variável Wellness</a:t>
             </a:r>
@@ -9793,7 +9793,7 @@
                 <a:solidFill>
                   <a:srgbClr val="41719C"/>
                 </a:solidFill>
-                <a:latin typeface="Book Antiqua"/>
+                <a:latin typeface="Palatino Linotype"/>
               </a:rPr>
               <a:t>03</a:t>
             </a:r>
@@ -9835,7 +9835,7 @@
                 <a:solidFill>
                   <a:srgbClr val="203864"/>
                 </a:solidFill>
-                <a:latin typeface="Book Antiqua"/>
+                <a:latin typeface="Palatino Linotype"/>
               </a:rPr>
               <a:t>Como funciona</a:t>
             </a:r>
@@ -9854,7 +9854,7 @@
                 <a:solidFill>
                   <a:srgbClr val="595959"/>
                 </a:solidFill>
-                <a:latin typeface="Book Antiqua"/>
+                <a:latin typeface="Palatino Linotype"/>
               </a:rPr>
               <a:t>Passo a passo e por que PSO (enxame)</a:t>
             </a:r>
@@ -9986,7 +9986,7 @@
                 <a:solidFill>
                   <a:srgbClr val="41719C"/>
                 </a:solidFill>
-                <a:latin typeface="Book Antiqua"/>
+                <a:latin typeface="Palatino Linotype"/>
               </a:rPr>
               <a:t>04</a:t>
             </a:r>
@@ -10028,7 +10028,7 @@
                 <a:solidFill>
                   <a:srgbClr val="203864"/>
                 </a:solidFill>
-                <a:latin typeface="Book Antiqua"/>
+                <a:latin typeface="Palatino Linotype"/>
               </a:rPr>
               <a:t>Validação e ganho</a:t>
             </a:r>
@@ -10047,7 +10047,7 @@
                 <a:solidFill>
                   <a:srgbClr val="595959"/>
                 </a:solidFill>
-                <a:latin typeface="Book Antiqua"/>
+                <a:latin typeface="Palatino Linotype"/>
               </a:rPr>
               <a:t>O ótimo conhecido, o perfil ideal e o Meta-FSS</a:t>
             </a:r>
@@ -10179,7 +10179,7 @@
                 <a:solidFill>
                   <a:srgbClr val="41719C"/>
                 </a:solidFill>
-                <a:latin typeface="Book Antiqua"/>
+                <a:latin typeface="Palatino Linotype"/>
               </a:rPr>
               <a:t>05</a:t>
             </a:r>
@@ -10221,7 +10221,7 @@
                 <a:solidFill>
                   <a:srgbClr val="203864"/>
                 </a:solidFill>
-                <a:latin typeface="Book Antiqua"/>
+                <a:latin typeface="Palatino Linotype"/>
               </a:rPr>
               <a:t>Fechamento</a:t>
             </a:r>
@@ -10240,7 +10240,7 @@
                 <a:solidFill>
                   <a:srgbClr val="595959"/>
                 </a:solidFill>
-                <a:latin typeface="Book Antiqua"/>
+                <a:latin typeface="Palatino Linotype"/>
               </a:rPr>
               <a:t>BFSS de relance, limitações e próximos passos</a:t>
             </a:r>
@@ -10393,8 +10393,8 @@
         </p:blipFill>
         <p:spPr>
           <a:xfrm>
-            <a:off x="292608" y="6291072"/>
-            <a:ext cx="1065929" cy="548640"/>
+            <a:off x="292608" y="6355080"/>
+            <a:ext cx="1191126" cy="457200"/>
           </a:xfrm>
           <a:prstGeom prst="rect">
             <a:avLst/>
@@ -10409,8 +10409,8 @@
         </p:nvSpPr>
         <p:spPr>
           <a:xfrm>
-            <a:off x="1783080" y="6355080"/>
-            <a:ext cx="7498079" cy="457200"/>
+            <a:off x="1691640" y="6373368"/>
+            <a:ext cx="8229600" cy="457200"/>
           </a:xfrm>
           <a:prstGeom prst="rect">
             <a:avLst/>
@@ -10432,11 +10432,11 @@
               </a:spcAft>
             </a:pPr>
             <a:r>
-              <a:rPr sz="1000" b="0" i="0">
+              <a:rPr sz="1100" b="0" i="0">
                 <a:solidFill>
                   <a:srgbClr val="203864"/>
                 </a:solidFill>
-                <a:latin typeface="Book Antiqua"/>
+                <a:latin typeface="Palatino Linotype"/>
               </a:rPr>
               <a:t>COURSE: Computação Natural</a:t>
             </a:r>
@@ -10451,11 +10451,11 @@
               </a:spcAft>
             </a:pPr>
             <a:r>
-              <a:rPr sz="1000" b="0" i="0">
+              <a:rPr sz="1100" b="0" i="0">
                 <a:solidFill>
                   <a:srgbClr val="203864"/>
                 </a:solidFill>
-                <a:latin typeface="Book Antiqua"/>
+                <a:latin typeface="Palatino Linotype"/>
               </a:rPr>
               <a:t>CLASS: Equipe 4  -  TOPIC: Otimizador Bioinspirado (Plano B)</a:t>
             </a:r>
@@ -10470,7 +10470,7 @@
         </p:nvSpPr>
         <p:spPr>
           <a:xfrm>
-            <a:off x="11323015" y="6364224"/>
+            <a:off x="11323015" y="6400800"/>
             <a:ext cx="548640" cy="274320"/>
           </a:xfrm>
           <a:prstGeom prst="rect">
@@ -10497,7 +10497,7 @@
                 <a:solidFill>
                   <a:srgbClr val="203864"/>
                 </a:solidFill>
-                <a:latin typeface="Book Antiqua"/>
+                <a:latin typeface="Palatino Linotype"/>
               </a:rPr>
               <a:t>3</a:t>
             </a:r>
@@ -10539,7 +10539,7 @@
                 <a:solidFill>
                   <a:srgbClr val="203864"/>
                 </a:solidFill>
-                <a:latin typeface="Book Antiqua"/>
+                <a:latin typeface="Palatino Linotype"/>
               </a:rPr>
               <a:t>Síntese executiva</a:t>
             </a:r>
@@ -10671,7 +10671,7 @@
                 <a:solidFill>
                   <a:srgbClr val="203864"/>
                 </a:solidFill>
-                <a:latin typeface="Book Antiqua"/>
+                <a:latin typeface="Palatino Linotype"/>
               </a:rPr>
               <a:t>Contexto</a:t>
             </a:r>
@@ -10690,7 +10690,7 @@
                 <a:solidFill>
                   <a:srgbClr val="203864"/>
                 </a:solidFill>
-                <a:latin typeface="Book Antiqua"/>
+                <a:latin typeface="Arial"/>
               </a:rPr>
               <a:t>•  </a:t>
             </a:r>
@@ -10699,7 +10699,7 @@
                 <a:solidFill>
                   <a:srgbClr val="404040"/>
                 </a:solidFill>
-                <a:latin typeface="Book Antiqua"/>
+                <a:latin typeface="Palatino Linotype"/>
               </a:rPr>
               <a:t>Disciplina de Computação Natural.</a:t>
             </a:r>
@@ -10718,7 +10718,7 @@
                 <a:solidFill>
                   <a:srgbClr val="203864"/>
                 </a:solidFill>
-                <a:latin typeface="Book Antiqua"/>
+                <a:latin typeface="Arial"/>
               </a:rPr>
               <a:t>•  </a:t>
             </a:r>
@@ -10727,7 +10727,7 @@
                 <a:solidFill>
                   <a:srgbClr val="404040"/>
                 </a:solidFill>
-                <a:latin typeface="Book Antiqua"/>
+                <a:latin typeface="Palatino Linotype"/>
               </a:rPr>
               <a:t>Sistema REDS-PE (Rede de Atenção à Saúde).</a:t>
             </a:r>
@@ -10746,7 +10746,7 @@
                 <a:solidFill>
                   <a:srgbClr val="203864"/>
                 </a:solidFill>
-                <a:latin typeface="Book Antiqua"/>
+                <a:latin typeface="Arial"/>
               </a:rPr>
               <a:t>•  </a:t>
             </a:r>
@@ -10755,7 +10755,7 @@
                 <a:solidFill>
                   <a:srgbClr val="404040"/>
                 </a:solidFill>
-                <a:latin typeface="Book Antiqua"/>
+                <a:latin typeface="Palatino Linotype"/>
               </a:rPr>
               <a:t>Alvo: pacientes com diabetes em Pernambuco.</a:t>
             </a:r>
@@ -10774,7 +10774,7 @@
                 <a:solidFill>
                   <a:srgbClr val="203864"/>
                 </a:solidFill>
-                <a:latin typeface="Book Antiqua"/>
+                <a:latin typeface="Arial"/>
               </a:rPr>
               <a:t>•  </a:t>
             </a:r>
@@ -10783,7 +10783,7 @@
                 <a:solidFill>
                   <a:srgbClr val="404040"/>
                 </a:solidFill>
-                <a:latin typeface="Book Antiqua"/>
+                <a:latin typeface="Palatino Linotype"/>
               </a:rPr>
               <a:t>Financiamento: SUS / políticas públicas.</a:t>
             </a:r>
@@ -10915,7 +10915,7 @@
                 <a:solidFill>
                   <a:srgbClr val="203864"/>
                 </a:solidFill>
-                <a:latin typeface="Book Antiqua"/>
+                <a:latin typeface="Palatino Linotype"/>
               </a:rPr>
               <a:t>Proposta</a:t>
             </a:r>
@@ -10934,7 +10934,7 @@
                 <a:solidFill>
                   <a:srgbClr val="203864"/>
                 </a:solidFill>
-                <a:latin typeface="Book Antiqua"/>
+                <a:latin typeface="Arial"/>
               </a:rPr>
               <a:t>•  </a:t>
             </a:r>
@@ -10943,7 +10943,7 @@
                 <a:solidFill>
                   <a:srgbClr val="404040"/>
                 </a:solidFill>
-                <a:latin typeface="Book Antiqua"/>
+                <a:latin typeface="Palatino Linotype"/>
               </a:rPr>
               <a:t>Usar Inteligência de Enxames (PSO).</a:t>
             </a:r>
@@ -10962,7 +10962,7 @@
                 <a:solidFill>
                   <a:srgbClr val="203864"/>
                 </a:solidFill>
-                <a:latin typeface="Book Antiqua"/>
+                <a:latin typeface="Arial"/>
               </a:rPr>
               <a:t>•  </a:t>
             </a:r>
@@ -10971,7 +10971,7 @@
                 <a:solidFill>
                   <a:srgbClr val="404040"/>
                 </a:solidFill>
-                <a:latin typeface="Book Antiqua"/>
+                <a:latin typeface="Palatino Linotype"/>
               </a:rPr>
               <a:t>Achar o perfil do 'indivíduo ideal' entre diabéticos.</a:t>
             </a:r>
@@ -10990,7 +10990,7 @@
                 <a:solidFill>
                   <a:srgbClr val="203864"/>
                 </a:solidFill>
-                <a:latin typeface="Book Antiqua"/>
+                <a:latin typeface="Arial"/>
               </a:rPr>
               <a:t>•  </a:t>
             </a:r>
@@ -10999,7 +10999,7 @@
                 <a:solidFill>
                   <a:srgbClr val="404040"/>
                 </a:solidFill>
-                <a:latin typeface="Book Antiqua"/>
+                <a:latin typeface="Palatino Linotype"/>
               </a:rPr>
               <a:t>Horizonte: otimizar a alocação de recursos maximizando HLY.</a:t>
             </a:r>
@@ -11131,7 +11131,7 @@
                 <a:solidFill>
                   <a:srgbClr val="2E6B4F"/>
                 </a:solidFill>
-                <a:latin typeface="Book Antiqua"/>
+                <a:latin typeface="Palatino Linotype"/>
               </a:rPr>
               <a:t>Resultado</a:t>
             </a:r>
@@ -11150,7 +11150,7 @@
                 <a:solidFill>
                   <a:srgbClr val="2E6B4F"/>
                 </a:solidFill>
-                <a:latin typeface="Book Antiqua"/>
+                <a:latin typeface="Arial"/>
               </a:rPr>
               <a:t>•  </a:t>
             </a:r>
@@ -11159,7 +11159,7 @@
                 <a:solidFill>
                   <a:srgbClr val="404040"/>
                 </a:solidFill>
-                <a:latin typeface="Book Antiqua"/>
+                <a:latin typeface="Palatino Linotype"/>
               </a:rPr>
               <a:t>PSO implementado do zero (NumPy).</a:t>
             </a:r>
@@ -11178,7 +11178,7 @@
                 <a:solidFill>
                   <a:srgbClr val="2E6B4F"/>
                 </a:solidFill>
-                <a:latin typeface="Book Antiqua"/>
+                <a:latin typeface="Arial"/>
               </a:rPr>
               <a:t>•  </a:t>
             </a:r>
@@ -11187,7 +11187,7 @@
                 <a:solidFill>
                   <a:srgbClr val="404040"/>
                 </a:solidFill>
-                <a:latin typeface="Book Antiqua"/>
+                <a:latin typeface="Palatino Linotype"/>
               </a:rPr>
               <a:t>Validado contra a solução analítica: cosseno = 1,000.</a:t>
             </a:r>
@@ -11206,7 +11206,7 @@
                 <a:solidFill>
                   <a:srgbClr val="2E6B4F"/>
                 </a:solidFill>
-                <a:latin typeface="Book Antiqua"/>
+                <a:latin typeface="Arial"/>
               </a:rPr>
               <a:t>•  </a:t>
             </a:r>
@@ -11215,7 +11215,7 @@
                 <a:solidFill>
                   <a:srgbClr val="404040"/>
                 </a:solidFill>
-                <a:latin typeface="Book Antiqua"/>
+                <a:latin typeface="Palatino Linotype"/>
               </a:rPr>
               <a:t>Perfil clínico interpretável extraído dos pesos.</a:t>
             </a:r>
@@ -11368,8 +11368,8 @@
         </p:blipFill>
         <p:spPr>
           <a:xfrm>
-            <a:off x="292608" y="6291072"/>
-            <a:ext cx="1065929" cy="548640"/>
+            <a:off x="292608" y="6355080"/>
+            <a:ext cx="1191126" cy="457200"/>
           </a:xfrm>
           <a:prstGeom prst="rect">
             <a:avLst/>
@@ -11384,8 +11384,8 @@
         </p:nvSpPr>
         <p:spPr>
           <a:xfrm>
-            <a:off x="1783080" y="6355080"/>
-            <a:ext cx="7498079" cy="457200"/>
+            <a:off x="1691640" y="6373368"/>
+            <a:ext cx="8229600" cy="457200"/>
           </a:xfrm>
           <a:prstGeom prst="rect">
             <a:avLst/>
@@ -11407,11 +11407,11 @@
               </a:spcAft>
             </a:pPr>
             <a:r>
-              <a:rPr sz="1000" b="0" i="0">
+              <a:rPr sz="1100" b="0" i="0">
                 <a:solidFill>
                   <a:srgbClr val="203864"/>
                 </a:solidFill>
-                <a:latin typeface="Book Antiqua"/>
+                <a:latin typeface="Palatino Linotype"/>
               </a:rPr>
               <a:t>COURSE: Computação Natural</a:t>
             </a:r>
@@ -11426,11 +11426,11 @@
               </a:spcAft>
             </a:pPr>
             <a:r>
-              <a:rPr sz="1000" b="0" i="0">
+              <a:rPr sz="1100" b="0" i="0">
                 <a:solidFill>
                   <a:srgbClr val="203864"/>
                 </a:solidFill>
-                <a:latin typeface="Book Antiqua"/>
+                <a:latin typeface="Palatino Linotype"/>
               </a:rPr>
               <a:t>CLASS: Equipe 4  -  TOPIC: Otimizador Bioinspirado (Plano B)</a:t>
             </a:r>
@@ -11445,7 +11445,7 @@
         </p:nvSpPr>
         <p:spPr>
           <a:xfrm>
-            <a:off x="11323015" y="6364224"/>
+            <a:off x="11323015" y="6400800"/>
             <a:ext cx="548640" cy="274320"/>
           </a:xfrm>
           <a:prstGeom prst="rect">
@@ -11472,7 +11472,7 @@
                 <a:solidFill>
                   <a:srgbClr val="203864"/>
                 </a:solidFill>
-                <a:latin typeface="Book Antiqua"/>
+                <a:latin typeface="Palatino Linotype"/>
               </a:rPr>
               <a:t>4</a:t>
             </a:r>
@@ -11514,7 +11514,7 @@
                 <a:solidFill>
                   <a:srgbClr val="203864"/>
                 </a:solidFill>
-                <a:latin typeface="Book Antiqua"/>
+                <a:latin typeface="Palatino Linotype"/>
               </a:rPr>
               <a:t>Trajetória em três fases</a:t>
             </a:r>
@@ -11556,7 +11556,7 @@
                 <a:solidFill>
                   <a:srgbClr val="595959"/>
                 </a:solidFill>
-                <a:latin typeface="Book Antiqua"/>
+                <a:latin typeface="Palatino Linotype"/>
               </a:rPr>
               <a:t>A redução de escopo foi decisão técnica, não recuo.</a:t>
             </a:r>
@@ -11776,7 +11776,7 @@
                 <a:solidFill>
                   <a:srgbClr val="595959"/>
                 </a:solidFill>
-                <a:latin typeface="Book Antiqua"/>
+                <a:latin typeface="Palatino Linotype"/>
               </a:rPr>
               <a:t>FASE 1</a:t>
             </a:r>
@@ -11795,7 +11795,7 @@
                 <a:solidFill>
                   <a:srgbClr val="203864"/>
                 </a:solidFill>
-                <a:latin typeface="Book Antiqua"/>
+                <a:latin typeface="Palatino Linotype"/>
               </a:rPr>
               <a:t>130-US + CTGAN</a:t>
             </a:r>
@@ -11814,7 +11814,7 @@
                 <a:solidFill>
                   <a:srgbClr val="9A9A9A"/>
                 </a:solidFill>
-                <a:latin typeface="Book Antiqua"/>
+                <a:latin typeface="Palatino Linotype"/>
               </a:rPr>
               <a:t>ABANDONADA</a:t>
             </a:r>
@@ -11833,7 +11833,7 @@
                 <a:solidFill>
                   <a:srgbClr val="9A9A9A"/>
                 </a:solidFill>
-                <a:latin typeface="Book Antiqua"/>
+                <a:latin typeface="Arial"/>
               </a:rPr>
               <a:t>•  </a:t>
             </a:r>
@@ -11842,7 +11842,7 @@
                 <a:solidFill>
                   <a:srgbClr val="404040"/>
                 </a:solidFill>
-                <a:latin typeface="Book Antiqua"/>
+                <a:latin typeface="Palatino Linotype"/>
               </a:rPr>
               <a:t>População errada (97% DM2)</a:t>
             </a:r>
@@ -11861,7 +11861,7 @@
                 <a:solidFill>
                   <a:srgbClr val="9A9A9A"/>
                 </a:solidFill>
-                <a:latin typeface="Book Antiqua"/>
+                <a:latin typeface="Arial"/>
               </a:rPr>
               <a:t>•  </a:t>
             </a:r>
@@ -11870,7 +11870,7 @@
                 <a:solidFill>
                   <a:srgbClr val="404040"/>
                 </a:solidFill>
-                <a:latin typeface="Book Antiqua"/>
+                <a:latin typeface="Palatino Linotype"/>
               </a:rPr>
               <a:t>Sem eixo temporal</a:t>
             </a:r>
@@ -11889,7 +11889,7 @@
                 <a:solidFill>
                   <a:srgbClr val="9A9A9A"/>
                 </a:solidFill>
-                <a:latin typeface="Book Antiqua"/>
+                <a:latin typeface="Arial"/>
               </a:rPr>
               <a:t>•  </a:t>
             </a:r>
@@ -11898,7 +11898,7 @@
                 <a:solidFill>
                   <a:srgbClr val="404040"/>
                 </a:solidFill>
-                <a:latin typeface="Book Antiqua"/>
+                <a:latin typeface="Palatino Linotype"/>
               </a:rPr>
               <a:t>Sem gabarito de validação</a:t>
             </a:r>
@@ -12074,7 +12074,7 @@
                 <a:solidFill>
                   <a:srgbClr val="595959"/>
                 </a:solidFill>
-                <a:latin typeface="Book Antiqua"/>
+                <a:latin typeface="Palatino Linotype"/>
               </a:rPr>
               <a:t>FASE 2</a:t>
             </a:r>
@@ -12093,7 +12093,7 @@
                 <a:solidFill>
                   <a:srgbClr val="203864"/>
                 </a:solidFill>
-                <a:latin typeface="Book Antiqua"/>
+                <a:latin typeface="Palatino Linotype"/>
               </a:rPr>
               <a:t>Marcadores plantados</a:t>
             </a:r>
@@ -12112,7 +12112,7 @@
                 <a:solidFill>
                   <a:srgbClr val="B07A2A"/>
                 </a:solidFill>
-                <a:latin typeface="Book Antiqua"/>
+                <a:latin typeface="Palatino Linotype"/>
               </a:rPr>
               <a:t>PAUSADA</a:t>
             </a:r>
@@ -12131,7 +12131,7 @@
                 <a:solidFill>
                   <a:srgbClr val="B07A2A"/>
                 </a:solidFill>
-                <a:latin typeface="Book Antiqua"/>
+                <a:latin typeface="Arial"/>
               </a:rPr>
               <a:t>•  </a:t>
             </a:r>
@@ -12140,7 +12140,7 @@
                 <a:solidFill>
                   <a:srgbClr val="404040"/>
                 </a:solidFill>
-                <a:latin typeface="Book Antiqua"/>
+                <a:latin typeface="Palatino Linotype"/>
               </a:rPr>
               <a:t>Base sintética com gabarito</a:t>
             </a:r>
@@ -12159,7 +12159,7 @@
                 <a:solidFill>
                   <a:srgbClr val="B07A2A"/>
                 </a:solidFill>
-                <a:latin typeface="Book Antiqua"/>
+                <a:latin typeface="Arial"/>
               </a:rPr>
               <a:t>•  </a:t>
             </a:r>
@@ -12168,7 +12168,7 @@
                 <a:solidFill>
                   <a:srgbClr val="404040"/>
                 </a:solidFill>
-                <a:latin typeface="Book Antiqua"/>
+                <a:latin typeface="Palatino Linotype"/>
               </a:rPr>
               <a:t>Prova algorítmica do otimizador</a:t>
             </a:r>
@@ -12187,7 +12187,7 @@
                 <a:solidFill>
                   <a:srgbClr val="B07A2A"/>
                 </a:solidFill>
-                <a:latin typeface="Book Antiqua"/>
+                <a:latin typeface="Arial"/>
               </a:rPr>
               <a:t>•  </a:t>
             </a:r>
@@ -12196,7 +12196,7 @@
                 <a:solidFill>
                   <a:srgbClr val="404040"/>
                 </a:solidFill>
-                <a:latin typeface="Book Antiqua"/>
+                <a:latin typeface="Palatino Linotype"/>
               </a:rPr>
               <a:t>BFSS validado aqui</a:t>
             </a:r>
@@ -12372,7 +12372,7 @@
                 <a:solidFill>
                   <a:srgbClr val="595959"/>
                 </a:solidFill>
-                <a:latin typeface="Book Antiqua"/>
+                <a:latin typeface="Palatino Linotype"/>
               </a:rPr>
               <a:t>FASE 3</a:t>
             </a:r>
@@ -12391,7 +12391,7 @@
                 <a:solidFill>
                   <a:srgbClr val="203864"/>
                 </a:solidFill>
-                <a:latin typeface="Book Antiqua"/>
+                <a:latin typeface="Palatino Linotype"/>
               </a:rPr>
               <a:t>Plano B — PSO / coorte bimodal</a:t>
             </a:r>
@@ -12410,7 +12410,7 @@
                 <a:solidFill>
                   <a:srgbClr val="2E6B4F"/>
                 </a:solidFill>
-                <a:latin typeface="Book Antiqua"/>
+                <a:latin typeface="Palatino Linotype"/>
               </a:rPr>
               <a:t>ENTREGUE</a:t>
             </a:r>
@@ -12429,7 +12429,7 @@
                 <a:solidFill>
                   <a:srgbClr val="2E6B4F"/>
                 </a:solidFill>
-                <a:latin typeface="Book Antiqua"/>
+                <a:latin typeface="Arial"/>
               </a:rPr>
               <a:t>•  </a:t>
             </a:r>
@@ -12438,7 +12438,7 @@
                 <a:solidFill>
                   <a:srgbClr val="404040"/>
                 </a:solidFill>
-                <a:latin typeface="Book Antiqua"/>
+                <a:latin typeface="Palatino Linotype"/>
               </a:rPr>
               <a:t>Foco da apresentação de hoje</a:t>
             </a:r>
@@ -12457,7 +12457,7 @@
                 <a:solidFill>
                   <a:srgbClr val="2E6B4F"/>
                 </a:solidFill>
-                <a:latin typeface="Book Antiqua"/>
+                <a:latin typeface="Arial"/>
               </a:rPr>
               <a:t>•  </a:t>
             </a:r>
@@ -12466,7 +12466,7 @@
                 <a:solidFill>
                   <a:srgbClr val="404040"/>
                 </a:solidFill>
-                <a:latin typeface="Book Antiqua"/>
+                <a:latin typeface="Palatino Linotype"/>
               </a:rPr>
               <a:t>PSO validado (cosseno 1,000)</a:t>
             </a:r>
@@ -12485,7 +12485,7 @@
                 <a:solidFill>
                   <a:srgbClr val="2E6B4F"/>
                 </a:solidFill>
-                <a:latin typeface="Book Antiqua"/>
+                <a:latin typeface="Arial"/>
               </a:rPr>
               <a:t>•  </a:t>
             </a:r>
@@ -12494,7 +12494,7 @@
                 <a:solidFill>
                   <a:srgbClr val="404040"/>
                 </a:solidFill>
-                <a:latin typeface="Book Antiqua"/>
+                <a:latin typeface="Palatino Linotype"/>
               </a:rPr>
               <a:t>Perfil ideal interpretável</a:t>
             </a:r>
@@ -12647,8 +12647,8 @@
         </p:blipFill>
         <p:spPr>
           <a:xfrm>
-            <a:off x="292608" y="6291072"/>
-            <a:ext cx="1065929" cy="548640"/>
+            <a:off x="292608" y="6355080"/>
+            <a:ext cx="1191126" cy="457200"/>
           </a:xfrm>
           <a:prstGeom prst="rect">
             <a:avLst/>
@@ -12663,8 +12663,8 @@
         </p:nvSpPr>
         <p:spPr>
           <a:xfrm>
-            <a:off x="1783080" y="6355080"/>
-            <a:ext cx="7498079" cy="457200"/>
+            <a:off x="1691640" y="6373368"/>
+            <a:ext cx="8229600" cy="457200"/>
           </a:xfrm>
           <a:prstGeom prst="rect">
             <a:avLst/>
@@ -12686,11 +12686,11 @@
               </a:spcAft>
             </a:pPr>
             <a:r>
-              <a:rPr sz="1000" b="0" i="0">
+              <a:rPr sz="1100" b="0" i="0">
                 <a:solidFill>
                   <a:srgbClr val="203864"/>
                 </a:solidFill>
-                <a:latin typeface="Book Antiqua"/>
+                <a:latin typeface="Palatino Linotype"/>
               </a:rPr>
               <a:t>COURSE: Computação Natural</a:t>
             </a:r>
@@ -12705,11 +12705,11 @@
               </a:spcAft>
             </a:pPr>
             <a:r>
-              <a:rPr sz="1000" b="0" i="0">
+              <a:rPr sz="1100" b="0" i="0">
                 <a:solidFill>
                   <a:srgbClr val="203864"/>
                 </a:solidFill>
-                <a:latin typeface="Book Antiqua"/>
+                <a:latin typeface="Palatino Linotype"/>
               </a:rPr>
               <a:t>CLASS: Equipe 4  -  TOPIC: Otimizador Bioinspirado (Plano B)</a:t>
             </a:r>
@@ -12724,7 +12724,7 @@
         </p:nvSpPr>
         <p:spPr>
           <a:xfrm>
-            <a:off x="11323015" y="6364224"/>
+            <a:off x="11323015" y="6400800"/>
             <a:ext cx="548640" cy="274320"/>
           </a:xfrm>
           <a:prstGeom prst="rect">
@@ -12751,7 +12751,7 @@
                 <a:solidFill>
                   <a:srgbClr val="203864"/>
                 </a:solidFill>
-                <a:latin typeface="Book Antiqua"/>
+                <a:latin typeface="Palatino Linotype"/>
               </a:rPr>
               <a:t>5</a:t>
             </a:r>
@@ -12793,7 +12793,7 @@
                 <a:solidFill>
                   <a:srgbClr val="203864"/>
                 </a:solidFill>
-                <a:latin typeface="Book Antiqua"/>
+                <a:latin typeface="Palatino Linotype"/>
               </a:rPr>
               <a:t>Redução de escopo — status de cada componente</a:t>
             </a:r>
@@ -12925,7 +12925,7 @@
                 <a:solidFill>
                   <a:srgbClr val="404040"/>
                 </a:solidFill>
-                <a:latin typeface="Book Antiqua"/>
+                <a:latin typeface="Palatino Linotype"/>
               </a:rPr>
               <a:t>130-US + CTGAN</a:t>
             </a:r>
@@ -13011,7 +13011,7 @@
                 <a:solidFill>
                   <a:srgbClr val="9A9A9A"/>
                 </a:solidFill>
-                <a:latin typeface="Book Antiqua"/>
+                <a:latin typeface="Palatino Linotype"/>
               </a:rPr>
               <a:t>ABANDONADO</a:t>
             </a:r>
@@ -13143,7 +13143,7 @@
                 <a:solidFill>
                   <a:srgbClr val="203864"/>
                 </a:solidFill>
-                <a:latin typeface="Book Antiqua"/>
+                <a:latin typeface="Palatino Linotype"/>
               </a:rPr>
               <a:t>PSO sobre coorte bimodal (Plano B)</a:t>
             </a:r>
@@ -13229,7 +13229,7 @@
                 <a:solidFill>
                   <a:srgbClr val="2E6B4F"/>
                 </a:solidFill>
-                <a:latin typeface="Book Antiqua"/>
+                <a:latin typeface="Palatino Linotype"/>
               </a:rPr>
               <a:t>ENTREGUE</a:t>
             </a:r>
@@ -13361,7 +13361,7 @@
                 <a:solidFill>
                   <a:srgbClr val="404040"/>
                 </a:solidFill>
-                <a:latin typeface="Book Antiqua"/>
+                <a:latin typeface="Palatino Linotype"/>
               </a:rPr>
               <a:t>Meta-FSS (hiperparâmetros do PSO)</a:t>
             </a:r>
@@ -13447,7 +13447,7 @@
                 <a:solidFill>
                   <a:srgbClr val="2E6B4F"/>
                 </a:solidFill>
-                <a:latin typeface="Book Antiqua"/>
+                <a:latin typeface="Palatino Linotype"/>
               </a:rPr>
               <a:t>ENTREGUE</a:t>
             </a:r>
@@ -13579,7 +13579,7 @@
                 <a:solidFill>
                   <a:srgbClr val="404040"/>
                 </a:solidFill>
-                <a:latin typeface="Book Antiqua"/>
+                <a:latin typeface="Palatino Linotype"/>
               </a:rPr>
               <a:t>Visualização HTML do PSO (3 abas)</a:t>
             </a:r>
@@ -13665,7 +13665,7 @@
                 <a:solidFill>
                   <a:srgbClr val="2E6B4F"/>
                 </a:solidFill>
-                <a:latin typeface="Book Antiqua"/>
+                <a:latin typeface="Palatino Linotype"/>
               </a:rPr>
               <a:t>ENTREGUE</a:t>
             </a:r>
@@ -13797,7 +13797,7 @@
                 <a:solidFill>
                   <a:srgbClr val="404040"/>
                 </a:solidFill>
-                <a:latin typeface="Book Antiqua"/>
+                <a:latin typeface="Palatino Linotype"/>
               </a:rPr>
               <a:t>Banco sintético de marcadores</a:t>
             </a:r>
@@ -13883,7 +13883,7 @@
                 <a:solidFill>
                   <a:srgbClr val="2E6B4F"/>
                 </a:solidFill>
-                <a:latin typeface="Book Antiqua"/>
+                <a:latin typeface="Palatino Linotype"/>
               </a:rPr>
               <a:t>CONCLUÍDO</a:t>
             </a:r>
@@ -14015,7 +14015,7 @@
                 <a:solidFill>
                   <a:srgbClr val="404040"/>
                 </a:solidFill>
-                <a:latin typeface="Book Antiqua"/>
+                <a:latin typeface="Palatino Linotype"/>
               </a:rPr>
               <a:t>BFSS (seleção de variáveis)</a:t>
             </a:r>
@@ -14101,7 +14101,7 @@
                 <a:solidFill>
                   <a:srgbClr val="2E6B4F"/>
                 </a:solidFill>
-                <a:latin typeface="Book Antiqua"/>
+                <a:latin typeface="Palatino Linotype"/>
               </a:rPr>
               <a:t>VALIDADO</a:t>
             </a:r>
@@ -14233,7 +14233,7 @@
                 <a:solidFill>
                   <a:srgbClr val="404040"/>
                 </a:solidFill>
-                <a:latin typeface="Book Antiqua"/>
+                <a:latin typeface="Palatino Linotype"/>
               </a:rPr>
               <a:t>MOPSO + NSGA-II (frente de Pareto)</a:t>
             </a:r>
@@ -14319,7 +14319,7 @@
                 <a:solidFill>
                   <a:srgbClr val="B07A2A"/>
                 </a:solidFill>
-                <a:latin typeface="Book Antiqua"/>
+                <a:latin typeface="Palatino Linotype"/>
               </a:rPr>
               <a:t>PLANEJADO</a:t>
             </a:r>
@@ -14472,8 +14472,8 @@
         </p:blipFill>
         <p:spPr>
           <a:xfrm>
-            <a:off x="292608" y="6291072"/>
-            <a:ext cx="1065929" cy="548640"/>
+            <a:off x="292608" y="6355080"/>
+            <a:ext cx="1191126" cy="457200"/>
           </a:xfrm>
           <a:prstGeom prst="rect">
             <a:avLst/>
@@ -14488,8 +14488,8 @@
         </p:nvSpPr>
         <p:spPr>
           <a:xfrm>
-            <a:off x="1783080" y="6355080"/>
-            <a:ext cx="7498079" cy="457200"/>
+            <a:off x="1691640" y="6373368"/>
+            <a:ext cx="8229600" cy="457200"/>
           </a:xfrm>
           <a:prstGeom prst="rect">
             <a:avLst/>
@@ -14511,11 +14511,11 @@
               </a:spcAft>
             </a:pPr>
             <a:r>
-              <a:rPr sz="1000" b="0" i="0">
+              <a:rPr sz="1100" b="0" i="0">
                 <a:solidFill>
                   <a:srgbClr val="203864"/>
                 </a:solidFill>
-                <a:latin typeface="Book Antiqua"/>
+                <a:latin typeface="Palatino Linotype"/>
               </a:rPr>
               <a:t>COURSE: Computação Natural</a:t>
             </a:r>
@@ -14530,11 +14530,11 @@
               </a:spcAft>
             </a:pPr>
             <a:r>
-              <a:rPr sz="1000" b="0" i="0">
+              <a:rPr sz="1100" b="0" i="0">
                 <a:solidFill>
                   <a:srgbClr val="203864"/>
                 </a:solidFill>
-                <a:latin typeface="Book Antiqua"/>
+                <a:latin typeface="Palatino Linotype"/>
               </a:rPr>
               <a:t>CLASS: Equipe 4  -  TOPIC: Otimizador Bioinspirado (Plano B)</a:t>
             </a:r>
@@ -14549,7 +14549,7 @@
         </p:nvSpPr>
         <p:spPr>
           <a:xfrm>
-            <a:off x="11323015" y="6364224"/>
+            <a:off x="11323015" y="6400800"/>
             <a:ext cx="548640" cy="274320"/>
           </a:xfrm>
           <a:prstGeom prst="rect">
@@ -14576,7 +14576,7 @@
                 <a:solidFill>
                   <a:srgbClr val="203864"/>
                 </a:solidFill>
-                <a:latin typeface="Book Antiqua"/>
+                <a:latin typeface="Palatino Linotype"/>
               </a:rPr>
               <a:t>6</a:t>
             </a:r>
@@ -14618,7 +14618,7 @@
                 <a:solidFill>
                   <a:srgbClr val="203864"/>
                 </a:solidFill>
-                <a:latin typeface="Book Antiqua"/>
+                <a:latin typeface="Palatino Linotype"/>
               </a:rPr>
               <a:t>Objetivo: original  →  adaptado</a:t>
             </a:r>
@@ -14750,7 +14750,7 @@
                 <a:solidFill>
                   <a:srgbClr val="595959"/>
                 </a:solidFill>
-                <a:latin typeface="Book Antiqua"/>
+                <a:latin typeface="Palatino Linotype"/>
               </a:rPr>
               <a:t>ORIGINAL — PLANO A</a:t>
             </a:r>
@@ -14769,7 +14769,7 @@
                 <a:solidFill>
                   <a:srgbClr val="203864"/>
                 </a:solidFill>
-                <a:latin typeface="Book Antiqua"/>
+                <a:latin typeface="Palatino Linotype"/>
               </a:rPr>
               <a:t>Otimizador multiobjetivo completo</a:t>
             </a:r>
@@ -14788,7 +14788,7 @@
                 <a:solidFill>
                   <a:srgbClr val="9A9A9A"/>
                 </a:solidFill>
-                <a:latin typeface="Book Antiqua"/>
+                <a:latin typeface="Arial"/>
               </a:rPr>
               <a:t>•  </a:t>
             </a:r>
@@ -14797,7 +14797,7 @@
                 <a:solidFill>
                   <a:srgbClr val="404040"/>
                 </a:solidFill>
-                <a:latin typeface="Book Antiqua"/>
+                <a:latin typeface="Palatino Linotype"/>
               </a:rPr>
               <a:t>Três objetivos concorrentes (frente de Pareto):</a:t>
             </a:r>
@@ -14816,7 +14816,7 @@
                 <a:solidFill>
                   <a:srgbClr val="9A9A9A"/>
                 </a:solidFill>
-                <a:latin typeface="Book Antiqua"/>
+                <a:latin typeface="Arial"/>
               </a:rPr>
               <a:t>•  </a:t>
             </a:r>
@@ -14825,7 +14825,7 @@
                 <a:solidFill>
                   <a:srgbClr val="404040"/>
                 </a:solidFill>
-                <a:latin typeface="Book Antiqua"/>
+                <a:latin typeface="Palatino Linotype"/>
               </a:rPr>
               <a:t>Maximizar HLY (Anos de Vida Saudáveis).</a:t>
             </a:r>
@@ -14844,7 +14844,7 @@
                 <a:solidFill>
                   <a:srgbClr val="9A9A9A"/>
                 </a:solidFill>
-                <a:latin typeface="Book Antiqua"/>
+                <a:latin typeface="Arial"/>
               </a:rPr>
               <a:t>•  </a:t>
             </a:r>
@@ -14853,7 +14853,7 @@
                 <a:solidFill>
                   <a:srgbClr val="404040"/>
                 </a:solidFill>
-                <a:latin typeface="Book Antiqua"/>
+                <a:latin typeface="Palatino Linotype"/>
               </a:rPr>
               <a:t>Minimizar o custo da política pública.</a:t>
             </a:r>
@@ -14872,7 +14872,7 @@
                 <a:solidFill>
                   <a:srgbClr val="9A9A9A"/>
                 </a:solidFill>
-                <a:latin typeface="Book Antiqua"/>
+                <a:latin typeface="Arial"/>
               </a:rPr>
               <a:t>•  </a:t>
             </a:r>
@@ -14881,7 +14881,7 @@
                 <a:solidFill>
                   <a:srgbClr val="404040"/>
                 </a:solidFill>
-                <a:latin typeface="Book Antiqua"/>
+                <a:latin typeface="Palatino Linotype"/>
               </a:rPr>
               <a:t>Maximizar a equidade regional entre municípios.</a:t>
             </a:r>
@@ -14900,7 +14900,7 @@
                 <a:solidFill>
                   <a:srgbClr val="9A9A9A"/>
                 </a:solidFill>
-                <a:latin typeface="Book Antiqua"/>
+                <a:latin typeface="Arial"/>
               </a:rPr>
               <a:t>•  </a:t>
             </a:r>
@@ -14909,7 +14909,7 @@
                 <a:solidFill>
                   <a:srgbClr val="404040"/>
                 </a:solidFill>
-                <a:latin typeface="Book Antiqua"/>
+                <a:latin typeface="Palatino Linotype"/>
               </a:rPr>
               <a:t>Baselines: MOPSO + NSGA-II.</a:t>
             </a:r>
@@ -14951,7 +14951,7 @@
                 <a:solidFill>
                   <a:srgbClr val="41719C"/>
                 </a:solidFill>
-                <a:latin typeface="Book Antiqua"/>
+                <a:latin typeface="Palatino Linotype"/>
               </a:rPr>
               <a:t>→</a:t>
             </a:r>
@@ -15083,7 +15083,7 @@
                 <a:solidFill>
                   <a:srgbClr val="203864"/>
                 </a:solidFill>
-                <a:latin typeface="Book Antiqua"/>
+                <a:latin typeface="Palatino Linotype"/>
               </a:rPr>
               <a:t>ADAPTADO — PLANO B  (entregável real)</a:t>
             </a:r>
@@ -15102,7 +15102,7 @@
                 <a:solidFill>
                   <a:srgbClr val="203864"/>
                 </a:solidFill>
-                <a:latin typeface="Book Antiqua"/>
+                <a:latin typeface="Palatino Linotype"/>
               </a:rPr>
               <a:t>PSO acha o perfil do indivíduo ideal</a:t>
             </a:r>
@@ -15121,7 +15121,7 @@
                 <a:solidFill>
                   <a:srgbClr val="203864"/>
                 </a:solidFill>
-                <a:latin typeface="Book Antiqua"/>
+                <a:latin typeface="Arial"/>
               </a:rPr>
               <a:t>•  </a:t>
             </a:r>
@@ -15130,7 +15130,7 @@
                 <a:solidFill>
                   <a:srgbClr val="404040"/>
                 </a:solidFill>
-                <a:latin typeface="Book Antiqua"/>
+                <a:latin typeface="Palatino Linotype"/>
               </a:rPr>
               <a:t>PSO otimiza os pesos de uma regressão logística.</a:t>
             </a:r>
@@ -15149,7 +15149,7 @@
                 <a:solidFill>
                   <a:srgbClr val="203864"/>
                 </a:solidFill>
-                <a:latin typeface="Book Antiqua"/>
+                <a:latin typeface="Arial"/>
               </a:rPr>
               <a:t>•  </a:t>
             </a:r>
@@ -15158,7 +15158,7 @@
                 <a:solidFill>
                   <a:srgbClr val="404040"/>
                 </a:solidFill>
-                <a:latin typeface="Book Antiqua"/>
+                <a:latin typeface="Palatino Linotype"/>
               </a:rPr>
               <a:t>Variável-alvo: Wellness (proxy de HLY).</a:t>
             </a:r>
@@ -15177,7 +15177,7 @@
                 <a:solidFill>
                   <a:srgbClr val="203864"/>
                 </a:solidFill>
-                <a:latin typeface="Book Antiqua"/>
+                <a:latin typeface="Arial"/>
               </a:rPr>
               <a:t>•  </a:t>
             </a:r>
@@ -15186,7 +15186,7 @@
                 <a:solidFill>
                   <a:srgbClr val="404040"/>
                 </a:solidFill>
-                <a:latin typeface="Book Antiqua"/>
+                <a:latin typeface="Palatino Linotype"/>
               </a:rPr>
               <a:t>Validar contra a solução analítica do scikit-learn.</a:t>
             </a:r>
@@ -15205,7 +15205,7 @@
                 <a:solidFill>
                   <a:srgbClr val="203864"/>
                 </a:solidFill>
-                <a:latin typeface="Book Antiqua"/>
+                <a:latin typeface="Arial"/>
               </a:rPr>
               <a:t>•  </a:t>
             </a:r>
@@ -15214,7 +15214,7 @@
                 <a:solidFill>
                   <a:srgbClr val="404040"/>
                 </a:solidFill>
-                <a:latin typeface="Book Antiqua"/>
+                <a:latin typeface="Palatino Linotype"/>
               </a:rPr>
               <a:t>Extrair o perfil clínico interpretável dos pesos.</a:t>
             </a:r>
@@ -15256,7 +15256,7 @@
                 <a:solidFill>
                   <a:srgbClr val="595959"/>
                 </a:solidFill>
-                <a:latin typeface="Book Antiqua"/>
+                <a:latin typeface="Palatino Linotype"/>
               </a:rPr>
               <a:t>Honestidade metodológica: a base é testbed; o entregável é o otimizador. Coorte única (China, 2012), que não distingue T1D/T2D.</a:t>
             </a:r>
@@ -15409,8 +15409,8 @@
         </p:blipFill>
         <p:spPr>
           <a:xfrm>
-            <a:off x="292608" y="6291072"/>
-            <a:ext cx="1065929" cy="548640"/>
+            <a:off x="292608" y="6355080"/>
+            <a:ext cx="1191126" cy="457200"/>
           </a:xfrm>
           <a:prstGeom prst="rect">
             <a:avLst/>
@@ -15425,8 +15425,8 @@
         </p:nvSpPr>
         <p:spPr>
           <a:xfrm>
-            <a:off x="1783080" y="6355080"/>
-            <a:ext cx="7498079" cy="457200"/>
+            <a:off x="1691640" y="6373368"/>
+            <a:ext cx="8229600" cy="457200"/>
           </a:xfrm>
           <a:prstGeom prst="rect">
             <a:avLst/>
@@ -15448,11 +15448,11 @@
               </a:spcAft>
             </a:pPr>
             <a:r>
-              <a:rPr sz="1000" b="0" i="0">
+              <a:rPr sz="1100" b="0" i="0">
                 <a:solidFill>
                   <a:srgbClr val="203864"/>
                 </a:solidFill>
-                <a:latin typeface="Book Antiqua"/>
+                <a:latin typeface="Palatino Linotype"/>
               </a:rPr>
               <a:t>COURSE: Computação Natural</a:t>
             </a:r>
@@ -15467,11 +15467,11 @@
               </a:spcAft>
             </a:pPr>
             <a:r>
-              <a:rPr sz="1000" b="0" i="0">
+              <a:rPr sz="1100" b="0" i="0">
                 <a:solidFill>
                   <a:srgbClr val="203864"/>
                 </a:solidFill>
-                <a:latin typeface="Book Antiqua"/>
+                <a:latin typeface="Palatino Linotype"/>
               </a:rPr>
               <a:t>CLASS: Equipe 4  -  TOPIC: Otimizador Bioinspirado (Plano B)</a:t>
             </a:r>
@@ -15486,7 +15486,7 @@
         </p:nvSpPr>
         <p:spPr>
           <a:xfrm>
-            <a:off x="11323015" y="6364224"/>
+            <a:off x="11323015" y="6400800"/>
             <a:ext cx="548640" cy="274320"/>
           </a:xfrm>
           <a:prstGeom prst="rect">
@@ -15513,7 +15513,7 @@
                 <a:solidFill>
                   <a:srgbClr val="203864"/>
                 </a:solidFill>
-                <a:latin typeface="Book Antiqua"/>
+                <a:latin typeface="Palatino Linotype"/>
               </a:rPr>
               <a:t>7</a:t>
             </a:r>
@@ -15555,7 +15555,7 @@
                 <a:solidFill>
                   <a:srgbClr val="203864"/>
                 </a:solidFill>
-                <a:latin typeface="Book Antiqua"/>
+                <a:latin typeface="Palatino Linotype"/>
               </a:rPr>
               <a:t>A variável dependente: Wellness</a:t>
             </a:r>
@@ -15597,7 +15597,7 @@
                 <a:solidFill>
                   <a:srgbClr val="203864"/>
                 </a:solidFill>
-                <a:latin typeface="Book Antiqua"/>
+                <a:latin typeface="Palatino Linotype"/>
               </a:rPr>
               <a:t>Por que não um rótulo clínico direto?</a:t>
             </a:r>
@@ -15616,7 +15616,7 @@
                 <a:solidFill>
                   <a:srgbClr val="203864"/>
                 </a:solidFill>
-                <a:latin typeface="Book Antiqua"/>
+                <a:latin typeface="Arial"/>
               </a:rPr>
               <a:t>•  </a:t>
             </a:r>
@@ -15625,7 +15625,7 @@
                 <a:solidFill>
                   <a:srgbClr val="404040"/>
                 </a:solidFill>
-                <a:latin typeface="Book Antiqua"/>
+                <a:latin typeface="Palatino Linotype"/>
               </a:rPr>
               <a:t>A base não possui rótulo 'saudável vs. doente'.</a:t>
             </a:r>
@@ -15644,7 +15644,7 @@
                 <a:solidFill>
                   <a:srgbClr val="203864"/>
                 </a:solidFill>
-                <a:latin typeface="Book Antiqua"/>
+                <a:latin typeface="Arial"/>
               </a:rPr>
               <a:t>•  </a:t>
             </a:r>
@@ -15653,7 +15653,7 @@
                 <a:solidFill>
                   <a:srgbClr val="404040"/>
                 </a:solidFill>
-                <a:latin typeface="Book Antiqua"/>
+                <a:latin typeface="Palatino Linotype"/>
               </a:rPr>
               <a:t>É um snapshot transversal, sem trajetória longitudinal.</a:t>
             </a:r>
@@ -15672,7 +15672,7 @@
                 <a:solidFill>
                   <a:srgbClr val="203864"/>
                 </a:solidFill>
-                <a:latin typeface="Book Antiqua"/>
+                <a:latin typeface="Arial"/>
               </a:rPr>
               <a:t>•  </a:t>
             </a:r>
@@ -15681,7 +15681,7 @@
                 <a:solidFill>
                   <a:srgbClr val="404040"/>
                 </a:solidFill>
-                <a:latin typeface="Book Antiqua"/>
+                <a:latin typeface="Palatino Linotype"/>
               </a:rPr>
               <a:t>Wellness é construído a partir de variáveis objetivas da coorte.</a:t>
             </a:r>
@@ -15700,7 +15700,7 @@
                 <a:solidFill>
                   <a:srgbClr val="203864"/>
                 </a:solidFill>
-                <a:latin typeface="Book Antiqua"/>
+                <a:latin typeface="Palatino Linotype"/>
               </a:rPr>
               <a:t>Conexão com HLY</a:t>
             </a:r>
@@ -15719,7 +15719,7 @@
                 <a:solidFill>
                   <a:srgbClr val="404040"/>
                 </a:solidFill>
-                <a:latin typeface="Book Antiqua"/>
+                <a:latin typeface="Palatino Linotype"/>
               </a:rPr>
               <a:t>Ausência de complicações + controle metabólico = pilares que sustentam os Anos de Vida Saudáveis.</a:t>
             </a:r>
@@ -15807,7 +15807,7 @@
                 <a:solidFill>
                   <a:srgbClr val="595959"/>
                 </a:solidFill>
-                <a:latin typeface="Book Antiqua"/>
+                <a:latin typeface="Palatino Linotype"/>
               </a:rPr>
               <a:t>Wellness  =  terço superior de</a:t>
             </a:r>
@@ -15826,7 +15826,7 @@
                 <a:solidFill>
                   <a:srgbClr val="203864"/>
                 </a:solidFill>
-                <a:latin typeface="Book Antiqua"/>
+                <a:latin typeface="Palatino Linotype"/>
               </a:rPr>
               <a:t>z(idade) − z(HbA1c) − z(n.º de comorbidades)</a:t>
             </a:r>
@@ -15958,7 +15958,7 @@
                 <a:solidFill>
                   <a:srgbClr val="FFFFFF"/>
                 </a:solidFill>
-                <a:latin typeface="Book Antiqua"/>
+                <a:latin typeface="Palatino Linotype"/>
               </a:rPr>
               <a:t>Grupos  (filtro DM == 1)</a:t>
             </a:r>
@@ -16000,7 +16000,7 @@
                 <a:solidFill>
                   <a:srgbClr val="404040"/>
                 </a:solidFill>
-                <a:latin typeface="Book Antiqua"/>
+                <a:latin typeface="Palatino Linotype"/>
               </a:rPr>
               <a:t>Indivíduos ideais</a:t>
             </a:r>
@@ -16019,7 +16019,7 @@
                 <a:solidFill>
                   <a:srgbClr val="595959"/>
                 </a:solidFill>
-                <a:latin typeface="Book Antiqua"/>
+                <a:latin typeface="Palatino Linotype"/>
               </a:rPr>
               <a:t>terço superior</a:t>
             </a:r>
@@ -16061,7 +16061,7 @@
                 <a:solidFill>
                   <a:srgbClr val="203864"/>
                 </a:solidFill>
-                <a:latin typeface="Book Antiqua"/>
+                <a:latin typeface="Palatino Linotype"/>
               </a:rPr>
               <a:t>119</a:t>
             </a:r>
@@ -16103,7 +16103,7 @@
                 <a:solidFill>
                   <a:srgbClr val="404040"/>
                 </a:solidFill>
-                <a:latin typeface="Book Antiqua"/>
+                <a:latin typeface="Palatino Linotype"/>
               </a:rPr>
               <a:t>Demais diabéticos</a:t>
             </a:r>
@@ -16145,7 +16145,7 @@
                 <a:solidFill>
                   <a:srgbClr val="203864"/>
                 </a:solidFill>
-                <a:latin typeface="Book Antiqua"/>
+                <a:latin typeface="Palatino Linotype"/>
               </a:rPr>
               <a:t>238</a:t>
             </a:r>
@@ -16231,7 +16231,7 @@
                 <a:solidFill>
                   <a:srgbClr val="404040"/>
                 </a:solidFill>
-                <a:latin typeface="Book Antiqua"/>
+                <a:latin typeface="Palatino Linotype"/>
               </a:rPr>
               <a:t>Total</a:t>
             </a:r>
@@ -16273,7 +16273,7 @@
                 <a:solidFill>
                   <a:srgbClr val="203864"/>
                 </a:solidFill>
-                <a:latin typeface="Book Antiqua"/>
+                <a:latin typeface="Palatino Linotype"/>
               </a:rPr>
               <a:t>357</a:t>
             </a:r>
@@ -16426,8 +16426,8 @@
         </p:blipFill>
         <p:spPr>
           <a:xfrm>
-            <a:off x="292608" y="6291072"/>
-            <a:ext cx="1065929" cy="548640"/>
+            <a:off x="292608" y="6355080"/>
+            <a:ext cx="1191126" cy="457200"/>
           </a:xfrm>
           <a:prstGeom prst="rect">
             <a:avLst/>
@@ -16442,8 +16442,8 @@
         </p:nvSpPr>
         <p:spPr>
           <a:xfrm>
-            <a:off x="1783080" y="6355080"/>
-            <a:ext cx="7498079" cy="457200"/>
+            <a:off x="1691640" y="6373368"/>
+            <a:ext cx="8229600" cy="457200"/>
           </a:xfrm>
           <a:prstGeom prst="rect">
             <a:avLst/>
@@ -16465,11 +16465,11 @@
               </a:spcAft>
             </a:pPr>
             <a:r>
-              <a:rPr sz="1000" b="0" i="0">
+              <a:rPr sz="1100" b="0" i="0">
                 <a:solidFill>
                   <a:srgbClr val="203864"/>
                 </a:solidFill>
-                <a:latin typeface="Book Antiqua"/>
+                <a:latin typeface="Palatino Linotype"/>
               </a:rPr>
               <a:t>COURSE: Computação Natural</a:t>
             </a:r>
@@ -16484,11 +16484,11 @@
               </a:spcAft>
             </a:pPr>
             <a:r>
-              <a:rPr sz="1000" b="0" i="0">
+              <a:rPr sz="1100" b="0" i="0">
                 <a:solidFill>
                   <a:srgbClr val="203864"/>
                 </a:solidFill>
-                <a:latin typeface="Book Antiqua"/>
+                <a:latin typeface="Palatino Linotype"/>
               </a:rPr>
               <a:t>CLASS: Equipe 4  -  TOPIC: Otimizador Bioinspirado (Plano B)</a:t>
             </a:r>
@@ -16503,7 +16503,7 @@
         </p:nvSpPr>
         <p:spPr>
           <a:xfrm>
-            <a:off x="11323015" y="6364224"/>
+            <a:off x="11323015" y="6400800"/>
             <a:ext cx="548640" cy="274320"/>
           </a:xfrm>
           <a:prstGeom prst="rect">
@@ -16530,7 +16530,7 @@
                 <a:solidFill>
                   <a:srgbClr val="203864"/>
                 </a:solidFill>
-                <a:latin typeface="Book Antiqua"/>
+                <a:latin typeface="Palatino Linotype"/>
               </a:rPr>
               <a:t>8</a:t>
             </a:r>
@@ -16572,7 +16572,7 @@
                 <a:solidFill>
                   <a:srgbClr val="203864"/>
                 </a:solidFill>
-                <a:latin typeface="Book Antiqua"/>
+                <a:latin typeface="Palatino Linotype"/>
               </a:rPr>
               <a:t>Passo a passo da solução (Plano B)</a:t>
             </a:r>
@@ -16614,7 +16614,7 @@
                 <a:solidFill>
                   <a:srgbClr val="595959"/>
                 </a:solidFill>
-                <a:latin typeface="Book Antiqua"/>
+                <a:latin typeface="Palatino Linotype"/>
               </a:rPr>
               <a:t>Da base bruta ao perfil do indivíduo ideal — 9 etapas reprodutíveis.</a:t>
             </a:r>
@@ -16656,7 +16656,7 @@
                 <a:solidFill>
                   <a:srgbClr val="41719C"/>
                 </a:solidFill>
-                <a:latin typeface="Book Antiqua"/>
+                <a:latin typeface="Palatino Linotype"/>
               </a:rPr>
               <a:t>PREPARAÇÃO</a:t>
             </a:r>
@@ -16832,7 +16832,7 @@
                 <a:solidFill>
                   <a:srgbClr val="FFFFFF"/>
                 </a:solidFill>
-                <a:latin typeface="Book Antiqua"/>
+                <a:latin typeface="Palatino Linotype"/>
               </a:rPr>
               <a:t>1</a:t>
             </a:r>
@@ -16874,7 +16874,7 @@
                 <a:solidFill>
                   <a:srgbClr val="203864"/>
                 </a:solidFill>
-                <a:latin typeface="Book Antiqua"/>
+                <a:latin typeface="Palatino Linotype"/>
               </a:rPr>
               <a:t>Carregar &amp; filtrar</a:t>
             </a:r>
@@ -16893,7 +16893,7 @@
                 <a:solidFill>
                   <a:srgbClr val="595959"/>
                 </a:solidFill>
-                <a:latin typeface="Book Antiqua"/>
+                <a:latin typeface="Palatino Linotype"/>
               </a:rPr>
               <a:t>CSV 5.922×190 → DM==1 → 357</a:t>
             </a:r>
@@ -17069,7 +17069,7 @@
                 <a:solidFill>
                   <a:srgbClr val="FFFFFF"/>
                 </a:solidFill>
-                <a:latin typeface="Book Antiqua"/>
+                <a:latin typeface="Palatino Linotype"/>
               </a:rPr>
               <a:t>2</a:t>
             </a:r>
@@ -17111,7 +17111,7 @@
                 <a:solidFill>
                   <a:srgbClr val="203864"/>
                 </a:solidFill>
-                <a:latin typeface="Book Antiqua"/>
+                <a:latin typeface="Palatino Linotype"/>
               </a:rPr>
               <a:t>Construir Wellness</a:t>
             </a:r>
@@ -17130,7 +17130,7 @@
                 <a:solidFill>
                   <a:srgbClr val="595959"/>
                 </a:solidFill>
-                <a:latin typeface="Book Antiqua"/>
+                <a:latin typeface="Palatino Linotype"/>
               </a:rPr>
               <a:t>rótulo 0/1</a:t>
             </a:r>
@@ -17306,7 +17306,7 @@
                 <a:solidFill>
                   <a:srgbClr val="FFFFFF"/>
                 </a:solidFill>
-                <a:latin typeface="Book Antiqua"/>
+                <a:latin typeface="Palatino Linotype"/>
               </a:rPr>
               <a:t>3</a:t>
             </a:r>
@@ -17348,7 +17348,7 @@
                 <a:solidFill>
                   <a:srgbClr val="203864"/>
                 </a:solidFill>
-                <a:latin typeface="Book Antiqua"/>
+                <a:latin typeface="Palatino Linotype"/>
               </a:rPr>
               <a:t>Selecionar 26 features</a:t>
             </a:r>
@@ -17367,7 +17367,7 @@
                 <a:solidFill>
                   <a:srgbClr val="595959"/>
                 </a:solidFill>
-                <a:latin typeface="Book Antiqua"/>
+                <a:latin typeface="Palatino Linotype"/>
               </a:rPr>
               <a:t>imputar mediana; z-score</a:t>
             </a:r>
@@ -17409,7 +17409,7 @@
                 <a:solidFill>
                   <a:srgbClr val="203864"/>
                 </a:solidFill>
-                <a:latin typeface="Book Antiqua"/>
+                <a:latin typeface="Palatino Linotype"/>
               </a:rPr>
               <a:t>OTIMIZAÇÃO</a:t>
             </a:r>
@@ -17585,7 +17585,7 @@
                 <a:solidFill>
                   <a:srgbClr val="FFFFFF"/>
                 </a:solidFill>
-                <a:latin typeface="Book Antiqua"/>
+                <a:latin typeface="Palatino Linotype"/>
               </a:rPr>
               <a:t>4</a:t>
             </a:r>
@@ -17627,7 +17627,7 @@
                 <a:solidFill>
                   <a:srgbClr val="203864"/>
                 </a:solidFill>
-                <a:latin typeface="Book Antiqua"/>
+                <a:latin typeface="Palatino Linotype"/>
               </a:rPr>
               <a:t>Função de fitness</a:t>
             </a:r>
@@ -17646,7 +17646,7 @@
                 <a:solidFill>
                   <a:srgbClr val="595959"/>
                 </a:solidFill>
-                <a:latin typeface="Book Antiqua"/>
+                <a:latin typeface="Palatino Linotype"/>
               </a:rPr>
               <a:t>−(log-loss + L2)</a:t>
             </a:r>
@@ -17822,7 +17822,7 @@
                 <a:solidFill>
                   <a:srgbClr val="FFFFFF"/>
                 </a:solidFill>
-                <a:latin typeface="Book Antiqua"/>
+                <a:latin typeface="Palatino Linotype"/>
               </a:rPr>
               <a:t>5</a:t>
             </a:r>
@@ -17864,7 +17864,7 @@
                 <a:solidFill>
                   <a:srgbClr val="203864"/>
                 </a:solidFill>
-                <a:latin typeface="Book Antiqua"/>
+                <a:latin typeface="Palatino Linotype"/>
               </a:rPr>
               <a:t>Executar PSO</a:t>
             </a:r>
@@ -17883,7 +17883,7 @@
                 <a:solidFill>
                   <a:srgbClr val="595959"/>
                 </a:solidFill>
-                <a:latin typeface="Book Antiqua"/>
+                <a:latin typeface="Palatino Linotype"/>
               </a:rPr>
               <a:t>27D; w=0,7; c1=c2=1,5</a:t>
             </a:r>
@@ -18059,7 +18059,7 @@
                 <a:solidFill>
                   <a:srgbClr val="FFFFFF"/>
                 </a:solidFill>
-                <a:latin typeface="Book Antiqua"/>
+                <a:latin typeface="Palatino Linotype"/>
               </a:rPr>
               <a:t>6</a:t>
             </a:r>
@@ -18101,7 +18101,7 @@
                 <a:solidFill>
                   <a:srgbClr val="203864"/>
                 </a:solidFill>
-                <a:latin typeface="Book Antiqua"/>
+                <a:latin typeface="Palatino Linotype"/>
               </a:rPr>
               <a:t>Validar</a:t>
             </a:r>
@@ -18120,7 +18120,7 @@
                 <a:solidFill>
                   <a:srgbClr val="595959"/>
                 </a:solidFill>
-                <a:latin typeface="Book Antiqua"/>
+                <a:latin typeface="Palatino Linotype"/>
               </a:rPr>
               <a:t>cosseno PSO × sklearn = 1,000</a:t>
             </a:r>
@@ -18162,7 +18162,7 @@
                 <a:solidFill>
                   <a:srgbClr val="2E6B4F"/>
                 </a:solidFill>
-                <a:latin typeface="Book Antiqua"/>
+                <a:latin typeface="Palatino Linotype"/>
               </a:rPr>
               <a:t>INTERPRETAÇÃO</a:t>
             </a:r>
@@ -18338,7 +18338,7 @@
                 <a:solidFill>
                   <a:srgbClr val="FFFFFF"/>
                 </a:solidFill>
-                <a:latin typeface="Book Antiqua"/>
+                <a:latin typeface="Palatino Linotype"/>
               </a:rPr>
               <a:t>7</a:t>
             </a:r>
@@ -18380,7 +18380,7 @@
                 <a:solidFill>
                   <a:srgbClr val="203864"/>
                 </a:solidFill>
-                <a:latin typeface="Book Antiqua"/>
+                <a:latin typeface="Palatino Linotype"/>
               </a:rPr>
               <a:t>Meta-FSS</a:t>
             </a:r>
@@ -18399,7 +18399,7 @@
                 <a:solidFill>
                   <a:srgbClr val="595959"/>
                 </a:solidFill>
-                <a:latin typeface="Book Antiqua"/>
+                <a:latin typeface="Palatino Linotype"/>
               </a:rPr>
               <a:t>hiperparâm.; AUC cross-val</a:t>
             </a:r>
@@ -18575,7 +18575,7 @@
                 <a:solidFill>
                   <a:srgbClr val="FFFFFF"/>
                 </a:solidFill>
-                <a:latin typeface="Book Antiqua"/>
+                <a:latin typeface="Palatino Linotype"/>
               </a:rPr>
               <a:t>8</a:t>
             </a:r>
@@ -18617,7 +18617,7 @@
                 <a:solidFill>
                   <a:srgbClr val="203864"/>
                 </a:solidFill>
-                <a:latin typeface="Book Antiqua"/>
+                <a:latin typeface="Palatino Linotype"/>
               </a:rPr>
               <a:t>Perfil do ideal</a:t>
             </a:r>
@@ -18636,7 +18636,7 @@
                 <a:solidFill>
                   <a:srgbClr val="595959"/>
                 </a:solidFill>
-                <a:latin typeface="Book Antiqua"/>
+                <a:latin typeface="Palatino Linotype"/>
               </a:rPr>
               <a:t>rank por |peso|; sinal = direção</a:t>
             </a:r>
@@ -18812,7 +18812,7 @@
                 <a:solidFill>
                   <a:srgbClr val="FFFFFF"/>
                 </a:solidFill>
-                <a:latin typeface="Book Antiqua"/>
+                <a:latin typeface="Palatino Linotype"/>
               </a:rPr>
               <a:t>9</a:t>
             </a:r>
@@ -18854,7 +18854,7 @@
                 <a:solidFill>
                   <a:srgbClr val="203864"/>
                 </a:solidFill>
-                <a:latin typeface="Book Antiqua"/>
+                <a:latin typeface="Palatino Linotype"/>
               </a:rPr>
               <a:t>Visualizar</a:t>
             </a:r>
@@ -18873,7 +18873,7 @@
                 <a:solidFill>
                   <a:srgbClr val="595959"/>
                 </a:solidFill>
-                <a:latin typeface="Book Antiqua"/>
+                <a:latin typeface="Palatino Linotype"/>
               </a:rPr>
               <a:t>HTML, 3 abas, enxame animado</a:t>
             </a:r>
@@ -19026,8 +19026,8 @@
         </p:blipFill>
         <p:spPr>
           <a:xfrm>
-            <a:off x="292608" y="6291072"/>
-            <a:ext cx="1065929" cy="548640"/>
+            <a:off x="292608" y="6355080"/>
+            <a:ext cx="1191126" cy="457200"/>
           </a:xfrm>
           <a:prstGeom prst="rect">
             <a:avLst/>
@@ -19042,8 +19042,8 @@
         </p:nvSpPr>
         <p:spPr>
           <a:xfrm>
-            <a:off x="1783080" y="6355080"/>
-            <a:ext cx="7498079" cy="457200"/>
+            <a:off x="1691640" y="6373368"/>
+            <a:ext cx="8229600" cy="457200"/>
           </a:xfrm>
           <a:prstGeom prst="rect">
             <a:avLst/>
@@ -19065,11 +19065,11 @@
               </a:spcAft>
             </a:pPr>
             <a:r>
-              <a:rPr sz="1000" b="0" i="0">
+              <a:rPr sz="1100" b="0" i="0">
                 <a:solidFill>
                   <a:srgbClr val="203864"/>
                 </a:solidFill>
-                <a:latin typeface="Book Antiqua"/>
+                <a:latin typeface="Palatino Linotype"/>
               </a:rPr>
               <a:t>COURSE: Computação Natural</a:t>
             </a:r>
@@ -19084,11 +19084,11 @@
               </a:spcAft>
             </a:pPr>
             <a:r>
-              <a:rPr sz="1000" b="0" i="0">
+              <a:rPr sz="1100" b="0" i="0">
                 <a:solidFill>
                   <a:srgbClr val="203864"/>
                 </a:solidFill>
-                <a:latin typeface="Book Antiqua"/>
+                <a:latin typeface="Palatino Linotype"/>
               </a:rPr>
               <a:t>CLASS: Equipe 4  -  TOPIC: Otimizador Bioinspirado (Plano B)</a:t>
             </a:r>
@@ -19103,7 +19103,7 @@
         </p:nvSpPr>
         <p:spPr>
           <a:xfrm>
-            <a:off x="11323015" y="6364224"/>
+            <a:off x="11323015" y="6400800"/>
             <a:ext cx="548640" cy="274320"/>
           </a:xfrm>
           <a:prstGeom prst="rect">
@@ -19130,7 +19130,7 @@
                 <a:solidFill>
                   <a:srgbClr val="203864"/>
                 </a:solidFill>
-                <a:latin typeface="Book Antiqua"/>
+                <a:latin typeface="Palatino Linotype"/>
               </a:rPr>
               <a:t>9</a:t>
             </a:r>
@@ -19172,7 +19172,7 @@
                 <a:solidFill>
                   <a:srgbClr val="203864"/>
                 </a:solidFill>
-                <a:latin typeface="Book Antiqua"/>
+                <a:latin typeface="Palatino Linotype"/>
               </a:rPr>
               <a:t>Por que PSO (enxame) e não algoritmo evolucionário</a:t>
             </a:r>
@@ -19304,7 +19304,7 @@
                 <a:solidFill>
                   <a:srgbClr val="203864"/>
                 </a:solidFill>
-                <a:latin typeface="Book Antiqua"/>
+                <a:latin typeface="Palatino Linotype"/>
               </a:rPr>
               <a:t>Terreno do problema</a:t>
             </a:r>
@@ -19323,7 +19323,7 @@
                 <a:solidFill>
                   <a:srgbClr val="404040"/>
                 </a:solidFill>
-                <a:latin typeface="Book Antiqua"/>
+                <a:latin typeface="Palatino Linotype"/>
               </a:rPr>
               <a:t>Os pesos vivem em espaço contínuo de alta dimensão (27D) e a perda é convexa. O PSO desliza no contínuo com momento e converge rápido para o ótimo. GAs exigem crossover/mutação, menos intuitivos para pesos reais.</a:t>
             </a:r>
@@ -19455,7 +19455,7 @@
                 <a:solidFill>
                   <a:srgbClr val="41719C"/>
                 </a:solidFill>
-                <a:latin typeface="Book Antiqua"/>
+                <a:latin typeface="Palatino Linotype"/>
               </a:rPr>
               <a:t>Alinhamento com o enunciado</a:t>
             </a:r>
@@ -19474,7 +19474,7 @@
                 <a:solidFill>
                   <a:srgbClr val="404040"/>
                 </a:solidFill>
-                <a:latin typeface="Book Antiqua"/>
+                <a:latin typeface="Palatino Linotype"/>
               </a:rPr>
               <a:t>A disciplina avalia Inteligência de Enxames. PSO é o algoritmo canônico, e a família FSS é o fio condutor do projeto.</a:t>
             </a:r>
@@ -19606,7 +19606,7 @@
                 <a:solidFill>
                   <a:srgbClr val="41719C"/>
                 </a:solidFill>
-                <a:latin typeface="Book Antiqua"/>
+                <a:latin typeface="Palatino Linotype"/>
               </a:rPr>
               <a:t>Interpretabilidade</a:t>
             </a:r>
@@ -19625,7 +19625,7 @@
                 <a:solidFill>
                   <a:srgbClr val="404040"/>
                 </a:solidFill>
-                <a:latin typeface="Book Antiqua"/>
+                <a:latin typeface="Palatino Linotype"/>
               </a:rPr>
               <a:t>O PSO entrega direto um vetor de pesos: magnitude = importância, sinal = direção clínica. Um genoma binário de GA obscureceria isso.</a:t>
             </a:r>
@@ -19757,7 +19757,7 @@
                 <a:solidFill>
                   <a:srgbClr val="2E6B4F"/>
                 </a:solidFill>
-                <a:latin typeface="Book Antiqua"/>
+                <a:latin typeface="Palatino Linotype"/>
               </a:rPr>
               <a:t>Validação elegante</a:t>
             </a:r>
@@ -19776,7 +19776,7 @@
                 <a:solidFill>
                   <a:srgbClr val="404040"/>
                 </a:solidFill>
-                <a:latin typeface="Book Antiqua"/>
+                <a:latin typeface="Palatino Linotype"/>
               </a:rPr>
               <a:t>Em problema convexo existe ótimo conhecido — dá para provar que o otimizador chegou nele (cosseno = 1,000). Demonstração limpa e didática.</a:t>
             </a:r>

</xml_diff>

<commit_message>
fix(plano-b): recorta logo do rodape sem clipar o emblema do PPGEC
</commit_message>
<xml_diff>
--- a/plano_b_pso_diabetes/Apresentacao_Equipe4_PlanoB_CIRG.pptx
+++ b/plano_b_pso_diabetes/Apresentacao_Equipe4_PlanoB_CIRG.pptx
@@ -3230,8 +3230,8 @@
         </p:blipFill>
         <p:spPr>
           <a:xfrm>
-            <a:off x="292608" y="6355080"/>
-            <a:ext cx="1191126" cy="457200"/>
+            <a:off x="292608" y="6327648"/>
+            <a:ext cx="1026579" cy="502920"/>
           </a:xfrm>
           <a:prstGeom prst="rect">
             <a:avLst/>
@@ -3750,8 +3750,8 @@
         </p:blipFill>
         <p:spPr>
           <a:xfrm>
-            <a:off x="292608" y="6355080"/>
-            <a:ext cx="1191126" cy="457200"/>
+            <a:off x="292608" y="6327648"/>
+            <a:ext cx="1026579" cy="502920"/>
           </a:xfrm>
           <a:prstGeom prst="rect">
             <a:avLst/>
@@ -4656,8 +4656,8 @@
         </p:blipFill>
         <p:spPr>
           <a:xfrm>
-            <a:off x="292608" y="6355080"/>
-            <a:ext cx="1191126" cy="457200"/>
+            <a:off x="292608" y="6327648"/>
+            <a:ext cx="1026579" cy="502920"/>
           </a:xfrm>
           <a:prstGeom prst="rect">
             <a:avLst/>
@@ -5319,8 +5319,8 @@
         </p:blipFill>
         <p:spPr>
           <a:xfrm>
-            <a:off x="292608" y="6355080"/>
-            <a:ext cx="1191126" cy="457200"/>
+            <a:off x="292608" y="6327648"/>
+            <a:ext cx="1026579" cy="502920"/>
           </a:xfrm>
           <a:prstGeom prst="rect">
             <a:avLst/>
@@ -6481,8 +6481,8 @@
         </p:blipFill>
         <p:spPr>
           <a:xfrm>
-            <a:off x="292608" y="6355080"/>
-            <a:ext cx="1191126" cy="457200"/>
+            <a:off x="292608" y="6327648"/>
+            <a:ext cx="1026579" cy="502920"/>
           </a:xfrm>
           <a:prstGeom prst="rect">
             <a:avLst/>
@@ -7095,8 +7095,8 @@
         </p:blipFill>
         <p:spPr>
           <a:xfrm>
-            <a:off x="292608" y="6355080"/>
-            <a:ext cx="1191126" cy="457200"/>
+            <a:off x="292608" y="6327648"/>
+            <a:ext cx="1026579" cy="502920"/>
           </a:xfrm>
           <a:prstGeom prst="rect">
             <a:avLst/>
@@ -8186,8 +8186,8 @@
         </p:blipFill>
         <p:spPr>
           <a:xfrm>
-            <a:off x="292608" y="6355080"/>
-            <a:ext cx="1191126" cy="457200"/>
+            <a:off x="292608" y="6327648"/>
+            <a:ext cx="1026579" cy="502920"/>
           </a:xfrm>
           <a:prstGeom prst="rect">
             <a:avLst/>
@@ -9129,8 +9129,8 @@
         </p:blipFill>
         <p:spPr>
           <a:xfrm>
-            <a:off x="292608" y="6355080"/>
-            <a:ext cx="1191126" cy="457200"/>
+            <a:off x="292608" y="6327648"/>
+            <a:ext cx="1026579" cy="502920"/>
           </a:xfrm>
           <a:prstGeom prst="rect">
             <a:avLst/>
@@ -10393,8 +10393,8 @@
         </p:blipFill>
         <p:spPr>
           <a:xfrm>
-            <a:off x="292608" y="6355080"/>
-            <a:ext cx="1191126" cy="457200"/>
+            <a:off x="292608" y="6327648"/>
+            <a:ext cx="1026579" cy="502920"/>
           </a:xfrm>
           <a:prstGeom prst="rect">
             <a:avLst/>
@@ -11368,8 +11368,8 @@
         </p:blipFill>
         <p:spPr>
           <a:xfrm>
-            <a:off x="292608" y="6355080"/>
-            <a:ext cx="1191126" cy="457200"/>
+            <a:off x="292608" y="6327648"/>
+            <a:ext cx="1026579" cy="502920"/>
           </a:xfrm>
           <a:prstGeom prst="rect">
             <a:avLst/>
@@ -12647,8 +12647,8 @@
         </p:blipFill>
         <p:spPr>
           <a:xfrm>
-            <a:off x="292608" y="6355080"/>
-            <a:ext cx="1191126" cy="457200"/>
+            <a:off x="292608" y="6327648"/>
+            <a:ext cx="1026579" cy="502920"/>
           </a:xfrm>
           <a:prstGeom prst="rect">
             <a:avLst/>
@@ -14472,8 +14472,8 @@
         </p:blipFill>
         <p:spPr>
           <a:xfrm>
-            <a:off x="292608" y="6355080"/>
-            <a:ext cx="1191126" cy="457200"/>
+            <a:off x="292608" y="6327648"/>
+            <a:ext cx="1026579" cy="502920"/>
           </a:xfrm>
           <a:prstGeom prst="rect">
             <a:avLst/>
@@ -15409,8 +15409,8 @@
         </p:blipFill>
         <p:spPr>
           <a:xfrm>
-            <a:off x="292608" y="6355080"/>
-            <a:ext cx="1191126" cy="457200"/>
+            <a:off x="292608" y="6327648"/>
+            <a:ext cx="1026579" cy="502920"/>
           </a:xfrm>
           <a:prstGeom prst="rect">
             <a:avLst/>
@@ -16426,8 +16426,8 @@
         </p:blipFill>
         <p:spPr>
           <a:xfrm>
-            <a:off x="292608" y="6355080"/>
-            <a:ext cx="1191126" cy="457200"/>
+            <a:off x="292608" y="6327648"/>
+            <a:ext cx="1026579" cy="502920"/>
           </a:xfrm>
           <a:prstGeom prst="rect">
             <a:avLst/>
@@ -19026,8 +19026,8 @@
         </p:blipFill>
         <p:spPr>
           <a:xfrm>
-            <a:off x="292608" y="6355080"/>
-            <a:ext cx="1191126" cy="457200"/>
+            <a:off x="292608" y="6327648"/>
+            <a:ext cx="1026579" cy="502920"/>
           </a:xfrm>
           <a:prstGeom prst="rect">
             <a:avLst/>

</xml_diff>

<commit_message>
feat(plano-b): adiciona slide de contribuicao/descobertas do estudo (16 telas)
</commit_message>
<xml_diff>
--- a/plano_b_pso_diabetes/Apresentacao_Equipe4_PlanoB_CIRG.pptx
+++ b/plano_b_pso_diabetes/Apresentacao_Equipe4_PlanoB_CIRG.pptx
@@ -20,6 +20,7 @@
     <p:sldId id="268" r:id="rId19"/>
     <p:sldId id="269" r:id="rId20"/>
     <p:sldId id="270" r:id="rId21"/>
+    <p:sldId id="271" r:id="rId22"/>
   </p:sldIdLst>
   <p:sldSz cx="12191695" cy="6858000" type="screen4x3"/>
   <p:notesSz cx="6858000" cy="9144000"/>
@@ -7243,21 +7244,63 @@
                 </a:solidFill>
                 <a:latin typeface="Palatino Linotype"/>
               </a:rPr>
-              <a:t>Limitações declaradas</a:t>
-            </a:r>
-          </a:p>
-        </p:txBody>
-      </p:sp>
-      <p:sp>
-        <p:nvSpPr>
-          <p:cNvPr id="9" name="Rectangle 8"/>
+              <a:t>O que descobrimos — contribuição do estudo</a:t>
+            </a:r>
+          </a:p>
+        </p:txBody>
+      </p:sp>
+      <p:sp>
+        <p:nvSpPr>
+          <p:cNvPr id="9" name="TextBox 8"/>
+          <p:cNvSpPr txBox="1"/>
+          <p:nvPr/>
+        </p:nvSpPr>
+        <p:spPr>
+          <a:xfrm>
+            <a:off x="502920" y="1188720"/>
+            <a:ext cx="11185855" cy="320040"/>
+          </a:xfrm>
+          <a:prstGeom prst="rect">
+            <a:avLst/>
+          </a:prstGeom>
+          <a:noFill/>
+        </p:spPr>
+        <p:txBody>
+          <a:bodyPr wrap="square" lIns="0" rIns="0" tIns="0" bIns="0">
+            <a:spAutoFit/>
+          </a:bodyPr>
+          <a:lstStyle/>
+          <a:p>
+            <a:pPr algn="l">
+              <a:spcBef>
+                <a:spcPts val="0"/>
+              </a:spcBef>
+              <a:spcAft>
+                <a:spcPts val="600"/>
+              </a:spcAft>
+            </a:pPr>
+            <a:r>
+              <a:rPr sz="1350" b="0" i="1">
+                <a:solidFill>
+                  <a:srgbClr val="595959"/>
+                </a:solidFill>
+                <a:latin typeface="Palatino Linotype"/>
+              </a:rPr>
+              <a:t>A entrega é um otimizador validado e um perfil interpretável — não uma conclusão clínica.</a:t>
+            </a:r>
+          </a:p>
+        </p:txBody>
+      </p:sp>
+      <p:sp>
+        <p:nvSpPr>
+          <p:cNvPr id="10" name="Rectangle 9"/>
           <p:cNvSpPr/>
           <p:nvPr/>
         </p:nvSpPr>
         <p:spPr>
           <a:xfrm>
-            <a:off x="502920" y="1508760"/>
-            <a:ext cx="5364327" cy="1143000"/>
+            <a:off x="502920" y="1627632"/>
+            <a:ext cx="3545738" cy="2834640"/>
           </a:xfrm>
           <a:prstGeom prst="rect">
             <a:avLst/>
@@ -7296,20 +7339,20 @@
       </p:sp>
       <p:sp>
         <p:nvSpPr>
-          <p:cNvPr id="10" name="Rectangle 9"/>
+          <p:cNvPr id="11" name="Rectangle 10"/>
           <p:cNvSpPr/>
           <p:nvPr/>
         </p:nvSpPr>
         <p:spPr>
           <a:xfrm>
-            <a:off x="502920" y="1508760"/>
-            <a:ext cx="82296" cy="1143000"/>
+            <a:off x="502920" y="1627632"/>
+            <a:ext cx="3545738" cy="91440"/>
           </a:xfrm>
           <a:prstGeom prst="rect">
             <a:avLst/>
           </a:prstGeom>
           <a:solidFill>
-            <a:srgbClr val="41719C"/>
+            <a:srgbClr val="203864"/>
           </a:solidFill>
           <a:ln>
             <a:noFill/>
@@ -7340,14 +7383,14 @@
       </p:sp>
       <p:sp>
         <p:nvSpPr>
-          <p:cNvPr id="11" name="TextBox 10"/>
+          <p:cNvPr id="12" name="TextBox 11"/>
           <p:cNvSpPr txBox="1"/>
           <p:nvPr/>
         </p:nvSpPr>
         <p:spPr>
           <a:xfrm>
-            <a:off x="777240" y="1709928"/>
-            <a:ext cx="4861407" cy="868680"/>
+            <a:off x="740664" y="1920240"/>
+            <a:ext cx="3070250" cy="2377440"/>
           </a:xfrm>
           <a:prstGeom prst="rect">
             <a:avLst/>
@@ -7365,31 +7408,143 @@
                 <a:spcPts val="0"/>
               </a:spcBef>
               <a:spcAft>
-                <a:spcPts val="600"/>
-              </a:spcAft>
-            </a:pPr>
-            <a:r>
-              <a:rPr sz="1350" b="0" i="0">
+                <a:spcPts val="900"/>
+              </a:spcAft>
+            </a:pPr>
+            <a:r>
+              <a:rPr sz="1550" b="1" i="0">
+                <a:solidFill>
+                  <a:srgbClr val="203864"/>
+                </a:solidFill>
+                <a:latin typeface="Palatino Linotype"/>
+              </a:rPr>
+              <a:t>Contribuição metodológica</a:t>
+            </a:r>
+          </a:p>
+          <a:p>
+            <a:pPr>
+              <a:spcBef>
+                <a:spcPts val="0"/>
+              </a:spcBef>
+              <a:spcAft>
+                <a:spcPts val="800"/>
+              </a:spcAft>
+            </a:pPr>
+            <a:r>
+              <a:rPr sz="1280" b="1" i="0">
+                <a:solidFill>
+                  <a:srgbClr val="203864"/>
+                </a:solidFill>
+                <a:latin typeface="Arial"/>
+              </a:rPr>
+              <a:t>•  </a:t>
+            </a:r>
+            <a:r>
+              <a:rPr sz="1280" b="0" i="0">
                 <a:solidFill>
                   <a:srgbClr val="404040"/>
                 </a:solidFill>
                 <a:latin typeface="Palatino Linotype"/>
               </a:rPr>
-              <a:t>A base não distingue T1D/T2D → 'diabetes tipo não especificado'; é testbed, não evidência clínica.</a:t>
-            </a:r>
-          </a:p>
-        </p:txBody>
-      </p:sp>
-      <p:sp>
-        <p:nvSpPr>
-          <p:cNvPr id="12" name="Rectangle 11"/>
+              <a:t>PSO de enxame implementado do zero e validado.</a:t>
+            </a:r>
+          </a:p>
+          <a:p>
+            <a:pPr>
+              <a:spcBef>
+                <a:spcPts val="0"/>
+              </a:spcBef>
+              <a:spcAft>
+                <a:spcPts val="800"/>
+              </a:spcAft>
+            </a:pPr>
+            <a:r>
+              <a:rPr sz="1280" b="1" i="0">
+                <a:solidFill>
+                  <a:srgbClr val="203864"/>
+                </a:solidFill>
+                <a:latin typeface="Arial"/>
+              </a:rPr>
+              <a:t>•  </a:t>
+            </a:r>
+            <a:r>
+              <a:rPr sz="1280" b="0" i="0">
+                <a:solidFill>
+                  <a:srgbClr val="404040"/>
+                </a:solidFill>
+                <a:latin typeface="Palatino Linotype"/>
+              </a:rPr>
+              <a:t>Corretude provada por dois caminhos independentes:</a:t>
+            </a:r>
+          </a:p>
+          <a:p>
+            <a:pPr>
+              <a:spcBef>
+                <a:spcPts val="0"/>
+              </a:spcBef>
+              <a:spcAft>
+                <a:spcPts val="800"/>
+              </a:spcAft>
+            </a:pPr>
+            <a:r>
+              <a:rPr sz="1280" b="1" i="0">
+                <a:solidFill>
+                  <a:srgbClr val="203864"/>
+                </a:solidFill>
+                <a:latin typeface="Arial"/>
+              </a:rPr>
+              <a:t>•  </a:t>
+            </a:r>
+            <a:r>
+              <a:rPr sz="1280" b="0" i="0">
+                <a:solidFill>
+                  <a:srgbClr val="404040"/>
+                </a:solidFill>
+                <a:latin typeface="Palatino Linotype"/>
+              </a:rPr>
+              <a:t>ótimo analítico — cosseno = 1,000;</a:t>
+            </a:r>
+          </a:p>
+          <a:p>
+            <a:pPr>
+              <a:spcBef>
+                <a:spcPts val="0"/>
+              </a:spcBef>
+              <a:spcAft>
+                <a:spcPts val="800"/>
+              </a:spcAft>
+            </a:pPr>
+            <a:r>
+              <a:rPr sz="1280" b="1" i="0">
+                <a:solidFill>
+                  <a:srgbClr val="203864"/>
+                </a:solidFill>
+                <a:latin typeface="Arial"/>
+              </a:rPr>
+              <a:t>•  </a:t>
+            </a:r>
+            <a:r>
+              <a:rPr sz="1280" b="0" i="0">
+                <a:solidFill>
+                  <a:srgbClr val="404040"/>
+                </a:solidFill>
+                <a:latin typeface="Palatino Linotype"/>
+              </a:rPr>
+              <a:t>verdade-base plantada (BFSS) — F1 = 0,94.</a:t>
+            </a:r>
+          </a:p>
+        </p:txBody>
+      </p:sp>
+      <p:sp>
+        <p:nvSpPr>
+          <p:cNvPr id="13" name="Rectangle 12"/>
           <p:cNvSpPr/>
           <p:nvPr/>
         </p:nvSpPr>
         <p:spPr>
           <a:xfrm>
-            <a:off x="6324447" y="1508760"/>
-            <a:ext cx="5364327" cy="1143000"/>
+            <a:off x="4322978" y="1627632"/>
+            <a:ext cx="3545738" cy="2834640"/>
           </a:xfrm>
           <a:prstGeom prst="rect">
             <a:avLst/>
@@ -7428,20 +7583,20 @@
       </p:sp>
       <p:sp>
         <p:nvSpPr>
-          <p:cNvPr id="13" name="Rectangle 12"/>
+          <p:cNvPr id="14" name="Rectangle 13"/>
           <p:cNvSpPr/>
           <p:nvPr/>
         </p:nvSpPr>
         <p:spPr>
           <a:xfrm>
-            <a:off x="6324447" y="1508760"/>
-            <a:ext cx="82296" cy="1143000"/>
+            <a:off x="4322978" y="1627632"/>
+            <a:ext cx="3545738" cy="91440"/>
           </a:xfrm>
           <a:prstGeom prst="rect">
             <a:avLst/>
           </a:prstGeom>
           <a:solidFill>
-            <a:srgbClr val="41719C"/>
+            <a:srgbClr val="2E6B4F"/>
           </a:solidFill>
           <a:ln>
             <a:noFill/>
@@ -7472,14 +7627,14 @@
       </p:sp>
       <p:sp>
         <p:nvSpPr>
-          <p:cNvPr id="14" name="TextBox 13"/>
+          <p:cNvPr id="15" name="TextBox 14"/>
           <p:cNvSpPr txBox="1"/>
           <p:nvPr/>
         </p:nvSpPr>
         <p:spPr>
           <a:xfrm>
-            <a:off x="6598767" y="1709928"/>
-            <a:ext cx="4861407" cy="868680"/>
+            <a:off x="4560722" y="1920240"/>
+            <a:ext cx="3070250" cy="2377440"/>
           </a:xfrm>
           <a:prstGeom prst="rect">
             <a:avLst/>
@@ -7497,31 +7652,115 @@
                 <a:spcPts val="0"/>
               </a:spcBef>
               <a:spcAft>
-                <a:spcPts val="600"/>
-              </a:spcAft>
-            </a:pPr>
-            <a:r>
-              <a:rPr sz="1350" b="0" i="0">
+                <a:spcPts val="900"/>
+              </a:spcAft>
+            </a:pPr>
+            <a:r>
+              <a:rPr sz="1550" b="1" i="0">
+                <a:solidFill>
+                  <a:srgbClr val="2E6B4F"/>
+                </a:solidFill>
+                <a:latin typeface="Palatino Linotype"/>
+              </a:rPr>
+              <a:t>O que foi descoberto</a:t>
+            </a:r>
+          </a:p>
+          <a:p>
+            <a:pPr>
+              <a:spcBef>
+                <a:spcPts val="0"/>
+              </a:spcBef>
+              <a:spcAft>
+                <a:spcPts val="800"/>
+              </a:spcAft>
+            </a:pPr>
+            <a:r>
+              <a:rPr sz="1280" b="1" i="0">
+                <a:solidFill>
+                  <a:srgbClr val="2E6B4F"/>
+                </a:solidFill>
+                <a:latin typeface="Arial"/>
+              </a:rPr>
+              <a:t>•  </a:t>
+            </a:r>
+            <a:r>
+              <a:rPr sz="1280" b="0" i="0">
                 <a:solidFill>
                   <a:srgbClr val="404040"/>
                 </a:solidFill>
                 <a:latin typeface="Palatino Linotype"/>
               </a:rPr>
-              <a:t>Coorte única e transversal (China, 2012) → fala de associação, não de causalidade.</a:t>
-            </a:r>
-          </a:p>
-        </p:txBody>
-      </p:sp>
-      <p:sp>
-        <p:nvSpPr>
-          <p:cNvPr id="15" name="Rectangle 14"/>
+              <a:t>Perfil interpretável do 'indivíduo ideal' entre diabéticos.</a:t>
+            </a:r>
+          </a:p>
+          <a:p>
+            <a:pPr>
+              <a:spcBef>
+                <a:spcPts val="0"/>
+              </a:spcBef>
+              <a:spcAft>
+                <a:spcPts val="800"/>
+              </a:spcAft>
+            </a:pPr>
+            <a:r>
+              <a:rPr sz="1280" b="1" i="0">
+                <a:solidFill>
+                  <a:srgbClr val="2E6B4F"/>
+                </a:solidFill>
+                <a:latin typeface="Arial"/>
+              </a:rPr>
+              <a:t>•  </a:t>
+            </a:r>
+            <a:r>
+              <a:rPr sz="1280" b="0" i="0">
+                <a:solidFill>
+                  <a:srgbClr val="404040"/>
+                </a:solidFill>
+                <a:latin typeface="Palatino Linotype"/>
+              </a:rPr>
+              <a:t>Mais magro, menor resistência à insulina, fígado preservado, sem histórico familiar.</a:t>
+            </a:r>
+          </a:p>
+          <a:p>
+            <a:pPr>
+              <a:spcBef>
+                <a:spcPts val="0"/>
+              </a:spcBef>
+              <a:spcAft>
+                <a:spcPts val="800"/>
+              </a:spcAft>
+            </a:pPr>
+            <a:r>
+              <a:rPr sz="1280" b="1" i="0">
+                <a:solidFill>
+                  <a:srgbClr val="2E6B4F"/>
+                </a:solidFill>
+                <a:latin typeface="Arial"/>
+              </a:rPr>
+              <a:t>•  </a:t>
+            </a:r>
+            <a:r>
+              <a:rPr sz="1280" b="0" i="0">
+                <a:solidFill>
+                  <a:srgbClr val="404040"/>
+                </a:solidFill>
+                <a:latin typeface="Palatino Linotype"/>
+              </a:rPr>
+              <a:t>O otimizador redescobre, sozinho, um perfil clinicamente coerente.</a:t>
+            </a:r>
+          </a:p>
+        </p:txBody>
+      </p:sp>
+      <p:sp>
+        <p:nvSpPr>
+          <p:cNvPr id="16" name="Rectangle 15"/>
           <p:cNvSpPr/>
           <p:nvPr/>
         </p:nvSpPr>
         <p:spPr>
           <a:xfrm>
-            <a:off x="502920" y="2834640"/>
-            <a:ext cx="5364327" cy="1143000"/>
+            <a:off x="8143036" y="1627632"/>
+            <a:ext cx="3545738" cy="2834640"/>
           </a:xfrm>
           <a:prstGeom prst="rect">
             <a:avLst/>
@@ -7560,14 +7799,14 @@
       </p:sp>
       <p:sp>
         <p:nvSpPr>
-          <p:cNvPr id="16" name="Rectangle 15"/>
+          <p:cNvPr id="17" name="Rectangle 16"/>
           <p:cNvSpPr/>
           <p:nvPr/>
         </p:nvSpPr>
         <p:spPr>
           <a:xfrm>
-            <a:off x="502920" y="2834640"/>
-            <a:ext cx="82296" cy="1143000"/>
+            <a:off x="8143036" y="1627632"/>
+            <a:ext cx="3545738" cy="91440"/>
           </a:xfrm>
           <a:prstGeom prst="rect">
             <a:avLst/>
@@ -7604,14 +7843,14 @@
       </p:sp>
       <p:sp>
         <p:nvSpPr>
-          <p:cNvPr id="17" name="TextBox 16"/>
+          <p:cNvPr id="18" name="TextBox 17"/>
           <p:cNvSpPr txBox="1"/>
           <p:nvPr/>
         </p:nvSpPr>
         <p:spPr>
           <a:xfrm>
-            <a:off x="777240" y="3035808"/>
-            <a:ext cx="4861407" cy="868680"/>
+            <a:off x="8380780" y="1920240"/>
+            <a:ext cx="3070250" cy="2377440"/>
           </a:xfrm>
           <a:prstGeom prst="rect">
             <a:avLst/>
@@ -7629,42 +7868,124 @@
                 <a:spcPts val="0"/>
               </a:spcBef>
               <a:spcAft>
-                <a:spcPts val="600"/>
-              </a:spcAft>
-            </a:pPr>
-            <a:r>
-              <a:rPr sz="1350" b="0" i="0">
+                <a:spcPts val="900"/>
+              </a:spcAft>
+            </a:pPr>
+            <a:r>
+              <a:rPr sz="1550" b="1" i="0">
+                <a:solidFill>
+                  <a:srgbClr val="41719C"/>
+                </a:solidFill>
+                <a:latin typeface="Palatino Linotype"/>
+              </a:rPr>
+              <a:t>A fronteira (o que não é)</a:t>
+            </a:r>
+          </a:p>
+          <a:p>
+            <a:pPr>
+              <a:spcBef>
+                <a:spcPts val="0"/>
+              </a:spcBef>
+              <a:spcAft>
+                <a:spcPts val="800"/>
+              </a:spcAft>
+            </a:pPr>
+            <a:r>
+              <a:rPr sz="1280" b="1" i="0">
+                <a:solidFill>
+                  <a:srgbClr val="41719C"/>
+                </a:solidFill>
+                <a:latin typeface="Arial"/>
+              </a:rPr>
+              <a:t>•  </a:t>
+            </a:r>
+            <a:r>
+              <a:rPr sz="1280" b="0" i="0">
                 <a:solidFill>
                   <a:srgbClr val="404040"/>
                 </a:solidFill>
                 <a:latin typeface="Palatino Linotype"/>
               </a:rPr>
-              <a:t>O rótulo 'ideal' é uma escolha de projeto defensável, não a única.</a:t>
-            </a:r>
-          </a:p>
-        </p:txBody>
-      </p:sp>
-      <p:sp>
-        <p:nvSpPr>
-          <p:cNvPr id="18" name="Rectangle 17"/>
+              <a:t>Não é achado clínico: a base é testbed.</a:t>
+            </a:r>
+          </a:p>
+          <a:p>
+            <a:pPr>
+              <a:spcBef>
+                <a:spcPts val="0"/>
+              </a:spcBef>
+              <a:spcAft>
+                <a:spcPts val="800"/>
+              </a:spcAft>
+            </a:pPr>
+            <a:r>
+              <a:rPr sz="1280" b="1" i="0">
+                <a:solidFill>
+                  <a:srgbClr val="41719C"/>
+                </a:solidFill>
+                <a:latin typeface="Arial"/>
+              </a:rPr>
+              <a:t>•  </a:t>
+            </a:r>
+            <a:r>
+              <a:rPr sz="1280" b="0" i="0">
+                <a:solidFill>
+                  <a:srgbClr val="404040"/>
+                </a:solidFill>
+                <a:latin typeface="Palatino Linotype"/>
+              </a:rPr>
+              <a:t>Não distingue T1D/T2D; coorte única e transversal.</a:t>
+            </a:r>
+          </a:p>
+          <a:p>
+            <a:pPr>
+              <a:spcBef>
+                <a:spcPts val="0"/>
+              </a:spcBef>
+              <a:spcAft>
+                <a:spcPts val="800"/>
+              </a:spcAft>
+            </a:pPr>
+            <a:r>
+              <a:rPr sz="1280" b="1" i="0">
+                <a:solidFill>
+                  <a:srgbClr val="41719C"/>
+                </a:solidFill>
+                <a:latin typeface="Arial"/>
+              </a:rPr>
+              <a:t>•  </a:t>
+            </a:r>
+            <a:r>
+              <a:rPr sz="1280" b="0" i="0">
+                <a:solidFill>
+                  <a:srgbClr val="404040"/>
+                </a:solidFill>
+                <a:latin typeface="Palatino Linotype"/>
+              </a:rPr>
+              <a:t>Fala de associação, não de causalidade.</a:t>
+            </a:r>
+          </a:p>
+        </p:txBody>
+      </p:sp>
+      <p:sp>
+        <p:nvSpPr>
+          <p:cNvPr id="19" name="Rectangle 18"/>
           <p:cNvSpPr/>
           <p:nvPr/>
         </p:nvSpPr>
         <p:spPr>
           <a:xfrm>
-            <a:off x="6324447" y="2834640"/>
-            <a:ext cx="5364327" cy="1143000"/>
+            <a:off x="502920" y="4663440"/>
+            <a:ext cx="11185855" cy="1143000"/>
           </a:xfrm>
           <a:prstGeom prst="rect">
             <a:avLst/>
           </a:prstGeom>
           <a:solidFill>
-            <a:srgbClr val="F1F4F8"/>
+            <a:srgbClr val="203864"/>
           </a:solidFill>
-          <a:ln w="9525">
-            <a:solidFill>
-              <a:srgbClr val="D3D9E0"/>
-            </a:solidFill>
+          <a:ln>
+            <a:noFill/>
           </a:ln>
           <a:effectLst/>
         </p:spPr>
@@ -7692,58 +8013,14 @@
       </p:sp>
       <p:sp>
         <p:nvSpPr>
-          <p:cNvPr id="19" name="Rectangle 18"/>
-          <p:cNvSpPr/>
-          <p:nvPr/>
-        </p:nvSpPr>
-        <p:spPr>
-          <a:xfrm>
-            <a:off x="6324447" y="2834640"/>
-            <a:ext cx="82296" cy="1143000"/>
-          </a:xfrm>
-          <a:prstGeom prst="rect">
-            <a:avLst/>
-          </a:prstGeom>
-          <a:solidFill>
-            <a:srgbClr val="41719C"/>
-          </a:solidFill>
-          <a:ln>
-            <a:noFill/>
-          </a:ln>
-          <a:effectLst/>
-        </p:spPr>
-        <p:style>
-          <a:lnRef idx="1">
-            <a:schemeClr val="accent1"/>
-          </a:lnRef>
-          <a:fillRef idx="3">
-            <a:schemeClr val="accent1"/>
-          </a:fillRef>
-          <a:effectRef idx="2">
-            <a:schemeClr val="accent1"/>
-          </a:effectRef>
-          <a:fontRef idx="minor">
-            <a:schemeClr val="lt1"/>
-          </a:fontRef>
-        </p:style>
-        <p:txBody>
-          <a:bodyPr rtlCol="0" anchor="ctr"/>
-          <a:lstStyle/>
-          <a:p>
-            <a:pPr algn="ctr"/>
-          </a:p>
-        </p:txBody>
-      </p:sp>
-      <p:sp>
-        <p:nvSpPr>
           <p:cNvPr id="20" name="TextBox 19"/>
           <p:cNvSpPr txBox="1"/>
           <p:nvPr/>
         </p:nvSpPr>
         <p:spPr>
           <a:xfrm>
-            <a:off x="6598767" y="3035808"/>
-            <a:ext cx="4861407" cy="868680"/>
+            <a:off x="868680" y="4828032"/>
+            <a:ext cx="10454335" cy="868680"/>
           </a:xfrm>
           <a:prstGeom prst="rect">
             <a:avLst/>
@@ -7761,281 +8038,36 @@
                 <a:spcPts val="0"/>
               </a:spcBef>
               <a:spcAft>
-                <a:spcPts val="600"/>
-              </a:spcAft>
-            </a:pPr>
-            <a:r>
-              <a:rPr sz="1350" b="0" i="0">
-                <a:solidFill>
-                  <a:srgbClr val="404040"/>
-                </a:solidFill>
-                <a:latin typeface="Palatino Linotype"/>
-              </a:rPr>
-              <a:t>As 26 preditoras foram curadas à mão → podem ter omitido pistas relevantes.</a:t>
-            </a:r>
-          </a:p>
-        </p:txBody>
-      </p:sp>
-      <p:sp>
-        <p:nvSpPr>
-          <p:cNvPr id="21" name="Rectangle 20"/>
-          <p:cNvSpPr/>
-          <p:nvPr/>
-        </p:nvSpPr>
-        <p:spPr>
-          <a:xfrm>
-            <a:off x="502920" y="4160520"/>
-            <a:ext cx="5364327" cy="1143000"/>
-          </a:xfrm>
-          <a:prstGeom prst="rect">
-            <a:avLst/>
-          </a:prstGeom>
-          <a:solidFill>
-            <a:srgbClr val="F1F4F8"/>
-          </a:solidFill>
-          <a:ln w="9525">
-            <a:solidFill>
-              <a:srgbClr val="D3D9E0"/>
-            </a:solidFill>
-          </a:ln>
-          <a:effectLst/>
-        </p:spPr>
-        <p:style>
-          <a:lnRef idx="1">
-            <a:schemeClr val="accent1"/>
-          </a:lnRef>
-          <a:fillRef idx="3">
-            <a:schemeClr val="accent1"/>
-          </a:fillRef>
-          <a:effectRef idx="2">
-            <a:schemeClr val="accent1"/>
-          </a:effectRef>
-          <a:fontRef idx="minor">
-            <a:schemeClr val="lt1"/>
-          </a:fontRef>
-        </p:style>
-        <p:txBody>
-          <a:bodyPr rtlCol="0" anchor="ctr"/>
-          <a:lstStyle/>
-          <a:p>
-            <a:pPr algn="ctr"/>
-          </a:p>
-        </p:txBody>
-      </p:sp>
-      <p:sp>
-        <p:nvSpPr>
-          <p:cNvPr id="22" name="Rectangle 21"/>
-          <p:cNvSpPr/>
-          <p:nvPr/>
-        </p:nvSpPr>
-        <p:spPr>
-          <a:xfrm>
-            <a:off x="502920" y="4160520"/>
-            <a:ext cx="82296" cy="1143000"/>
-          </a:xfrm>
-          <a:prstGeom prst="rect">
-            <a:avLst/>
-          </a:prstGeom>
-          <a:solidFill>
-            <a:srgbClr val="41719C"/>
-          </a:solidFill>
-          <a:ln>
-            <a:noFill/>
-          </a:ln>
-          <a:effectLst/>
-        </p:spPr>
-        <p:style>
-          <a:lnRef idx="1">
-            <a:schemeClr val="accent1"/>
-          </a:lnRef>
-          <a:fillRef idx="3">
-            <a:schemeClr val="accent1"/>
-          </a:fillRef>
-          <a:effectRef idx="2">
-            <a:schemeClr val="accent1"/>
-          </a:effectRef>
-          <a:fontRef idx="minor">
-            <a:schemeClr val="lt1"/>
-          </a:fontRef>
-        </p:style>
-        <p:txBody>
-          <a:bodyPr rtlCol="0" anchor="ctr"/>
-          <a:lstStyle/>
-          <a:p>
-            <a:pPr algn="ctr"/>
-          </a:p>
-        </p:txBody>
-      </p:sp>
-      <p:sp>
-        <p:nvSpPr>
-          <p:cNvPr id="23" name="TextBox 22"/>
-          <p:cNvSpPr txBox="1"/>
-          <p:nvPr/>
-        </p:nvSpPr>
-        <p:spPr>
-          <a:xfrm>
-            <a:off x="777240" y="4361688"/>
-            <a:ext cx="4861407" cy="868680"/>
-          </a:xfrm>
-          <a:prstGeom prst="rect">
-            <a:avLst/>
-          </a:prstGeom>
-          <a:noFill/>
-        </p:spPr>
-        <p:txBody>
-          <a:bodyPr wrap="square" lIns="0" rIns="0" tIns="0" bIns="0">
-            <a:spAutoFit/>
-          </a:bodyPr>
-          <a:lstStyle/>
+                <a:spcPts val="300"/>
+              </a:spcAft>
+            </a:pPr>
+            <a:r>
+              <a:rPr sz="1200" b="1" i="0">
+                <a:solidFill>
+                  <a:srgbClr val="CDD7E3"/>
+                </a:solidFill>
+                <a:latin typeface="Palatino Linotype"/>
+              </a:rPr>
+              <a:t>Em uma frase</a:t>
+            </a:r>
+          </a:p>
           <a:p>
             <a:pPr algn="l">
               <a:spcBef>
                 <a:spcPts val="0"/>
               </a:spcBef>
               <a:spcAft>
-                <a:spcPts val="600"/>
-              </a:spcAft>
-            </a:pPr>
-            <a:r>
-              <a:rPr sz="1350" b="0" i="0">
-                <a:solidFill>
-                  <a:srgbClr val="404040"/>
-                </a:solidFill>
-                <a:latin typeface="Palatino Linotype"/>
-              </a:rPr>
-              <a:t>Imputação pela mediana 'achata' a variação; o corte do terço (33%) é limiar arbitrário.</a:t>
-            </a:r>
-          </a:p>
-        </p:txBody>
-      </p:sp>
-      <p:sp>
-        <p:nvSpPr>
-          <p:cNvPr id="24" name="Rectangle 23"/>
-          <p:cNvSpPr/>
-          <p:nvPr/>
-        </p:nvSpPr>
-        <p:spPr>
-          <a:xfrm>
-            <a:off x="6324447" y="4160520"/>
-            <a:ext cx="5364327" cy="1143000"/>
-          </a:xfrm>
-          <a:prstGeom prst="rect">
-            <a:avLst/>
-          </a:prstGeom>
-          <a:solidFill>
-            <a:srgbClr val="F1F4F8"/>
-          </a:solidFill>
-          <a:ln w="9525">
-            <a:solidFill>
-              <a:srgbClr val="D3D9E0"/>
-            </a:solidFill>
-          </a:ln>
-          <a:effectLst/>
-        </p:spPr>
-        <p:style>
-          <a:lnRef idx="1">
-            <a:schemeClr val="accent1"/>
-          </a:lnRef>
-          <a:fillRef idx="3">
-            <a:schemeClr val="accent1"/>
-          </a:fillRef>
-          <a:effectRef idx="2">
-            <a:schemeClr val="accent1"/>
-          </a:effectRef>
-          <a:fontRef idx="minor">
-            <a:schemeClr val="lt1"/>
-          </a:fontRef>
-        </p:style>
-        <p:txBody>
-          <a:bodyPr rtlCol="0" anchor="ctr"/>
-          <a:lstStyle/>
-          <a:p>
-            <a:pPr algn="ctr"/>
-          </a:p>
-        </p:txBody>
-      </p:sp>
-      <p:sp>
-        <p:nvSpPr>
-          <p:cNvPr id="25" name="Rectangle 24"/>
-          <p:cNvSpPr/>
-          <p:nvPr/>
-        </p:nvSpPr>
-        <p:spPr>
-          <a:xfrm>
-            <a:off x="6324447" y="4160520"/>
-            <a:ext cx="82296" cy="1143000"/>
-          </a:xfrm>
-          <a:prstGeom prst="rect">
-            <a:avLst/>
-          </a:prstGeom>
-          <a:solidFill>
-            <a:srgbClr val="41719C"/>
-          </a:solidFill>
-          <a:ln>
-            <a:noFill/>
-          </a:ln>
-          <a:effectLst/>
-        </p:spPr>
-        <p:style>
-          <a:lnRef idx="1">
-            <a:schemeClr val="accent1"/>
-          </a:lnRef>
-          <a:fillRef idx="3">
-            <a:schemeClr val="accent1"/>
-          </a:fillRef>
-          <a:effectRef idx="2">
-            <a:schemeClr val="accent1"/>
-          </a:effectRef>
-          <a:fontRef idx="minor">
-            <a:schemeClr val="lt1"/>
-          </a:fontRef>
-        </p:style>
-        <p:txBody>
-          <a:bodyPr rtlCol="0" anchor="ctr"/>
-          <a:lstStyle/>
-          <a:p>
-            <a:pPr algn="ctr"/>
-          </a:p>
-        </p:txBody>
-      </p:sp>
-      <p:sp>
-        <p:nvSpPr>
-          <p:cNvPr id="26" name="TextBox 25"/>
-          <p:cNvSpPr txBox="1"/>
-          <p:nvPr/>
-        </p:nvSpPr>
-        <p:spPr>
-          <a:xfrm>
-            <a:off x="6598767" y="4361688"/>
-            <a:ext cx="4861407" cy="868680"/>
-          </a:xfrm>
-          <a:prstGeom prst="rect">
-            <a:avLst/>
-          </a:prstGeom>
-          <a:noFill/>
-        </p:spPr>
-        <p:txBody>
-          <a:bodyPr wrap="square" lIns="0" rIns="0" tIns="0" bIns="0">
-            <a:spAutoFit/>
-          </a:bodyPr>
-          <a:lstStyle/>
-          <a:p>
-            <a:pPr algn="l">
-              <a:spcBef>
-                <a:spcPts val="0"/>
-              </a:spcBef>
-              <a:spcAft>
-                <a:spcPts val="600"/>
-              </a:spcAft>
-            </a:pPr>
-            <a:r>
-              <a:rPr sz="1350" b="0" i="0">
-                <a:solidFill>
-                  <a:srgbClr val="404040"/>
-                </a:solidFill>
-                <a:latin typeface="Palatino Linotype"/>
-              </a:rPr>
-              <a:t>L2 (λ=0,05) calibrado empiricamente, não por cross-validation formal.</a:t>
+                <a:spcPts val="0"/>
+              </a:spcAft>
+            </a:pPr>
+            <a:r>
+              <a:rPr sz="1300" b="1" i="0">
+                <a:solidFill>
+                  <a:srgbClr val="FFFFFF"/>
+                </a:solidFill>
+                <a:latin typeface="Palatino Linotype"/>
+              </a:rPr>
+              <a:t>Contribuímos com um otimizador de enxame validado por dois caminhos — ótimo analítico (cosseno 1,000) e verdade-base plantada (F1 0,94) — e com um perfil interpretável e reprodutível; o valor é o método validado, não uma conclusão clínica.</a:t>
             </a:r>
           </a:p>
         </p:txBody>
@@ -8334,6 +8366,1097 @@
                 </a:solidFill>
                 <a:latin typeface="Palatino Linotype"/>
               </a:rPr>
+              <a:t>Limitações declaradas</a:t>
+            </a:r>
+          </a:p>
+        </p:txBody>
+      </p:sp>
+      <p:sp>
+        <p:nvSpPr>
+          <p:cNvPr id="9" name="Rectangle 8"/>
+          <p:cNvSpPr/>
+          <p:nvPr/>
+        </p:nvSpPr>
+        <p:spPr>
+          <a:xfrm>
+            <a:off x="502920" y="1508760"/>
+            <a:ext cx="5364327" cy="1143000"/>
+          </a:xfrm>
+          <a:prstGeom prst="rect">
+            <a:avLst/>
+          </a:prstGeom>
+          <a:solidFill>
+            <a:srgbClr val="F1F4F8"/>
+          </a:solidFill>
+          <a:ln w="9525">
+            <a:solidFill>
+              <a:srgbClr val="D3D9E0"/>
+            </a:solidFill>
+          </a:ln>
+          <a:effectLst/>
+        </p:spPr>
+        <p:style>
+          <a:lnRef idx="1">
+            <a:schemeClr val="accent1"/>
+          </a:lnRef>
+          <a:fillRef idx="3">
+            <a:schemeClr val="accent1"/>
+          </a:fillRef>
+          <a:effectRef idx="2">
+            <a:schemeClr val="accent1"/>
+          </a:effectRef>
+          <a:fontRef idx="minor">
+            <a:schemeClr val="lt1"/>
+          </a:fontRef>
+        </p:style>
+        <p:txBody>
+          <a:bodyPr rtlCol="0" anchor="ctr"/>
+          <a:lstStyle/>
+          <a:p>
+            <a:pPr algn="ctr"/>
+          </a:p>
+        </p:txBody>
+      </p:sp>
+      <p:sp>
+        <p:nvSpPr>
+          <p:cNvPr id="10" name="Rectangle 9"/>
+          <p:cNvSpPr/>
+          <p:nvPr/>
+        </p:nvSpPr>
+        <p:spPr>
+          <a:xfrm>
+            <a:off x="502920" y="1508760"/>
+            <a:ext cx="82296" cy="1143000"/>
+          </a:xfrm>
+          <a:prstGeom prst="rect">
+            <a:avLst/>
+          </a:prstGeom>
+          <a:solidFill>
+            <a:srgbClr val="41719C"/>
+          </a:solidFill>
+          <a:ln>
+            <a:noFill/>
+          </a:ln>
+          <a:effectLst/>
+        </p:spPr>
+        <p:style>
+          <a:lnRef idx="1">
+            <a:schemeClr val="accent1"/>
+          </a:lnRef>
+          <a:fillRef idx="3">
+            <a:schemeClr val="accent1"/>
+          </a:fillRef>
+          <a:effectRef idx="2">
+            <a:schemeClr val="accent1"/>
+          </a:effectRef>
+          <a:fontRef idx="minor">
+            <a:schemeClr val="lt1"/>
+          </a:fontRef>
+        </p:style>
+        <p:txBody>
+          <a:bodyPr rtlCol="0" anchor="ctr"/>
+          <a:lstStyle/>
+          <a:p>
+            <a:pPr algn="ctr"/>
+          </a:p>
+        </p:txBody>
+      </p:sp>
+      <p:sp>
+        <p:nvSpPr>
+          <p:cNvPr id="11" name="TextBox 10"/>
+          <p:cNvSpPr txBox="1"/>
+          <p:nvPr/>
+        </p:nvSpPr>
+        <p:spPr>
+          <a:xfrm>
+            <a:off x="777240" y="1709928"/>
+            <a:ext cx="4861407" cy="868680"/>
+          </a:xfrm>
+          <a:prstGeom prst="rect">
+            <a:avLst/>
+          </a:prstGeom>
+          <a:noFill/>
+        </p:spPr>
+        <p:txBody>
+          <a:bodyPr wrap="square" lIns="0" rIns="0" tIns="0" bIns="0">
+            <a:spAutoFit/>
+          </a:bodyPr>
+          <a:lstStyle/>
+          <a:p>
+            <a:pPr algn="l">
+              <a:spcBef>
+                <a:spcPts val="0"/>
+              </a:spcBef>
+              <a:spcAft>
+                <a:spcPts val="600"/>
+              </a:spcAft>
+            </a:pPr>
+            <a:r>
+              <a:rPr sz="1350" b="0" i="0">
+                <a:solidFill>
+                  <a:srgbClr val="404040"/>
+                </a:solidFill>
+                <a:latin typeface="Palatino Linotype"/>
+              </a:rPr>
+              <a:t>A base não distingue T1D/T2D → 'diabetes tipo não especificado'; é testbed, não evidência clínica.</a:t>
+            </a:r>
+          </a:p>
+        </p:txBody>
+      </p:sp>
+      <p:sp>
+        <p:nvSpPr>
+          <p:cNvPr id="12" name="Rectangle 11"/>
+          <p:cNvSpPr/>
+          <p:nvPr/>
+        </p:nvSpPr>
+        <p:spPr>
+          <a:xfrm>
+            <a:off x="6324447" y="1508760"/>
+            <a:ext cx="5364327" cy="1143000"/>
+          </a:xfrm>
+          <a:prstGeom prst="rect">
+            <a:avLst/>
+          </a:prstGeom>
+          <a:solidFill>
+            <a:srgbClr val="F1F4F8"/>
+          </a:solidFill>
+          <a:ln w="9525">
+            <a:solidFill>
+              <a:srgbClr val="D3D9E0"/>
+            </a:solidFill>
+          </a:ln>
+          <a:effectLst/>
+        </p:spPr>
+        <p:style>
+          <a:lnRef idx="1">
+            <a:schemeClr val="accent1"/>
+          </a:lnRef>
+          <a:fillRef idx="3">
+            <a:schemeClr val="accent1"/>
+          </a:fillRef>
+          <a:effectRef idx="2">
+            <a:schemeClr val="accent1"/>
+          </a:effectRef>
+          <a:fontRef idx="minor">
+            <a:schemeClr val="lt1"/>
+          </a:fontRef>
+        </p:style>
+        <p:txBody>
+          <a:bodyPr rtlCol="0" anchor="ctr"/>
+          <a:lstStyle/>
+          <a:p>
+            <a:pPr algn="ctr"/>
+          </a:p>
+        </p:txBody>
+      </p:sp>
+      <p:sp>
+        <p:nvSpPr>
+          <p:cNvPr id="13" name="Rectangle 12"/>
+          <p:cNvSpPr/>
+          <p:nvPr/>
+        </p:nvSpPr>
+        <p:spPr>
+          <a:xfrm>
+            <a:off x="6324447" y="1508760"/>
+            <a:ext cx="82296" cy="1143000"/>
+          </a:xfrm>
+          <a:prstGeom prst="rect">
+            <a:avLst/>
+          </a:prstGeom>
+          <a:solidFill>
+            <a:srgbClr val="41719C"/>
+          </a:solidFill>
+          <a:ln>
+            <a:noFill/>
+          </a:ln>
+          <a:effectLst/>
+        </p:spPr>
+        <p:style>
+          <a:lnRef idx="1">
+            <a:schemeClr val="accent1"/>
+          </a:lnRef>
+          <a:fillRef idx="3">
+            <a:schemeClr val="accent1"/>
+          </a:fillRef>
+          <a:effectRef idx="2">
+            <a:schemeClr val="accent1"/>
+          </a:effectRef>
+          <a:fontRef idx="minor">
+            <a:schemeClr val="lt1"/>
+          </a:fontRef>
+        </p:style>
+        <p:txBody>
+          <a:bodyPr rtlCol="0" anchor="ctr"/>
+          <a:lstStyle/>
+          <a:p>
+            <a:pPr algn="ctr"/>
+          </a:p>
+        </p:txBody>
+      </p:sp>
+      <p:sp>
+        <p:nvSpPr>
+          <p:cNvPr id="14" name="TextBox 13"/>
+          <p:cNvSpPr txBox="1"/>
+          <p:nvPr/>
+        </p:nvSpPr>
+        <p:spPr>
+          <a:xfrm>
+            <a:off x="6598767" y="1709928"/>
+            <a:ext cx="4861407" cy="868680"/>
+          </a:xfrm>
+          <a:prstGeom prst="rect">
+            <a:avLst/>
+          </a:prstGeom>
+          <a:noFill/>
+        </p:spPr>
+        <p:txBody>
+          <a:bodyPr wrap="square" lIns="0" rIns="0" tIns="0" bIns="0">
+            <a:spAutoFit/>
+          </a:bodyPr>
+          <a:lstStyle/>
+          <a:p>
+            <a:pPr algn="l">
+              <a:spcBef>
+                <a:spcPts val="0"/>
+              </a:spcBef>
+              <a:spcAft>
+                <a:spcPts val="600"/>
+              </a:spcAft>
+            </a:pPr>
+            <a:r>
+              <a:rPr sz="1350" b="0" i="0">
+                <a:solidFill>
+                  <a:srgbClr val="404040"/>
+                </a:solidFill>
+                <a:latin typeface="Palatino Linotype"/>
+              </a:rPr>
+              <a:t>Coorte única e transversal (China, 2012) → fala de associação, não de causalidade.</a:t>
+            </a:r>
+          </a:p>
+        </p:txBody>
+      </p:sp>
+      <p:sp>
+        <p:nvSpPr>
+          <p:cNvPr id="15" name="Rectangle 14"/>
+          <p:cNvSpPr/>
+          <p:nvPr/>
+        </p:nvSpPr>
+        <p:spPr>
+          <a:xfrm>
+            <a:off x="502920" y="2834640"/>
+            <a:ext cx="5364327" cy="1143000"/>
+          </a:xfrm>
+          <a:prstGeom prst="rect">
+            <a:avLst/>
+          </a:prstGeom>
+          <a:solidFill>
+            <a:srgbClr val="F1F4F8"/>
+          </a:solidFill>
+          <a:ln w="9525">
+            <a:solidFill>
+              <a:srgbClr val="D3D9E0"/>
+            </a:solidFill>
+          </a:ln>
+          <a:effectLst/>
+        </p:spPr>
+        <p:style>
+          <a:lnRef idx="1">
+            <a:schemeClr val="accent1"/>
+          </a:lnRef>
+          <a:fillRef idx="3">
+            <a:schemeClr val="accent1"/>
+          </a:fillRef>
+          <a:effectRef idx="2">
+            <a:schemeClr val="accent1"/>
+          </a:effectRef>
+          <a:fontRef idx="minor">
+            <a:schemeClr val="lt1"/>
+          </a:fontRef>
+        </p:style>
+        <p:txBody>
+          <a:bodyPr rtlCol="0" anchor="ctr"/>
+          <a:lstStyle/>
+          <a:p>
+            <a:pPr algn="ctr"/>
+          </a:p>
+        </p:txBody>
+      </p:sp>
+      <p:sp>
+        <p:nvSpPr>
+          <p:cNvPr id="16" name="Rectangle 15"/>
+          <p:cNvSpPr/>
+          <p:nvPr/>
+        </p:nvSpPr>
+        <p:spPr>
+          <a:xfrm>
+            <a:off x="502920" y="2834640"/>
+            <a:ext cx="82296" cy="1143000"/>
+          </a:xfrm>
+          <a:prstGeom prst="rect">
+            <a:avLst/>
+          </a:prstGeom>
+          <a:solidFill>
+            <a:srgbClr val="41719C"/>
+          </a:solidFill>
+          <a:ln>
+            <a:noFill/>
+          </a:ln>
+          <a:effectLst/>
+        </p:spPr>
+        <p:style>
+          <a:lnRef idx="1">
+            <a:schemeClr val="accent1"/>
+          </a:lnRef>
+          <a:fillRef idx="3">
+            <a:schemeClr val="accent1"/>
+          </a:fillRef>
+          <a:effectRef idx="2">
+            <a:schemeClr val="accent1"/>
+          </a:effectRef>
+          <a:fontRef idx="minor">
+            <a:schemeClr val="lt1"/>
+          </a:fontRef>
+        </p:style>
+        <p:txBody>
+          <a:bodyPr rtlCol="0" anchor="ctr"/>
+          <a:lstStyle/>
+          <a:p>
+            <a:pPr algn="ctr"/>
+          </a:p>
+        </p:txBody>
+      </p:sp>
+      <p:sp>
+        <p:nvSpPr>
+          <p:cNvPr id="17" name="TextBox 16"/>
+          <p:cNvSpPr txBox="1"/>
+          <p:nvPr/>
+        </p:nvSpPr>
+        <p:spPr>
+          <a:xfrm>
+            <a:off x="777240" y="3035808"/>
+            <a:ext cx="4861407" cy="868680"/>
+          </a:xfrm>
+          <a:prstGeom prst="rect">
+            <a:avLst/>
+          </a:prstGeom>
+          <a:noFill/>
+        </p:spPr>
+        <p:txBody>
+          <a:bodyPr wrap="square" lIns="0" rIns="0" tIns="0" bIns="0">
+            <a:spAutoFit/>
+          </a:bodyPr>
+          <a:lstStyle/>
+          <a:p>
+            <a:pPr algn="l">
+              <a:spcBef>
+                <a:spcPts val="0"/>
+              </a:spcBef>
+              <a:spcAft>
+                <a:spcPts val="600"/>
+              </a:spcAft>
+            </a:pPr>
+            <a:r>
+              <a:rPr sz="1350" b="0" i="0">
+                <a:solidFill>
+                  <a:srgbClr val="404040"/>
+                </a:solidFill>
+                <a:latin typeface="Palatino Linotype"/>
+              </a:rPr>
+              <a:t>O rótulo 'ideal' é uma escolha de projeto defensável, não a única.</a:t>
+            </a:r>
+          </a:p>
+        </p:txBody>
+      </p:sp>
+      <p:sp>
+        <p:nvSpPr>
+          <p:cNvPr id="18" name="Rectangle 17"/>
+          <p:cNvSpPr/>
+          <p:nvPr/>
+        </p:nvSpPr>
+        <p:spPr>
+          <a:xfrm>
+            <a:off x="6324447" y="2834640"/>
+            <a:ext cx="5364327" cy="1143000"/>
+          </a:xfrm>
+          <a:prstGeom prst="rect">
+            <a:avLst/>
+          </a:prstGeom>
+          <a:solidFill>
+            <a:srgbClr val="F1F4F8"/>
+          </a:solidFill>
+          <a:ln w="9525">
+            <a:solidFill>
+              <a:srgbClr val="D3D9E0"/>
+            </a:solidFill>
+          </a:ln>
+          <a:effectLst/>
+        </p:spPr>
+        <p:style>
+          <a:lnRef idx="1">
+            <a:schemeClr val="accent1"/>
+          </a:lnRef>
+          <a:fillRef idx="3">
+            <a:schemeClr val="accent1"/>
+          </a:fillRef>
+          <a:effectRef idx="2">
+            <a:schemeClr val="accent1"/>
+          </a:effectRef>
+          <a:fontRef idx="minor">
+            <a:schemeClr val="lt1"/>
+          </a:fontRef>
+        </p:style>
+        <p:txBody>
+          <a:bodyPr rtlCol="0" anchor="ctr"/>
+          <a:lstStyle/>
+          <a:p>
+            <a:pPr algn="ctr"/>
+          </a:p>
+        </p:txBody>
+      </p:sp>
+      <p:sp>
+        <p:nvSpPr>
+          <p:cNvPr id="19" name="Rectangle 18"/>
+          <p:cNvSpPr/>
+          <p:nvPr/>
+        </p:nvSpPr>
+        <p:spPr>
+          <a:xfrm>
+            <a:off x="6324447" y="2834640"/>
+            <a:ext cx="82296" cy="1143000"/>
+          </a:xfrm>
+          <a:prstGeom prst="rect">
+            <a:avLst/>
+          </a:prstGeom>
+          <a:solidFill>
+            <a:srgbClr val="41719C"/>
+          </a:solidFill>
+          <a:ln>
+            <a:noFill/>
+          </a:ln>
+          <a:effectLst/>
+        </p:spPr>
+        <p:style>
+          <a:lnRef idx="1">
+            <a:schemeClr val="accent1"/>
+          </a:lnRef>
+          <a:fillRef idx="3">
+            <a:schemeClr val="accent1"/>
+          </a:fillRef>
+          <a:effectRef idx="2">
+            <a:schemeClr val="accent1"/>
+          </a:effectRef>
+          <a:fontRef idx="minor">
+            <a:schemeClr val="lt1"/>
+          </a:fontRef>
+        </p:style>
+        <p:txBody>
+          <a:bodyPr rtlCol="0" anchor="ctr"/>
+          <a:lstStyle/>
+          <a:p>
+            <a:pPr algn="ctr"/>
+          </a:p>
+        </p:txBody>
+      </p:sp>
+      <p:sp>
+        <p:nvSpPr>
+          <p:cNvPr id="20" name="TextBox 19"/>
+          <p:cNvSpPr txBox="1"/>
+          <p:nvPr/>
+        </p:nvSpPr>
+        <p:spPr>
+          <a:xfrm>
+            <a:off x="6598767" y="3035808"/>
+            <a:ext cx="4861407" cy="868680"/>
+          </a:xfrm>
+          <a:prstGeom prst="rect">
+            <a:avLst/>
+          </a:prstGeom>
+          <a:noFill/>
+        </p:spPr>
+        <p:txBody>
+          <a:bodyPr wrap="square" lIns="0" rIns="0" tIns="0" bIns="0">
+            <a:spAutoFit/>
+          </a:bodyPr>
+          <a:lstStyle/>
+          <a:p>
+            <a:pPr algn="l">
+              <a:spcBef>
+                <a:spcPts val="0"/>
+              </a:spcBef>
+              <a:spcAft>
+                <a:spcPts val="600"/>
+              </a:spcAft>
+            </a:pPr>
+            <a:r>
+              <a:rPr sz="1350" b="0" i="0">
+                <a:solidFill>
+                  <a:srgbClr val="404040"/>
+                </a:solidFill>
+                <a:latin typeface="Palatino Linotype"/>
+              </a:rPr>
+              <a:t>As 26 preditoras foram curadas à mão → podem ter omitido pistas relevantes.</a:t>
+            </a:r>
+          </a:p>
+        </p:txBody>
+      </p:sp>
+      <p:sp>
+        <p:nvSpPr>
+          <p:cNvPr id="21" name="Rectangle 20"/>
+          <p:cNvSpPr/>
+          <p:nvPr/>
+        </p:nvSpPr>
+        <p:spPr>
+          <a:xfrm>
+            <a:off x="502920" y="4160520"/>
+            <a:ext cx="5364327" cy="1143000"/>
+          </a:xfrm>
+          <a:prstGeom prst="rect">
+            <a:avLst/>
+          </a:prstGeom>
+          <a:solidFill>
+            <a:srgbClr val="F1F4F8"/>
+          </a:solidFill>
+          <a:ln w="9525">
+            <a:solidFill>
+              <a:srgbClr val="D3D9E0"/>
+            </a:solidFill>
+          </a:ln>
+          <a:effectLst/>
+        </p:spPr>
+        <p:style>
+          <a:lnRef idx="1">
+            <a:schemeClr val="accent1"/>
+          </a:lnRef>
+          <a:fillRef idx="3">
+            <a:schemeClr val="accent1"/>
+          </a:fillRef>
+          <a:effectRef idx="2">
+            <a:schemeClr val="accent1"/>
+          </a:effectRef>
+          <a:fontRef idx="minor">
+            <a:schemeClr val="lt1"/>
+          </a:fontRef>
+        </p:style>
+        <p:txBody>
+          <a:bodyPr rtlCol="0" anchor="ctr"/>
+          <a:lstStyle/>
+          <a:p>
+            <a:pPr algn="ctr"/>
+          </a:p>
+        </p:txBody>
+      </p:sp>
+      <p:sp>
+        <p:nvSpPr>
+          <p:cNvPr id="22" name="Rectangle 21"/>
+          <p:cNvSpPr/>
+          <p:nvPr/>
+        </p:nvSpPr>
+        <p:spPr>
+          <a:xfrm>
+            <a:off x="502920" y="4160520"/>
+            <a:ext cx="82296" cy="1143000"/>
+          </a:xfrm>
+          <a:prstGeom prst="rect">
+            <a:avLst/>
+          </a:prstGeom>
+          <a:solidFill>
+            <a:srgbClr val="41719C"/>
+          </a:solidFill>
+          <a:ln>
+            <a:noFill/>
+          </a:ln>
+          <a:effectLst/>
+        </p:spPr>
+        <p:style>
+          <a:lnRef idx="1">
+            <a:schemeClr val="accent1"/>
+          </a:lnRef>
+          <a:fillRef idx="3">
+            <a:schemeClr val="accent1"/>
+          </a:fillRef>
+          <a:effectRef idx="2">
+            <a:schemeClr val="accent1"/>
+          </a:effectRef>
+          <a:fontRef idx="minor">
+            <a:schemeClr val="lt1"/>
+          </a:fontRef>
+        </p:style>
+        <p:txBody>
+          <a:bodyPr rtlCol="0" anchor="ctr"/>
+          <a:lstStyle/>
+          <a:p>
+            <a:pPr algn="ctr"/>
+          </a:p>
+        </p:txBody>
+      </p:sp>
+      <p:sp>
+        <p:nvSpPr>
+          <p:cNvPr id="23" name="TextBox 22"/>
+          <p:cNvSpPr txBox="1"/>
+          <p:nvPr/>
+        </p:nvSpPr>
+        <p:spPr>
+          <a:xfrm>
+            <a:off x="777240" y="4361688"/>
+            <a:ext cx="4861407" cy="868680"/>
+          </a:xfrm>
+          <a:prstGeom prst="rect">
+            <a:avLst/>
+          </a:prstGeom>
+          <a:noFill/>
+        </p:spPr>
+        <p:txBody>
+          <a:bodyPr wrap="square" lIns="0" rIns="0" tIns="0" bIns="0">
+            <a:spAutoFit/>
+          </a:bodyPr>
+          <a:lstStyle/>
+          <a:p>
+            <a:pPr algn="l">
+              <a:spcBef>
+                <a:spcPts val="0"/>
+              </a:spcBef>
+              <a:spcAft>
+                <a:spcPts val="600"/>
+              </a:spcAft>
+            </a:pPr>
+            <a:r>
+              <a:rPr sz="1350" b="0" i="0">
+                <a:solidFill>
+                  <a:srgbClr val="404040"/>
+                </a:solidFill>
+                <a:latin typeface="Palatino Linotype"/>
+              </a:rPr>
+              <a:t>Imputação pela mediana 'achata' a variação; o corte do terço (33%) é limiar arbitrário.</a:t>
+            </a:r>
+          </a:p>
+        </p:txBody>
+      </p:sp>
+      <p:sp>
+        <p:nvSpPr>
+          <p:cNvPr id="24" name="Rectangle 23"/>
+          <p:cNvSpPr/>
+          <p:nvPr/>
+        </p:nvSpPr>
+        <p:spPr>
+          <a:xfrm>
+            <a:off x="6324447" y="4160520"/>
+            <a:ext cx="5364327" cy="1143000"/>
+          </a:xfrm>
+          <a:prstGeom prst="rect">
+            <a:avLst/>
+          </a:prstGeom>
+          <a:solidFill>
+            <a:srgbClr val="F1F4F8"/>
+          </a:solidFill>
+          <a:ln w="9525">
+            <a:solidFill>
+              <a:srgbClr val="D3D9E0"/>
+            </a:solidFill>
+          </a:ln>
+          <a:effectLst/>
+        </p:spPr>
+        <p:style>
+          <a:lnRef idx="1">
+            <a:schemeClr val="accent1"/>
+          </a:lnRef>
+          <a:fillRef idx="3">
+            <a:schemeClr val="accent1"/>
+          </a:fillRef>
+          <a:effectRef idx="2">
+            <a:schemeClr val="accent1"/>
+          </a:effectRef>
+          <a:fontRef idx="minor">
+            <a:schemeClr val="lt1"/>
+          </a:fontRef>
+        </p:style>
+        <p:txBody>
+          <a:bodyPr rtlCol="0" anchor="ctr"/>
+          <a:lstStyle/>
+          <a:p>
+            <a:pPr algn="ctr"/>
+          </a:p>
+        </p:txBody>
+      </p:sp>
+      <p:sp>
+        <p:nvSpPr>
+          <p:cNvPr id="25" name="Rectangle 24"/>
+          <p:cNvSpPr/>
+          <p:nvPr/>
+        </p:nvSpPr>
+        <p:spPr>
+          <a:xfrm>
+            <a:off x="6324447" y="4160520"/>
+            <a:ext cx="82296" cy="1143000"/>
+          </a:xfrm>
+          <a:prstGeom prst="rect">
+            <a:avLst/>
+          </a:prstGeom>
+          <a:solidFill>
+            <a:srgbClr val="41719C"/>
+          </a:solidFill>
+          <a:ln>
+            <a:noFill/>
+          </a:ln>
+          <a:effectLst/>
+        </p:spPr>
+        <p:style>
+          <a:lnRef idx="1">
+            <a:schemeClr val="accent1"/>
+          </a:lnRef>
+          <a:fillRef idx="3">
+            <a:schemeClr val="accent1"/>
+          </a:fillRef>
+          <a:effectRef idx="2">
+            <a:schemeClr val="accent1"/>
+          </a:effectRef>
+          <a:fontRef idx="minor">
+            <a:schemeClr val="lt1"/>
+          </a:fontRef>
+        </p:style>
+        <p:txBody>
+          <a:bodyPr rtlCol="0" anchor="ctr"/>
+          <a:lstStyle/>
+          <a:p>
+            <a:pPr algn="ctr"/>
+          </a:p>
+        </p:txBody>
+      </p:sp>
+      <p:sp>
+        <p:nvSpPr>
+          <p:cNvPr id="26" name="TextBox 25"/>
+          <p:cNvSpPr txBox="1"/>
+          <p:nvPr/>
+        </p:nvSpPr>
+        <p:spPr>
+          <a:xfrm>
+            <a:off x="6598767" y="4361688"/>
+            <a:ext cx="4861407" cy="868680"/>
+          </a:xfrm>
+          <a:prstGeom prst="rect">
+            <a:avLst/>
+          </a:prstGeom>
+          <a:noFill/>
+        </p:spPr>
+        <p:txBody>
+          <a:bodyPr wrap="square" lIns="0" rIns="0" tIns="0" bIns="0">
+            <a:spAutoFit/>
+          </a:bodyPr>
+          <a:lstStyle/>
+          <a:p>
+            <a:pPr algn="l">
+              <a:spcBef>
+                <a:spcPts val="0"/>
+              </a:spcBef>
+              <a:spcAft>
+                <a:spcPts val="600"/>
+              </a:spcAft>
+            </a:pPr>
+            <a:r>
+              <a:rPr sz="1350" b="0" i="0">
+                <a:solidFill>
+                  <a:srgbClr val="404040"/>
+                </a:solidFill>
+                <a:latin typeface="Palatino Linotype"/>
+              </a:rPr>
+              <a:t>L2 (λ=0,05) calibrado empiricamente, não por cross-validation formal.</a:t>
+            </a:r>
+          </a:p>
+        </p:txBody>
+      </p:sp>
+    </p:spTree>
+  </p:cSld>
+  <p:clrMapOvr>
+    <a:masterClrMapping/>
+  </p:clrMapOvr>
+</p:sld>
+</file>
+
+<file path=ppt/slides/slide16.xml><?xml version="1.0" encoding="utf-8"?>
+<p:sld xmlns:a="http://schemas.openxmlformats.org/drawingml/2006/main" xmlns:p="http://schemas.openxmlformats.org/presentationml/2006/main" xmlns:r="http://schemas.openxmlformats.org/officeDocument/2006/relationships">
+  <p:cSld>
+    <p:spTree>
+      <p:nvGrpSpPr>
+        <p:cNvPr id="1" name=""/>
+        <p:cNvGrpSpPr/>
+        <p:nvPr/>
+      </p:nvGrpSpPr>
+      <p:grpSpPr/>
+      <p:sp>
+        <p:nvSpPr>
+          <p:cNvPr id="2" name="Rectangle 1"/>
+          <p:cNvSpPr/>
+          <p:nvPr/>
+        </p:nvSpPr>
+        <p:spPr>
+          <a:xfrm>
+            <a:off x="0" y="0"/>
+            <a:ext cx="12191695" cy="6858000"/>
+          </a:xfrm>
+          <a:prstGeom prst="rect">
+            <a:avLst/>
+          </a:prstGeom>
+          <a:solidFill>
+            <a:srgbClr val="FFFFFF"/>
+          </a:solidFill>
+          <a:ln>
+            <a:noFill/>
+          </a:ln>
+          <a:effectLst/>
+        </p:spPr>
+        <p:style>
+          <a:lnRef idx="1">
+            <a:schemeClr val="accent1"/>
+          </a:lnRef>
+          <a:fillRef idx="3">
+            <a:schemeClr val="accent1"/>
+          </a:fillRef>
+          <a:effectRef idx="2">
+            <a:schemeClr val="accent1"/>
+          </a:effectRef>
+          <a:fontRef idx="minor">
+            <a:schemeClr val="lt1"/>
+          </a:fontRef>
+        </p:style>
+        <p:txBody>
+          <a:bodyPr rtlCol="0" anchor="ctr"/>
+          <a:lstStyle/>
+          <a:p>
+            <a:pPr algn="ctr"/>
+          </a:p>
+        </p:txBody>
+      </p:sp>
+      <p:pic>
+        <p:nvPicPr>
+          <p:cNvPr id="3" name="Picture 2" descr="header_right.png"/>
+          <p:cNvPicPr>
+            <a:picLocks noChangeAspect="1"/>
+          </p:cNvPicPr>
+          <p:nvPr/>
+        </p:nvPicPr>
+        <p:blipFill>
+          <a:blip r:embed="rId2"/>
+          <a:stretch>
+            <a:fillRect/>
+          </a:stretch>
+        </p:blipFill>
+        <p:spPr>
+          <a:xfrm>
+            <a:off x="8031175" y="109728"/>
+            <a:ext cx="4160520" cy="650081"/>
+          </a:xfrm>
+          <a:prstGeom prst="rect">
+            <a:avLst/>
+          </a:prstGeom>
+        </p:spPr>
+      </p:pic>
+      <p:sp>
+        <p:nvSpPr>
+          <p:cNvPr id="4" name="Rectangle 3"/>
+          <p:cNvSpPr/>
+          <p:nvPr/>
+        </p:nvSpPr>
+        <p:spPr>
+          <a:xfrm>
+            <a:off x="274320" y="6236208"/>
+            <a:ext cx="11643055" cy="17780"/>
+          </a:xfrm>
+          <a:prstGeom prst="rect">
+            <a:avLst/>
+          </a:prstGeom>
+          <a:solidFill>
+            <a:srgbClr val="41719C"/>
+          </a:solidFill>
+          <a:ln>
+            <a:noFill/>
+          </a:ln>
+          <a:effectLst/>
+        </p:spPr>
+        <p:style>
+          <a:lnRef idx="1">
+            <a:schemeClr val="accent1"/>
+          </a:lnRef>
+          <a:fillRef idx="3">
+            <a:schemeClr val="accent1"/>
+          </a:fillRef>
+          <a:effectRef idx="2">
+            <a:schemeClr val="accent1"/>
+          </a:effectRef>
+          <a:fontRef idx="minor">
+            <a:schemeClr val="lt1"/>
+          </a:fontRef>
+        </p:style>
+        <p:txBody>
+          <a:bodyPr rtlCol="0" anchor="ctr"/>
+          <a:lstStyle/>
+          <a:p>
+            <a:pPr algn="ctr"/>
+          </a:p>
+        </p:txBody>
+      </p:sp>
+      <p:pic>
+        <p:nvPicPr>
+          <p:cNvPr id="5" name="Picture 4" descr="footer_left.png"/>
+          <p:cNvPicPr>
+            <a:picLocks noChangeAspect="1"/>
+          </p:cNvPicPr>
+          <p:nvPr/>
+        </p:nvPicPr>
+        <p:blipFill>
+          <a:blip r:embed="rId3"/>
+          <a:stretch>
+            <a:fillRect/>
+          </a:stretch>
+        </p:blipFill>
+        <p:spPr>
+          <a:xfrm>
+            <a:off x="292608" y="6327648"/>
+            <a:ext cx="1026579" cy="502920"/>
+          </a:xfrm>
+          <a:prstGeom prst="rect">
+            <a:avLst/>
+          </a:prstGeom>
+        </p:spPr>
+      </p:pic>
+      <p:sp>
+        <p:nvSpPr>
+          <p:cNvPr id="6" name="TextBox 5"/>
+          <p:cNvSpPr txBox="1"/>
+          <p:nvPr/>
+        </p:nvSpPr>
+        <p:spPr>
+          <a:xfrm>
+            <a:off x="1691640" y="6373368"/>
+            <a:ext cx="8229600" cy="457200"/>
+          </a:xfrm>
+          <a:prstGeom prst="rect">
+            <a:avLst/>
+          </a:prstGeom>
+          <a:noFill/>
+        </p:spPr>
+        <p:txBody>
+          <a:bodyPr wrap="square" lIns="0" rIns="0" tIns="0" bIns="0">
+            <a:spAutoFit/>
+          </a:bodyPr>
+          <a:lstStyle/>
+          <a:p>
+            <a:pPr algn="l">
+              <a:spcBef>
+                <a:spcPts val="0"/>
+              </a:spcBef>
+              <a:spcAft>
+                <a:spcPts val="100"/>
+              </a:spcAft>
+            </a:pPr>
+            <a:r>
+              <a:rPr sz="1100" b="0" i="0">
+                <a:solidFill>
+                  <a:srgbClr val="203864"/>
+                </a:solidFill>
+                <a:latin typeface="Palatino Linotype"/>
+              </a:rPr>
+              <a:t>COURSE: Computação Natural</a:t>
+            </a:r>
+          </a:p>
+          <a:p>
+            <a:pPr algn="l">
+              <a:spcBef>
+                <a:spcPts val="0"/>
+              </a:spcBef>
+              <a:spcAft>
+                <a:spcPts val="0"/>
+              </a:spcAft>
+            </a:pPr>
+            <a:r>
+              <a:rPr sz="1100" b="0" i="0">
+                <a:solidFill>
+                  <a:srgbClr val="203864"/>
+                </a:solidFill>
+                <a:latin typeface="Palatino Linotype"/>
+              </a:rPr>
+              <a:t>CLASS: Equipe 4  -  TOPIC: Otimizador Bioinspirado (Plano B)</a:t>
+            </a:r>
+          </a:p>
+        </p:txBody>
+      </p:sp>
+      <p:sp>
+        <p:nvSpPr>
+          <p:cNvPr id="7" name="TextBox 6"/>
+          <p:cNvSpPr txBox="1"/>
+          <p:nvPr/>
+        </p:nvSpPr>
+        <p:spPr>
+          <a:xfrm>
+            <a:off x="11323015" y="6400800"/>
+            <a:ext cx="548640" cy="274320"/>
+          </a:xfrm>
+          <a:prstGeom prst="rect">
+            <a:avLst/>
+          </a:prstGeom>
+          <a:noFill/>
+        </p:spPr>
+        <p:txBody>
+          <a:bodyPr wrap="square" lIns="0" rIns="0" tIns="0" bIns="0">
+            <a:spAutoFit/>
+          </a:bodyPr>
+          <a:lstStyle/>
+          <a:p>
+            <a:pPr algn="r">
+              <a:spcBef>
+                <a:spcPts val="0"/>
+              </a:spcBef>
+              <a:spcAft>
+                <a:spcPts val="600"/>
+              </a:spcAft>
+            </a:pPr>
+            <a:r>
+              <a:rPr sz="1200" b="0" i="0">
+                <a:solidFill>
+                  <a:srgbClr val="203864"/>
+                </a:solidFill>
+                <a:latin typeface="Palatino Linotype"/>
+              </a:rPr>
+              <a:t>16</a:t>
+            </a:r>
+          </a:p>
+        </p:txBody>
+      </p:sp>
+      <p:sp>
+        <p:nvSpPr>
+          <p:cNvPr id="8" name="TextBox 7"/>
+          <p:cNvSpPr txBox="1"/>
+          <p:nvPr/>
+        </p:nvSpPr>
+        <p:spPr>
+          <a:xfrm>
+            <a:off x="502920" y="384048"/>
+            <a:ext cx="7315200" cy="868680"/>
+          </a:xfrm>
+          <a:prstGeom prst="rect">
+            <a:avLst/>
+          </a:prstGeom>
+          <a:noFill/>
+        </p:spPr>
+        <p:txBody>
+          <a:bodyPr wrap="square" lIns="0" rIns="0" tIns="0" bIns="0">
+            <a:spAutoFit/>
+          </a:bodyPr>
+          <a:lstStyle/>
+          <a:p>
+            <a:pPr algn="l">
+              <a:spcBef>
+                <a:spcPts val="0"/>
+              </a:spcBef>
+              <a:spcAft>
+                <a:spcPts val="600"/>
+              </a:spcAft>
+            </a:pPr>
+            <a:r>
+              <a:rPr sz="2700" b="1" i="0">
+                <a:solidFill>
+                  <a:srgbClr val="203864"/>
+                </a:solidFill>
+                <a:latin typeface="Palatino Linotype"/>
+              </a:rPr>
               <a:t>Próximos passos e conclusão</a:t>
             </a:r>
           </a:p>
@@ -10242,7 +11365,7 @@
                 </a:solidFill>
                 <a:latin typeface="Palatino Linotype"/>
               </a:rPr>
-              <a:t>BFSS de relance, limitações e próximos passos</a:t>
+              <a:t>BFSS, contribuição, limitações e próximos passos</a:t>
             </a:r>
           </a:p>
         </p:txBody>

</xml_diff>